<commit_message>
Align submission evidence and validation claims
</commit_message>
<xml_diff>
--- a/submission/opsintel-ai-pitch-deck.pptx
+++ b/submission/opsintel-ai-pitch-deck.pptx
@@ -7214,7 +7214,7 @@
                 <a:ea typeface="Arial"/>
                 <a:cs typeface="Arial"/>
               </a:rPr>
-              <a:t>01  Independent reviewer holdout</a:t>
+              <a:t>01  External holdout: 0 reviewer cases</a:t>
             </a:r>
           </a:p>
         </p:txBody>
@@ -7548,7 +7548,7 @@
                 <a:ea typeface="Arial"/>
                 <a:cs typeface="Arial"/>
               </a:rPr>
-              <a:t>03  4–5 person impact study</a:t>
+              <a:t>03  Impact study: 0/40 trials (0/4 people)</a:t>
             </a:r>
           </a:p>
         </p:txBody>
@@ -8748,7 +8748,7 @@
                 <a:ea typeface="Arial"/>
                 <a:cs typeface="Arial"/>
               </a:rPr>
-              <a:t>The workflows are ready; no independent score or measured productivity gain is claimed until real participants complete them.</a:t>
+              <a:t>Evaluation workflows are ready. External cases and participant trials remain pending.</a:t>
             </a:r>
           </a:p>
         </p:txBody>

</xml_diff>

<commit_message>
Strengthen Exasol proof and investigation UX
</commit_message>
<xml_diff>
--- a/submission/opsintel-ai-pitch-deck.pptx
+++ b/submission/opsintel-ai-pitch-deck.pptx
@@ -4136,7 +4136,7 @@
           <c:idx val="0"/>
           <c:order val="0"/>
           <c:tx>
-            <c:v>Query latency</c:v>
+            <c:v>Median latency (ms)</c:v>
           </c:tx>
           <c:spPr>
             <a:solidFill xmlns:a="http://schemas.openxmlformats.org/drawingml/2006/main">
@@ -4146,59 +4146,41 @@
           <c:invertIfNegative val="0"/>
           <c:cat>
             <c:strRef>
-              <c:f>'Chart Data'!$A$2:$A$8</c:f>
+              <c:f>'Chart Data'!$A$2:$A$5</c:f>
               <c:strCache>
-                <c:ptCount val="7"/>
+                <c:ptCount val="4"/>
                 <c:pt idx="0">
-                  <c:v>Run 1</c:v>
+                  <c:v>Exasol 1M</c:v>
                 </c:pt>
                 <c:pt idx="1">
-                  <c:v>Run 2</c:v>
+                  <c:v>DuckDB 1M</c:v>
                 </c:pt>
                 <c:pt idx="2">
-                  <c:v>Run 3</c:v>
+                  <c:v>Exasol 10M</c:v>
                 </c:pt>
                 <c:pt idx="3">
-                  <c:v>Run 4</c:v>
-                </c:pt>
-                <c:pt idx="4">
-                  <c:v>Run 5</c:v>
-                </c:pt>
-                <c:pt idx="5">
-                  <c:v>Run 6</c:v>
-                </c:pt>
-                <c:pt idx="6">
-                  <c:v>Run 7</c:v>
+                  <c:v>DuckDB 10M</c:v>
                 </c:pt>
               </c:strCache>
             </c:strRef>
           </c:cat>
           <c:val>
             <c:numRef>
-              <c:f>'Chart Data'!$B$2:$B$8</c:f>
+              <c:f>'Chart Data'!$B$2:$B$5</c:f>
               <c:numCache>
                 <c:formatCode>General</c:formatCode>
-                <c:ptCount val="7"/>
+                <c:ptCount val="4"/>
                 <c:pt idx="0">
-                  <c:v>503.947</c:v>
+                  <c:v>437.118</c:v>
                 </c:pt>
                 <c:pt idx="1">
-                  <c:v>473.209</c:v>
+                  <c:v>114.912</c:v>
                 </c:pt>
                 <c:pt idx="2">
-                  <c:v>474.484</c:v>
+                  <c:v>4902.269</c:v>
                 </c:pt>
                 <c:pt idx="3">
-                  <c:v>445.887</c:v>
-                </c:pt>
-                <c:pt idx="4">
-                  <c:v>442.384</c:v>
-                </c:pt>
-                <c:pt idx="5">
-                  <c:v>469.597</c:v>
-                </c:pt>
-                <c:pt idx="6">
-                  <c:v>476.749</c:v>
+                  <c:v>1080.358</c:v>
                 </c:pt>
               </c:numCache>
             </c:numRef>
@@ -4250,7 +4232,7 @@
                       <a:srgbClr val="9AA5BD"/>
                     </a:solidFill>
                   </a:rPr>
-                  <a:t>Query repetition</a:t>
+                  <a:t>Engine and workload</a:t>
                 </a:r>
               </a:p>
             </c:rich>
@@ -4300,8 +4282,8 @@
         <c:axId val="48672768"/>
         <c:scaling>
           <c:orientation val="minMax"/>
-          <c:max val="550"/>
-          <c:min val="400"/>
+          <c:max val="5200"/>
+          <c:min val="0"/>
         </c:scaling>
         <c:delete val="0"/>
         <c:axPos val="l"/>
@@ -4327,7 +4309,7 @@
                       <a:srgbClr val="9AA5BD"/>
                     </a:solidFill>
                   </a:rPr>
-                  <a:t>Milliseconds</a:t>
+                  <a:t>Median latency (ms)</a:t>
                 </a:r>
               </a:p>
             </c:rich>
@@ -4373,7 +4355,7 @@
         </c:txPr>
         <c:crossAx val="48650112"/>
         <c:crossBetween val="between"/>
-        <c:majorUnit val="50"/>
+        <c:majorUnit val="1000"/>
       </c:valAx>
       <c:spPr>
         <a:solidFill xmlns:a="http://schemas.openxmlformats.org/drawingml/2006/main">
@@ -6515,7 +6497,7 @@
                 <a:ea typeface="Arial"/>
                 <a:cs typeface="Arial"/>
               </a:rPr>
-              <a:t>02  One-million-row benchmark</a:t>
+              <a:t>02  Controlled 1M/10M comparison</a:t>
             </a:r>
           </a:p>
         </p:txBody>
@@ -6682,7 +6664,7 @@
                 <a:ea typeface="Arial"/>
                 <a:cs typeface="Arial"/>
               </a:rPr>
-              <a:t>03  71 automated tests</a:t>
+              <a:t>03  75 automated tests</a:t>
             </a:r>
           </a:p>
         </p:txBody>
@@ -7381,7 +7363,7 @@
                 <a:ea typeface="Arial"/>
                 <a:cs typeface="Arial"/>
               </a:rPr>
-              <a:t>02  Controlled Exasol comparison</a:t>
+              <a:t>02  Independent LLM quality evaluation</a:t>
             </a:r>
           </a:p>
         </p:txBody>
@@ -8748,7 +8730,7 @@
                 <a:ea typeface="Arial"/>
                 <a:cs typeface="Arial"/>
               </a:rPr>
-              <a:t>Evaluation workflows are ready. External cases and participant trials remain pending.</a:t>
+              <a:t>The engine comparison is complete. External cases and participant trials remain pending.</a:t>
             </a:r>
           </a:p>
         </p:txBody>
@@ -9889,7 +9871,7 @@
                 <a:ea typeface="Arial"/>
                 <a:cs typeface="Arial"/>
               </a:rPr>
-              <a:t>Live demo: one incident, five observations, one safe next action</a:t>
+              <a:t>Live demo: observed facts, candidate causes, human verification</a:t>
             </a:r>
           </a:p>
         </p:txBody>
@@ -10419,7 +10401,7 @@
                 <a:ea typeface="Arial"/>
                 <a:cs typeface="Arial"/>
               </a:rPr>
-              <a:t>The failure is visible. The explanation is scattered.</a:t>
+              <a:t>At 3:07 a.m., the alert says failed. The evidence is scattered.</a:t>
             </a:r>
           </a:p>
         </p:txBody>
@@ -10920,7 +10902,7 @@
                 <a:ea typeface="Arial"/>
                 <a:cs typeface="Arial"/>
               </a:rPr>
-              <a:t>The engineer finds the run, compares row counts, searches logs, and decides what to inspect next.</a:t>
+              <a:t>This run expected 100 rows but received 80. The engineer still searches separate run, count, and log views.</a:t>
             </a:r>
           </a:p>
         </p:txBody>
@@ -12120,7 +12102,7 @@
                 <a:ea typeface="Arial"/>
                 <a:cs typeface="Arial"/>
               </a:rPr>
-              <a:t>Compare candidate explanations</a:t>
+              <a:t>Keep facts separate from candidate explanations</a:t>
             </a:r>
           </a:p>
         </p:txBody>
@@ -12454,7 +12436,7 @@
                 <a:ea typeface="Arial"/>
                 <a:cs typeface="Arial"/>
               </a:rPr>
-              <a:t>Human verifies before action</a:t>
+              <a:t>System abstains until a human verifies</a:t>
             </a:r>
           </a:p>
         </p:txBody>
@@ -12621,7 +12603,7 @@
                 <a:ea typeface="Arial"/>
                 <a:cs typeface="Arial"/>
               </a:rPr>
-              <a:t>Expected benefit: fewer context switches. The impact study will measure time and evidence selection.</a:t>
+              <a:t>No time saving is claimed yet. The prepared study measures investigation time and evidence selection.</a:t>
             </a:r>
           </a:p>
         </p:txBody>
@@ -20594,7 +20576,7 @@
                 <a:ea typeface="Arial"/>
                 <a:cs typeface="Arial"/>
               </a:rPr>
-              <a:t>CONFIRMATION</a:t>
+              <a:t>HUMAN CONFIRMATION</a:t>
             </a:r>
           </a:p>
         </p:txBody>
@@ -20761,7 +20743,7 @@
                 <a:ea typeface="Arial"/>
                 <a:cs typeface="Arial"/>
               </a:rPr>
-              <a:t>None</a:t>
+              <a:t>Not yet verified</a:t>
             </a:r>
           </a:p>
           <a:p xmlns:a="http://schemas.openxmlformats.org/drawingml/2006/main">
@@ -20785,7 +20767,7 @@
                 <a:ea typeface="Arial"/>
                 <a:cs typeface="Arial"/>
               </a:rPr>
-              <a:t>Human verification required</a:t>
+              <a:t>No automated repair</a:t>
             </a:r>
           </a:p>
         </p:txBody>
@@ -22985,7 +22967,7 @@
                 <a:ea typeface="Arial"/>
                 <a:cs typeface="Arial"/>
               </a:rPr>
-              <a:t>FastAPI reads the view directly</a:t>
+              <a:t>Parallel in-memory SQL execution</a:t>
             </a:r>
           </a:p>
         </p:txBody>
@@ -23979,7 +23961,7 @@
                 <a:ea typeface="Arial"/>
                 <a:cs typeface="Arial"/>
               </a:rPr>
-              <a:t>RECORDED EXASOL OUTPUT · PRIOR 4-CASE SEED</a:t>
+              <a:t>CURRENT SEED · LIVE EXASOL OUTPUT</a:t>
             </a:r>
           </a:p>
         </p:txBody>
@@ -24136,7 +24118,7 @@
                 <a:ea typeface="Arial"/>
                 <a:cs typeface="Arial"/>
               </a:rPr>
-              <a:t>5 runs  ·  4 incidents  ·  56.0% complete</a:t>
+              <a:t>12 runs  ·  11 incidents  ·  64.1% average completeness</a:t>
             </a:r>
           </a:p>
         </p:txBody>
@@ -24293,7 +24275,7 @@
                 <a:ea typeface="Arial"/>
                 <a:cs typeface="Arial"/>
               </a:rPr>
-              <a:t>The API reads the view directly; window calculations stay beside the run history. Re-run the expanded seed before the live demo.</a:t>
+              <a:t>GET /analytics/trend reads this view directly. The current seed output was verified against Exasol Personal.</a:t>
             </a:r>
           </a:p>
         </p:txBody>
@@ -24479,7 +24461,7 @@
                 <a:ea typeface="Arial"/>
                 <a:cs typeface="Arial"/>
               </a:rPr>
-              <a:t>WHAT EXASOL MADE POSSIBLE</a:t>
+              <a:t>EXASOL FINDS THE SHARED FAILURE</a:t>
             </a:r>
           </a:p>
         </p:txBody>
@@ -24636,7 +24618,7 @@
                 <a:ea typeface="Arial"/>
                 <a:cs typeface="Arial"/>
               </a:rPr>
-              <a:t>One SQL layer turns telemetry into explainable incident context</a:t>
+              <a:t>One upstream failure explains three downstream incidents</a:t>
             </a:r>
           </a:p>
         </p:txBody>
@@ -24985,7 +24967,7 @@
                 <a:ea typeface="Arial"/>
                 <a:cs typeface="Arial"/>
               </a:rPr>
-              <a:t>Window analytics</a:t>
+              <a:t>Window analytics at scale</a:t>
             </a:r>
           </a:p>
         </p:txBody>
@@ -25997,7 +25979,7 @@
                 <a:ea typeface="Arial"/>
                 <a:cs typeface="Arial"/>
               </a:rPr>
-              <a:t>Shared evidence</a:t>
+              <a:t>Operational evidence layer</a:t>
             </a:r>
           </a:p>
         </p:txBody>
@@ -26970,7 +26952,7 @@
                 <a:ea typeface="Arial"/>
                 <a:cs typeface="Arial"/>
               </a:rPr>
-              <a:t>Performance comparison status: DuckDB baseline recorded at 1M and 10M rows; the same-machine Exasol run is pending. No database-winner claim is made.</a:t>
+              <a:t>Live result: CONNECT BY maps customer_sync to 3 failed downstream runs. Bulk import loads benchmark history; no UDF is implemented.</a:t>
             </a:r>
           </a:p>
         </p:txBody>
@@ -27511,7 +27493,7 @@
                 <a:ea typeface="Arial"/>
                 <a:cs typeface="Arial"/>
               </a:rPr>
-              <a:t>MEASURED EVIDENCE</a:t>
+              <a:t>SAME QUERY, MEASURED HONESTLY</a:t>
             </a:r>
           </a:p>
         </p:txBody>
@@ -27678,7 +27660,7 @@
                 <a:ea typeface="Arial"/>
                 <a:cs typeface="Arial"/>
               </a:rPr>
-              <a:t>Measured separately: performance, software tests and synthetic cases</a:t>
+              <a:t>DuckDB was 4.5× faster at 10M rows in this local single-user test</a:t>
             </a:r>
           </a:p>
         </p:txBody>
@@ -27845,7 +27827,7 @@
                 <a:ea typeface="Arial"/>
                 <a:cs typeface="Arial"/>
               </a:rPr>
-              <a:t>473 ms</a:t>
+              <a:t>CACHE OFF</a:t>
             </a:r>
           </a:p>
         </p:txBody>
@@ -28012,7 +27994,7 @@
                 <a:ea typeface="Arial"/>
                 <a:cs typeface="Arial"/>
               </a:rPr>
-              <a:t>median analytical query</a:t>
+              <a:t>Exasol comparison</a:t>
             </a:r>
           </a:p>
         </p:txBody>
@@ -28179,7 +28161,7 @@
                 <a:ea typeface="Arial"/>
                 <a:cs typeface="Arial"/>
               </a:rPr>
-              <a:t>71/71</a:t>
+              <a:t>7 RUNS</a:t>
             </a:r>
           </a:p>
         </p:txBody>
@@ -28346,7 +28328,7 @@
                 <a:ea typeface="Arial"/>
                 <a:cs typeface="Arial"/>
               </a:rPr>
-              <a:t>automated tests passed</a:t>
+              <a:t>per engine</a:t>
             </a:r>
           </a:p>
         </p:txBody>
@@ -28513,7 +28495,7 @@
                 <a:ea typeface="Arial"/>
                 <a:cs typeface="Arial"/>
               </a:rPr>
-              <a:t>16 / 16</a:t>
+              <a:t>75 / 75</a:t>
             </a:r>
           </a:p>
         </p:txBody>
@@ -28680,7 +28662,7 @@
                 <a:ea typeface="Arial"/>
                 <a:cs typeface="Arial"/>
               </a:rPr>
-              <a:t>predefined synthetic challenge cases</a:t>
+              <a:t>automated tests passed</a:t>
             </a:r>
           </a:p>
         </p:txBody>
@@ -28847,7 +28829,7 @@
                 <a:ea typeface="Arial"/>
                 <a:cs typeface="Arial"/>
               </a:rPr>
-              <a:t>3.025 s</a:t>
+              <a:t>27 / 27</a:t>
             </a:r>
           </a:p>
         </p:txBody>
@@ -29014,7 +28996,7 @@
                 <a:ea typeface="Arial"/>
                 <a:cs typeface="Arial"/>
               </a:rPr>
-              <a:t>1,000,000-row import</a:t>
+              <a:t>project-authored holdout</a:t>
             </a:r>
           </a:p>
         </p:txBody>
@@ -29181,7 +29163,7 @@
                 <a:ea typeface="Arial"/>
                 <a:cs typeface="Arial"/>
               </a:rPr>
-              <a:t>Exasol benchmark: 1M-row import 3.025 s; analytical query median 473 ms, p95 504 ms, 7 repeats, local single-user. Tests: 71/71. Regression: 16/16. Project-authored holdout: 27/27—not independent.</a:t>
+              <a:t>Same deterministic query, 7 runs per engine, Exasol query cache OFF. 1M medians: Exasol 437 ms, DuckDB 115 ms. No production or concurrency claim.</a:t>
             </a:r>
           </a:p>
         </p:txBody>
@@ -31181,7 +31163,7 @@
                 <a:ea typeface="Arial"/>
                 <a:cs typeface="Arial"/>
               </a:rPr>
-              <a:t>Result: unclassified. Optional summary cannot confirm a cause or run a repair.</a:t>
+              <a:t>Result: unknown. The system says what to check next and cannot confirm a cause or run a repair.</a:t>
             </a:r>
           </a:p>
         </p:txBody>

</xml_diff>

<commit_message>
Add failed-run comparison and evidence tracing
</commit_message>
<xml_diff>
--- a/submission/opsintel-ai-pitch-deck.pptx
+++ b/submission/opsintel-ai-pitch-deck.pptx
@@ -2,23 +2,23 @@
 <file path=ppt/presentation.xml><?xml version="1.0" encoding="utf-8"?>
 <p:presentation xmlns:p="http://schemas.openxmlformats.org/presentationml/2006/main">
   <p:sldMasterIdLst>
-    <p:sldMasterId xmlns:r="http://schemas.openxmlformats.org/officeDocument/2006/relationships" id="2147483648" r:id="R575ebd297aeb441f"/>
+    <p:sldMasterId xmlns:r="http://schemas.openxmlformats.org/officeDocument/2006/relationships" id="2147483648" r:id="R5aa594a552a44e68"/>
   </p:sldMasterIdLst>
   <p:notesMasterIdLst>
-    <p:notesMasterId xmlns:r="http://schemas.openxmlformats.org/officeDocument/2006/relationships" r:id="R9c70cd565e484b3b"/>
+    <p:notesMasterId xmlns:r="http://schemas.openxmlformats.org/officeDocument/2006/relationships" r:id="R29828e954cb94682"/>
   </p:notesMasterIdLst>
   <p:sldIdLst>
-    <p:sldId xmlns:r="http://schemas.openxmlformats.org/officeDocument/2006/relationships" id="256" r:id="R7d36aca5d8334330"/>
-    <p:sldId xmlns:r="http://schemas.openxmlformats.org/officeDocument/2006/relationships" id="257" r:id="Rf16b453ca3a94197"/>
-    <p:sldId xmlns:r="http://schemas.openxmlformats.org/officeDocument/2006/relationships" id="258" r:id="R9d7e87fc9231444f"/>
-    <p:sldId xmlns:r="http://schemas.openxmlformats.org/officeDocument/2006/relationships" id="259" r:id="Rddbddd27adb84bf9"/>
-    <p:sldId xmlns:r="http://schemas.openxmlformats.org/officeDocument/2006/relationships" id="260" r:id="Rb285c702727d4deb"/>
-    <p:sldId xmlns:r="http://schemas.openxmlformats.org/officeDocument/2006/relationships" id="261" r:id="Rfa176320faf647bd"/>
-    <p:sldId xmlns:r="http://schemas.openxmlformats.org/officeDocument/2006/relationships" id="262" r:id="R7961aabb00d64bd9"/>
-    <p:sldId xmlns:r="http://schemas.openxmlformats.org/officeDocument/2006/relationships" id="263" r:id="R3488612cb7f041bb"/>
-    <p:sldId xmlns:r="http://schemas.openxmlformats.org/officeDocument/2006/relationships" id="264" r:id="R19daee06c75e444c"/>
-    <p:sldId xmlns:r="http://schemas.openxmlformats.org/officeDocument/2006/relationships" id="265" r:id="R0ddafb07b86c4559"/>
-    <p:sldId xmlns:r="http://schemas.openxmlformats.org/officeDocument/2006/relationships" id="266" r:id="Rccdb794e2c6140da"/>
+    <p:sldId xmlns:r="http://schemas.openxmlformats.org/officeDocument/2006/relationships" id="256" r:id="R0517f4137beb4faf"/>
+    <p:sldId xmlns:r="http://schemas.openxmlformats.org/officeDocument/2006/relationships" id="257" r:id="Rd4a2b4a2fe7a405a"/>
+    <p:sldId xmlns:r="http://schemas.openxmlformats.org/officeDocument/2006/relationships" id="258" r:id="R89be79b296fe45d1"/>
+    <p:sldId xmlns:r="http://schemas.openxmlformats.org/officeDocument/2006/relationships" id="259" r:id="Re339d9cf26e94cdf"/>
+    <p:sldId xmlns:r="http://schemas.openxmlformats.org/officeDocument/2006/relationships" id="260" r:id="Ra220b39febdb4ae3"/>
+    <p:sldId xmlns:r="http://schemas.openxmlformats.org/officeDocument/2006/relationships" id="261" r:id="Rb1da1caa8f4b4d91"/>
+    <p:sldId xmlns:r="http://schemas.openxmlformats.org/officeDocument/2006/relationships" id="262" r:id="Re8fc39268d114a92"/>
+    <p:sldId xmlns:r="http://schemas.openxmlformats.org/officeDocument/2006/relationships" id="263" r:id="Rbd05af1a713645dc"/>
+    <p:sldId xmlns:r="http://schemas.openxmlformats.org/officeDocument/2006/relationships" id="264" r:id="R8df191a8145f40a4"/>
+    <p:sldId xmlns:r="http://schemas.openxmlformats.org/officeDocument/2006/relationships" id="265" r:id="R65e6ac5164094475"/>
+    <p:sldId xmlns:r="http://schemas.openxmlformats.org/officeDocument/2006/relationships" id="266" r:id="Rd2f303b374404ef0"/>
   </p:sldIdLst>
   <p:sldSz cx="12192000" cy="6858000"/>
   <p:notesSz cx="6858000" cy="9144000"/>
@@ -3591,12 +3591,12 @@
   </p:cSld>
   <p:clrMap bg1="lt1" tx1="dk1" bg2="lt2" tx2="dk2" accent1="accent1" accent2="accent2" accent3="accent3" accent4="accent4" accent5="accent5" accent6="accent6" hlink="hlink" folHlink="folHlink"/>
   <p:sldLayoutIdLst>
-    <p:sldLayoutId xmlns:r="http://schemas.openxmlformats.org/officeDocument/2006/relationships" id="2147483649" r:id="R973bccf60cda493a"/>
-    <p:sldLayoutId xmlns:r="http://schemas.openxmlformats.org/officeDocument/2006/relationships" id="2147483650" r:id="R3f2fdd08c529411e"/>
-    <p:sldLayoutId xmlns:r="http://schemas.openxmlformats.org/officeDocument/2006/relationships" id="2147483651" r:id="R8a983c900a164190"/>
-    <p:sldLayoutId xmlns:r="http://schemas.openxmlformats.org/officeDocument/2006/relationships" id="2147483652" r:id="R18a97f69ce5441c8"/>
-    <p:sldLayoutId xmlns:r="http://schemas.openxmlformats.org/officeDocument/2006/relationships" id="2147483653" r:id="R0fc99665854c4ce5"/>
-    <p:sldLayoutId xmlns:r="http://schemas.openxmlformats.org/officeDocument/2006/relationships" id="2147483654" r:id="Reae25f3096b3429b"/>
+    <p:sldLayoutId xmlns:r="http://schemas.openxmlformats.org/officeDocument/2006/relationships" id="2147483649" r:id="R0df25e70dcb84a8b"/>
+    <p:sldLayoutId xmlns:r="http://schemas.openxmlformats.org/officeDocument/2006/relationships" id="2147483650" r:id="R676a97eabc2d450d"/>
+    <p:sldLayoutId xmlns:r="http://schemas.openxmlformats.org/officeDocument/2006/relationships" id="2147483651" r:id="Rbd50c59b7f404dad"/>
+    <p:sldLayoutId xmlns:r="http://schemas.openxmlformats.org/officeDocument/2006/relationships" id="2147483652" r:id="R15e0292c5bc848a5"/>
+    <p:sldLayoutId xmlns:r="http://schemas.openxmlformats.org/officeDocument/2006/relationships" id="2147483653" r:id="R247de4e18d114487"/>
+    <p:sldLayoutId xmlns:r="http://schemas.openxmlformats.org/officeDocument/2006/relationships" id="2147483654" r:id="Rdc7040ae40214d86"/>
   </p:sldLayoutIdLst>
   <p:txStyles>
     <p:titleStyle>
@@ -4140,7 +4140,7 @@
           </c:tx>
           <c:spPr>
             <a:solidFill xmlns:a="http://schemas.openxmlformats.org/drawingml/2006/main">
-              <a:srgbClr val="9B8CFF"/>
+              <a:srgbClr val="9182F4"/>
             </a:solidFill>
           </c:spPr>
           <c:invertIfNegative val="0"/>
@@ -4187,6 +4187,7 @@
           </c:val>
         </c:ser>
         <c:dLbls>
+          <c:numFmt formatCode="0.000" sourceLinked="0"/>
           <c:txPr>
             <a:bodyPr xmlns:a="http://schemas.openxmlformats.org/drawingml/2006/main" anchorCtr="1"/>
             <a:lstStyle xmlns:a="http://schemas.openxmlformats.org/drawingml/2006/main"/>
@@ -4194,7 +4195,7 @@
               <a:pPr>
                 <a:defRPr sz="750" b="1">
                   <a:solidFill>
-                    <a:srgbClr val="D7DEEF"/>
+                    <a:srgbClr val="F0F3FA"/>
                   </a:solidFill>
                 </a:defRPr>
               </a:pPr>
@@ -4209,7 +4210,7 @@
           <c:showBubbleSize val="0"/>
           <c:showLeaderLines val="0"/>
         </c:dLbls>
-        <c:gapWidth val="35"/>
+        <c:gapWidth val="55"/>
         <c:axId val="48650112"/>
         <c:axId val="48672768"/>
       </c:barChart>
@@ -4258,7 +4259,7 @@
         <c:spPr>
           <a:ln xmlns:a="http://schemas.openxmlformats.org/drawingml/2006/main" w="9525">
             <a:solidFill>
-              <a:srgbClr val="34415D"/>
+              <a:srgbClr val="546079"/>
             </a:solidFill>
             <a:prstDash val="solid"/>
           </a:ln>
@@ -4282,7 +4283,7 @@
         <c:axId val="48672768"/>
         <c:scaling>
           <c:orientation val="minMax"/>
-          <c:max val="5200"/>
+          <c:max val="5500"/>
           <c:min val="0"/>
         </c:scaling>
         <c:delete val="0"/>
@@ -4291,7 +4292,7 @@
           <c:spPr>
             <a:ln xmlns:a="http://schemas.openxmlformats.org/drawingml/2006/main" w="9525">
               <a:solidFill>
-                <a:srgbClr val="273149"/>
+                <a:srgbClr val="2A3246"/>
               </a:solidFill>
               <a:prstDash val="solid"/>
             </a:ln>
@@ -4335,7 +4336,7 @@
         <c:spPr>
           <a:ln xmlns:a="http://schemas.openxmlformats.org/drawingml/2006/main" w="9525">
             <a:solidFill>
-              <a:srgbClr val="34415D"/>
+              <a:srgbClr val="546079"/>
             </a:solidFill>
             <a:prstDash val="solid"/>
           </a:ln>
@@ -6664,7 +6665,7 @@
                 <a:ea typeface="Arial"/>
                 <a:cs typeface="Arial"/>
               </a:rPr>
-              <a:t>03  75 automated tests</a:t>
+              <a:t>03  80 automated tests</a:t>
             </a:r>
           </a:p>
         </p:txBody>
@@ -17016,7 +17017,7 @@
           <p:cNvPr id="3" name="">
             <a:extLst xmlns:a="http://schemas.openxmlformats.org/drawingml/2006/main">
               <a:ext uri="{FF2B5EF4-FFF2-40B4-BE49-F238E27FC236}">
-                <a16:creationId xmlns:a16="http://schemas.microsoft.com/office/drawing/2014/main" id="{89158501-9C09-4B51-ADC9-A316FF53B275}"/>
+                <a16:creationId xmlns:a16="http://schemas.microsoft.com/office/drawing/2014/main" id="{B9475F54-E239-4695-85AB-A5475AACDD00}"/>
               </a:ext>
             </a:extLst>
           </p:cNvPr>
@@ -17026,7 +17027,7 @@
           <p:nvPr/>
         </p:nvPicPr>
         <p:blipFill>
-          <a:blip xmlns:r="http://schemas.openxmlformats.org/officeDocument/2006/relationships" xmlns:a="http://schemas.openxmlformats.org/drawingml/2006/main" r:embed="R01afcf60a5ee422e"/>
+          <a:blip xmlns:r="http://schemas.openxmlformats.org/officeDocument/2006/relationships" xmlns:a="http://schemas.openxmlformats.org/drawingml/2006/main" r:embed="R87262fe55ab0457e"/>
           <a:srcRect xmlns:a="http://schemas.openxmlformats.org/drawingml/2006/main" l="13" t="0" r="13" b="0"/>
           <a:stretch xmlns:a="http://schemas.openxmlformats.org/drawingml/2006/main">
             <a:fillRect l="0" t="0" r="0" b="0"/>
@@ -18684,7 +18685,7 @@
           <p:cNvPr id="3" name="">
             <a:extLst xmlns:a="http://schemas.openxmlformats.org/drawingml/2006/main">
               <a:ext uri="{FF2B5EF4-FFF2-40B4-BE49-F238E27FC236}">
-                <a16:creationId xmlns:a16="http://schemas.microsoft.com/office/drawing/2014/main" id="{6BC4FD2E-F53D-44B0-9260-B3F3E6923ABA}"/>
+                <a16:creationId xmlns:a16="http://schemas.microsoft.com/office/drawing/2014/main" id="{1EB3ACD3-5310-4497-85A4-FF04D35A9BE5}"/>
               </a:ext>
             </a:extLst>
           </p:cNvPr>
@@ -18694,7 +18695,7 @@
           <p:nvPr/>
         </p:nvPicPr>
         <p:blipFill>
-          <a:blip xmlns:r="http://schemas.openxmlformats.org/officeDocument/2006/relationships" xmlns:a="http://schemas.openxmlformats.org/drawingml/2006/main" r:embed="Rc0aa3e1413554bbe"/>
+          <a:blip xmlns:r="http://schemas.openxmlformats.org/officeDocument/2006/relationships" xmlns:a="http://schemas.openxmlformats.org/drawingml/2006/main" r:embed="R9a4dc924064744b9"/>
           <a:srcRect xmlns:a="http://schemas.openxmlformats.org/drawingml/2006/main" l="15" t="0" r="15" b="0"/>
           <a:stretch xmlns:a="http://schemas.openxmlformats.org/drawingml/2006/main">
             <a:fillRect l="0" t="0" r="0" b="0"/>
@@ -18874,7 +18875,7 @@
                 <a:ea typeface="Arial"/>
                 <a:cs typeface="Arial"/>
               </a:rPr>
-              <a:t>Selected run</a:t>
+              <a:t>Selected failure vs last success</a:t>
             </a:r>
           </a:p>
         </p:txBody>
@@ -19063,7 +19064,7 @@
         <p:spPr>
           <a:xfrm xmlns:a="http://schemas.openxmlformats.org/drawingml/2006/main">
             <a:off x="685800" y="3352800"/>
-            <a:ext cx="3048000" cy="971550"/>
+            <a:ext cx="3619500" cy="971550"/>
           </a:xfrm>
           <a:prstGeom xmlns:a="http://schemas.openxmlformats.org/drawingml/2006/main" prst="rect">
             <a:avLst/>
@@ -19208,7 +19209,7 @@
                 <a:ea typeface="Arial"/>
                 <a:cs typeface="Arial"/>
               </a:rPr>
-              <a:t>Expected: 100 rows</a:t>
+              <a:t>Failed: 80 / 100 rows (80%)</a:t>
             </a:r>
           </a:p>
           <a:p xmlns:a="http://schemas.openxmlformats.org/drawingml/2006/main">
@@ -19232,7 +19233,7 @@
                 <a:ea typeface="Arial"/>
                 <a:cs typeface="Arial"/>
               </a:rPr>
-              <a:t>Received: 80 rows</a:t>
+              <a:t>Last success: 100 / 100 (100%)</a:t>
             </a:r>
           </a:p>
           <a:p xmlns:a="http://schemas.openxmlformats.org/drawingml/2006/main">
@@ -19256,7 +19257,7 @@
                 <a:ea typeface="Arial"/>
                 <a:cs typeface="Arial"/>
               </a:rPr>
-              <a:t>Missing: 20 rows</a:t>
+              <a:t>Change: -20 rows / -20 pp</a:t>
             </a:r>
           </a:p>
         </p:txBody>
@@ -20051,7 +20052,7 @@
                 <a:ea typeface="Arial"/>
                 <a:cs typeface="Arial"/>
               </a:rPr>
-              <a:t>OBSERVATION</a:t>
+              <a:t>FAILED VS LAST SUCCESS</a:t>
             </a:r>
           </a:p>
         </p:txBody>
@@ -23414,6 +23415,7 @@
               </a:defRPr>
             </a:defPPr>
             <a:lvl1pPr>
+              <a:buNone/>
               <a:defRPr sz="975" b="1">
                 <a:solidFill>
                   <a:srgbClr val="58DDB0"/>
@@ -23424,6 +23426,7 @@
               </a:defRPr>
             </a:lvl1pPr>
             <a:lvl2pPr>
+              <a:buNone/>
               <a:defRPr sz="975" b="1">
                 <a:solidFill>
                   <a:srgbClr val="58DDB0"/>
@@ -23434,6 +23437,7 @@
               </a:defRPr>
             </a:lvl2pPr>
             <a:lvl3pPr>
+              <a:buNone/>
               <a:defRPr sz="975" b="1">
                 <a:solidFill>
                   <a:srgbClr val="58DDB0"/>
@@ -23444,6 +23448,7 @@
               </a:defRPr>
             </a:lvl3pPr>
             <a:lvl4pPr>
+              <a:buNone/>
               <a:defRPr sz="975" b="1">
                 <a:solidFill>
                   <a:srgbClr val="58DDB0"/>
@@ -23454,6 +23459,7 @@
               </a:defRPr>
             </a:lvl4pPr>
             <a:lvl5pPr>
+              <a:buNone/>
               <a:defRPr sz="975" b="1">
                 <a:solidFill>
                   <a:srgbClr val="58DDB0"/>
@@ -23464,6 +23470,7 @@
               </a:defRPr>
             </a:lvl5pPr>
             <a:lvl6pPr>
+              <a:buNone/>
               <a:defRPr sz="975" b="1">
                 <a:solidFill>
                   <a:srgbClr val="58DDB0"/>
@@ -23474,6 +23481,7 @@
               </a:defRPr>
             </a:lvl6pPr>
             <a:lvl7pPr>
+              <a:buNone/>
               <a:defRPr sz="975" b="1">
                 <a:solidFill>
                   <a:srgbClr val="58DDB0"/>
@@ -23484,6 +23492,7 @@
               </a:defRPr>
             </a:lvl7pPr>
             <a:lvl8pPr>
+              <a:buNone/>
               <a:defRPr sz="975" b="1">
                 <a:solidFill>
                   <a:srgbClr val="58DDB0"/>
@@ -23494,6 +23503,7 @@
               </a:defRPr>
             </a:lvl8pPr>
             <a:lvl9pPr>
+              <a:buNone/>
               <a:defRPr sz="975" b="1">
                 <a:solidFill>
                   <a:srgbClr val="58DDB0"/>
@@ -23506,6 +23516,7 @@
           </a:lstStyle>
           <a:p xmlns:a="http://schemas.openxmlformats.org/drawingml/2006/main">
             <a:pPr>
+              <a:buNone/>
               <a:defRPr sz="975" b="1">
                 <a:solidFill>
                   <a:srgbClr val="58DDB0"/>
@@ -23571,6 +23582,7 @@
               </a:defRPr>
             </a:defPPr>
             <a:lvl1pPr>
+              <a:buNone/>
               <a:defRPr sz="1050">
                 <a:solidFill>
                   <a:srgbClr val="D7DEEF"/>
@@ -23581,6 +23593,7 @@
               </a:defRPr>
             </a:lvl1pPr>
             <a:lvl2pPr>
+              <a:buNone/>
               <a:defRPr sz="1050">
                 <a:solidFill>
                   <a:srgbClr val="D7DEEF"/>
@@ -23591,6 +23604,7 @@
               </a:defRPr>
             </a:lvl2pPr>
             <a:lvl3pPr>
+              <a:buNone/>
               <a:defRPr sz="1050">
                 <a:solidFill>
                   <a:srgbClr val="D7DEEF"/>
@@ -23601,6 +23615,7 @@
               </a:defRPr>
             </a:lvl3pPr>
             <a:lvl4pPr>
+              <a:buNone/>
               <a:defRPr sz="1050">
                 <a:solidFill>
                   <a:srgbClr val="D7DEEF"/>
@@ -23611,6 +23626,7 @@
               </a:defRPr>
             </a:lvl4pPr>
             <a:lvl5pPr>
+              <a:buNone/>
               <a:defRPr sz="1050">
                 <a:solidFill>
                   <a:srgbClr val="D7DEEF"/>
@@ -23621,6 +23637,7 @@
               </a:defRPr>
             </a:lvl5pPr>
             <a:lvl6pPr>
+              <a:buNone/>
               <a:defRPr sz="1050">
                 <a:solidFill>
                   <a:srgbClr val="D7DEEF"/>
@@ -23631,6 +23648,7 @@
               </a:defRPr>
             </a:lvl6pPr>
             <a:lvl7pPr>
+              <a:buNone/>
               <a:defRPr sz="1050">
                 <a:solidFill>
                   <a:srgbClr val="D7DEEF"/>
@@ -23641,6 +23659,7 @@
               </a:defRPr>
             </a:lvl7pPr>
             <a:lvl8pPr>
+              <a:buNone/>
               <a:defRPr sz="1050">
                 <a:solidFill>
                   <a:srgbClr val="D7DEEF"/>
@@ -23651,6 +23670,7 @@
               </a:defRPr>
             </a:lvl8pPr>
             <a:lvl9pPr>
+              <a:buNone/>
               <a:defRPr sz="1050">
                 <a:solidFill>
                   <a:srgbClr val="D7DEEF"/>
@@ -23663,6 +23683,7 @@
           </a:lstStyle>
           <a:p xmlns:a="http://schemas.openxmlformats.org/drawingml/2006/main">
             <a:pPr>
+              <a:buNone/>
               <a:defRPr sz="1050">
                 <a:solidFill>
                   <a:srgbClr val="D7DEEF"/>
@@ -23686,6 +23707,7 @@
           </a:p>
           <a:p xmlns:a="http://schemas.openxmlformats.org/drawingml/2006/main">
             <a:pPr>
+              <a:buNone/>
               <a:defRPr sz="1050">
                 <a:solidFill>
                   <a:srgbClr val="D7DEEF"/>
@@ -23709,6 +23731,7 @@
           </a:p>
           <a:p xmlns:a="http://schemas.openxmlformats.org/drawingml/2006/main">
             <a:pPr>
+              <a:buNone/>
               <a:defRPr sz="1050">
                 <a:solidFill>
                   <a:srgbClr val="D7DEEF"/>
@@ -23732,6 +23755,7 @@
           </a:p>
           <a:p xmlns:a="http://schemas.openxmlformats.org/drawingml/2006/main">
             <a:pPr>
+              <a:buNone/>
               <a:defRPr sz="1050">
                 <a:solidFill>
                   <a:srgbClr val="D7DEEF"/>
@@ -23755,6 +23779,7 @@
           </a:p>
           <a:p xmlns:a="http://schemas.openxmlformats.org/drawingml/2006/main">
             <a:pPr>
+              <a:buNone/>
               <a:defRPr sz="1050">
                 <a:solidFill>
                   <a:srgbClr val="D7DEEF"/>
@@ -23851,6 +23876,7 @@
               </a:defRPr>
             </a:defPPr>
             <a:lvl1pPr>
+              <a:buNone/>
               <a:defRPr sz="825" b="1">
                 <a:solidFill>
                   <a:srgbClr val="E8B76E"/>
@@ -23861,6 +23887,7 @@
               </a:defRPr>
             </a:lvl1pPr>
             <a:lvl2pPr>
+              <a:buNone/>
               <a:defRPr sz="825" b="1">
                 <a:solidFill>
                   <a:srgbClr val="E8B76E"/>
@@ -23871,6 +23898,7 @@
               </a:defRPr>
             </a:lvl2pPr>
             <a:lvl3pPr>
+              <a:buNone/>
               <a:defRPr sz="825" b="1">
                 <a:solidFill>
                   <a:srgbClr val="E8B76E"/>
@@ -23881,6 +23909,7 @@
               </a:defRPr>
             </a:lvl3pPr>
             <a:lvl4pPr>
+              <a:buNone/>
               <a:defRPr sz="825" b="1">
                 <a:solidFill>
                   <a:srgbClr val="E8B76E"/>
@@ -23891,6 +23920,7 @@
               </a:defRPr>
             </a:lvl4pPr>
             <a:lvl5pPr>
+              <a:buNone/>
               <a:defRPr sz="825" b="1">
                 <a:solidFill>
                   <a:srgbClr val="E8B76E"/>
@@ -23901,6 +23931,7 @@
               </a:defRPr>
             </a:lvl5pPr>
             <a:lvl6pPr>
+              <a:buNone/>
               <a:defRPr sz="825" b="1">
                 <a:solidFill>
                   <a:srgbClr val="E8B76E"/>
@@ -23911,6 +23942,7 @@
               </a:defRPr>
             </a:lvl6pPr>
             <a:lvl7pPr>
+              <a:buNone/>
               <a:defRPr sz="825" b="1">
                 <a:solidFill>
                   <a:srgbClr val="E8B76E"/>
@@ -23921,6 +23953,7 @@
               </a:defRPr>
             </a:lvl7pPr>
             <a:lvl8pPr>
+              <a:buNone/>
               <a:defRPr sz="825" b="1">
                 <a:solidFill>
                   <a:srgbClr val="E8B76E"/>
@@ -23931,6 +23964,7 @@
               </a:defRPr>
             </a:lvl8pPr>
             <a:lvl9pPr>
+              <a:buNone/>
               <a:defRPr sz="825" b="1">
                 <a:solidFill>
                   <a:srgbClr val="E8B76E"/>
@@ -23943,6 +23977,7 @@
           </a:lstStyle>
           <a:p xmlns:a="http://schemas.openxmlformats.org/drawingml/2006/main">
             <a:pPr>
+              <a:buNone/>
               <a:defRPr sz="825" b="1">
                 <a:solidFill>
                   <a:srgbClr val="E8B76E"/>
@@ -24008,6 +24043,7 @@
               </a:defRPr>
             </a:defPPr>
             <a:lvl1pPr>
+              <a:buNone/>
               <a:defRPr sz="1350" b="1">
                 <a:solidFill>
                   <a:srgbClr val="F0F3FA"/>
@@ -24018,6 +24054,7 @@
               </a:defRPr>
             </a:lvl1pPr>
             <a:lvl2pPr>
+              <a:buNone/>
               <a:defRPr sz="1350" b="1">
                 <a:solidFill>
                   <a:srgbClr val="F0F3FA"/>
@@ -24028,6 +24065,7 @@
               </a:defRPr>
             </a:lvl2pPr>
             <a:lvl3pPr>
+              <a:buNone/>
               <a:defRPr sz="1350" b="1">
                 <a:solidFill>
                   <a:srgbClr val="F0F3FA"/>
@@ -24038,6 +24076,7 @@
               </a:defRPr>
             </a:lvl3pPr>
             <a:lvl4pPr>
+              <a:buNone/>
               <a:defRPr sz="1350" b="1">
                 <a:solidFill>
                   <a:srgbClr val="F0F3FA"/>
@@ -24048,6 +24087,7 @@
               </a:defRPr>
             </a:lvl4pPr>
             <a:lvl5pPr>
+              <a:buNone/>
               <a:defRPr sz="1350" b="1">
                 <a:solidFill>
                   <a:srgbClr val="F0F3FA"/>
@@ -24058,6 +24098,7 @@
               </a:defRPr>
             </a:lvl5pPr>
             <a:lvl6pPr>
+              <a:buNone/>
               <a:defRPr sz="1350" b="1">
                 <a:solidFill>
                   <a:srgbClr val="F0F3FA"/>
@@ -24068,6 +24109,7 @@
               </a:defRPr>
             </a:lvl6pPr>
             <a:lvl7pPr>
+              <a:buNone/>
               <a:defRPr sz="1350" b="1">
                 <a:solidFill>
                   <a:srgbClr val="F0F3FA"/>
@@ -24078,6 +24120,7 @@
               </a:defRPr>
             </a:lvl7pPr>
             <a:lvl8pPr>
+              <a:buNone/>
               <a:defRPr sz="1350" b="1">
                 <a:solidFill>
                   <a:srgbClr val="F0F3FA"/>
@@ -24088,6 +24131,7 @@
               </a:defRPr>
             </a:lvl8pPr>
             <a:lvl9pPr>
+              <a:buNone/>
               <a:defRPr sz="1350" b="1">
                 <a:solidFill>
                   <a:srgbClr val="F0F3FA"/>
@@ -24100,6 +24144,7 @@
           </a:lstStyle>
           <a:p xmlns:a="http://schemas.openxmlformats.org/drawingml/2006/main">
             <a:pPr>
+              <a:buNone/>
               <a:defRPr sz="1350" b="1">
                 <a:solidFill>
                   <a:srgbClr val="F0F3FA"/>
@@ -24165,6 +24210,7 @@
               </a:defRPr>
             </a:defPPr>
             <a:lvl1pPr>
+              <a:buNone/>
               <a:defRPr sz="975">
                 <a:solidFill>
                   <a:srgbClr val="9AA5BD"/>
@@ -24175,6 +24221,7 @@
               </a:defRPr>
             </a:lvl1pPr>
             <a:lvl2pPr>
+              <a:buNone/>
               <a:defRPr sz="975">
                 <a:solidFill>
                   <a:srgbClr val="9AA5BD"/>
@@ -24185,6 +24232,7 @@
               </a:defRPr>
             </a:lvl2pPr>
             <a:lvl3pPr>
+              <a:buNone/>
               <a:defRPr sz="975">
                 <a:solidFill>
                   <a:srgbClr val="9AA5BD"/>
@@ -24195,6 +24243,7 @@
               </a:defRPr>
             </a:lvl3pPr>
             <a:lvl4pPr>
+              <a:buNone/>
               <a:defRPr sz="975">
                 <a:solidFill>
                   <a:srgbClr val="9AA5BD"/>
@@ -24205,6 +24254,7 @@
               </a:defRPr>
             </a:lvl4pPr>
             <a:lvl5pPr>
+              <a:buNone/>
               <a:defRPr sz="975">
                 <a:solidFill>
                   <a:srgbClr val="9AA5BD"/>
@@ -24215,6 +24265,7 @@
               </a:defRPr>
             </a:lvl5pPr>
             <a:lvl6pPr>
+              <a:buNone/>
               <a:defRPr sz="975">
                 <a:solidFill>
                   <a:srgbClr val="9AA5BD"/>
@@ -24225,6 +24276,7 @@
               </a:defRPr>
             </a:lvl6pPr>
             <a:lvl7pPr>
+              <a:buNone/>
               <a:defRPr sz="975">
                 <a:solidFill>
                   <a:srgbClr val="9AA5BD"/>
@@ -24235,6 +24287,7 @@
               </a:defRPr>
             </a:lvl7pPr>
             <a:lvl8pPr>
+              <a:buNone/>
               <a:defRPr sz="975">
                 <a:solidFill>
                   <a:srgbClr val="9AA5BD"/>
@@ -24245,6 +24298,7 @@
               </a:defRPr>
             </a:lvl8pPr>
             <a:lvl9pPr>
+              <a:buNone/>
               <a:defRPr sz="975">
                 <a:solidFill>
                   <a:srgbClr val="9AA5BD"/>
@@ -24257,6 +24311,7 @@
           </a:lstStyle>
           <a:p xmlns:a="http://schemas.openxmlformats.org/drawingml/2006/main">
             <a:pPr>
+              <a:buNone/>
               <a:defRPr sz="975">
                 <a:solidFill>
                   <a:srgbClr val="9AA5BD"/>
@@ -24351,6 +24406,7 @@
               </a:defRPr>
             </a:defPPr>
             <a:lvl1pPr>
+              <a:buNone/>
               <a:defRPr sz="1125" b="1">
                 <a:solidFill>
                   <a:srgbClr val="9B8CFF"/>
@@ -24361,6 +24417,7 @@
               </a:defRPr>
             </a:lvl1pPr>
             <a:lvl2pPr>
+              <a:buNone/>
               <a:defRPr sz="1125" b="1">
                 <a:solidFill>
                   <a:srgbClr val="9B8CFF"/>
@@ -24371,6 +24428,7 @@
               </a:defRPr>
             </a:lvl2pPr>
             <a:lvl3pPr>
+              <a:buNone/>
               <a:defRPr sz="1125" b="1">
                 <a:solidFill>
                   <a:srgbClr val="9B8CFF"/>
@@ -24381,6 +24439,7 @@
               </a:defRPr>
             </a:lvl3pPr>
             <a:lvl4pPr>
+              <a:buNone/>
               <a:defRPr sz="1125" b="1">
                 <a:solidFill>
                   <a:srgbClr val="9B8CFF"/>
@@ -24391,6 +24450,7 @@
               </a:defRPr>
             </a:lvl4pPr>
             <a:lvl5pPr>
+              <a:buNone/>
               <a:defRPr sz="1125" b="1">
                 <a:solidFill>
                   <a:srgbClr val="9B8CFF"/>
@@ -24401,6 +24461,7 @@
               </a:defRPr>
             </a:lvl5pPr>
             <a:lvl6pPr>
+              <a:buNone/>
               <a:defRPr sz="1125" b="1">
                 <a:solidFill>
                   <a:srgbClr val="9B8CFF"/>
@@ -24411,6 +24472,7 @@
               </a:defRPr>
             </a:lvl6pPr>
             <a:lvl7pPr>
+              <a:buNone/>
               <a:defRPr sz="1125" b="1">
                 <a:solidFill>
                   <a:srgbClr val="9B8CFF"/>
@@ -24421,6 +24483,7 @@
               </a:defRPr>
             </a:lvl7pPr>
             <a:lvl8pPr>
+              <a:buNone/>
               <a:defRPr sz="1125" b="1">
                 <a:solidFill>
                   <a:srgbClr val="9B8CFF"/>
@@ -24431,6 +24494,7 @@
               </a:defRPr>
             </a:lvl8pPr>
             <a:lvl9pPr>
+              <a:buNone/>
               <a:defRPr sz="1125" b="1">
                 <a:solidFill>
                   <a:srgbClr val="9B8CFF"/>
@@ -24443,6 +24507,7 @@
           </a:lstStyle>
           <a:p xmlns:a="http://schemas.openxmlformats.org/drawingml/2006/main">
             <a:pPr>
+              <a:buNone/>
               <a:defRPr sz="1125" b="1">
                 <a:solidFill>
                   <a:srgbClr val="9B8CFF"/>
@@ -24508,6 +24573,7 @@
               </a:defRPr>
             </a:defPPr>
             <a:lvl1pPr>
+              <a:buNone/>
               <a:defRPr sz="3000" b="1">
                 <a:solidFill>
                   <a:srgbClr val="F0F3FA"/>
@@ -24518,6 +24584,7 @@
               </a:defRPr>
             </a:lvl1pPr>
             <a:lvl2pPr>
+              <a:buNone/>
               <a:defRPr sz="3000" b="1">
                 <a:solidFill>
                   <a:srgbClr val="F0F3FA"/>
@@ -24528,6 +24595,7 @@
               </a:defRPr>
             </a:lvl2pPr>
             <a:lvl3pPr>
+              <a:buNone/>
               <a:defRPr sz="3000" b="1">
                 <a:solidFill>
                   <a:srgbClr val="F0F3FA"/>
@@ -24538,6 +24606,7 @@
               </a:defRPr>
             </a:lvl3pPr>
             <a:lvl4pPr>
+              <a:buNone/>
               <a:defRPr sz="3000" b="1">
                 <a:solidFill>
                   <a:srgbClr val="F0F3FA"/>
@@ -24548,6 +24617,7 @@
               </a:defRPr>
             </a:lvl4pPr>
             <a:lvl5pPr>
+              <a:buNone/>
               <a:defRPr sz="3000" b="1">
                 <a:solidFill>
                   <a:srgbClr val="F0F3FA"/>
@@ -24558,6 +24628,7 @@
               </a:defRPr>
             </a:lvl5pPr>
             <a:lvl6pPr>
+              <a:buNone/>
               <a:defRPr sz="3000" b="1">
                 <a:solidFill>
                   <a:srgbClr val="F0F3FA"/>
@@ -24568,6 +24639,7 @@
               </a:defRPr>
             </a:lvl6pPr>
             <a:lvl7pPr>
+              <a:buNone/>
               <a:defRPr sz="3000" b="1">
                 <a:solidFill>
                   <a:srgbClr val="F0F3FA"/>
@@ -24578,6 +24650,7 @@
               </a:defRPr>
             </a:lvl7pPr>
             <a:lvl8pPr>
+              <a:buNone/>
               <a:defRPr sz="3000" b="1">
                 <a:solidFill>
                   <a:srgbClr val="F0F3FA"/>
@@ -24588,6 +24661,7 @@
               </a:defRPr>
             </a:lvl8pPr>
             <a:lvl9pPr>
+              <a:buNone/>
               <a:defRPr sz="3000" b="1">
                 <a:solidFill>
                   <a:srgbClr val="F0F3FA"/>
@@ -24600,6 +24674,7 @@
           </a:lstStyle>
           <a:p xmlns:a="http://schemas.openxmlformats.org/drawingml/2006/main">
             <a:pPr>
+              <a:buNone/>
               <a:defRPr sz="3000" b="1">
                 <a:solidFill>
                   <a:srgbClr val="F0F3FA"/>
@@ -24700,6 +24775,7 @@
               </a:defRPr>
             </a:defPPr>
             <a:lvl1pPr>
+              <a:buNone/>
               <a:defRPr sz="1050" b="1">
                 <a:solidFill>
                   <a:srgbClr val="61D9F7"/>
@@ -24710,6 +24786,7 @@
               </a:defRPr>
             </a:lvl1pPr>
             <a:lvl2pPr>
+              <a:buNone/>
               <a:defRPr sz="1050" b="1">
                 <a:solidFill>
                   <a:srgbClr val="61D9F7"/>
@@ -24720,6 +24797,7 @@
               </a:defRPr>
             </a:lvl2pPr>
             <a:lvl3pPr>
+              <a:buNone/>
               <a:defRPr sz="1050" b="1">
                 <a:solidFill>
                   <a:srgbClr val="61D9F7"/>
@@ -24730,6 +24808,7 @@
               </a:defRPr>
             </a:lvl3pPr>
             <a:lvl4pPr>
+              <a:buNone/>
               <a:defRPr sz="1050" b="1">
                 <a:solidFill>
                   <a:srgbClr val="61D9F7"/>
@@ -24740,6 +24819,7 @@
               </a:defRPr>
             </a:lvl4pPr>
             <a:lvl5pPr>
+              <a:buNone/>
               <a:defRPr sz="1050" b="1">
                 <a:solidFill>
                   <a:srgbClr val="61D9F7"/>
@@ -24750,6 +24830,7 @@
               </a:defRPr>
             </a:lvl5pPr>
             <a:lvl6pPr>
+              <a:buNone/>
               <a:defRPr sz="1050" b="1">
                 <a:solidFill>
                   <a:srgbClr val="61D9F7"/>
@@ -24760,6 +24841,7 @@
               </a:defRPr>
             </a:lvl6pPr>
             <a:lvl7pPr>
+              <a:buNone/>
               <a:defRPr sz="1050" b="1">
                 <a:solidFill>
                   <a:srgbClr val="61D9F7"/>
@@ -24770,6 +24852,7 @@
               </a:defRPr>
             </a:lvl7pPr>
             <a:lvl8pPr>
+              <a:buNone/>
               <a:defRPr sz="1050" b="1">
                 <a:solidFill>
                   <a:srgbClr val="61D9F7"/>
@@ -24780,6 +24863,7 @@
               </a:defRPr>
             </a:lvl8pPr>
             <a:lvl9pPr>
+              <a:buNone/>
               <a:defRPr sz="1050" b="1">
                 <a:solidFill>
                   <a:srgbClr val="61D9F7"/>
@@ -24792,6 +24876,7 @@
           </a:lstStyle>
           <a:p xmlns:a="http://schemas.openxmlformats.org/drawingml/2006/main">
             <a:pPr>
+              <a:buNone/>
               <a:defRPr sz="1050" b="1">
                 <a:solidFill>
                   <a:srgbClr val="61D9F7"/>
@@ -24857,6 +24942,7 @@
               </a:defRPr>
             </a:defPPr>
             <a:lvl1pPr>
+              <a:buNone/>
               <a:defRPr sz="1725" b="1">
                 <a:solidFill>
                   <a:srgbClr val="F0F3FA"/>
@@ -24867,6 +24953,7 @@
               </a:defRPr>
             </a:lvl1pPr>
             <a:lvl2pPr>
+              <a:buNone/>
               <a:defRPr sz="1725" b="1">
                 <a:solidFill>
                   <a:srgbClr val="F0F3FA"/>
@@ -24877,6 +24964,7 @@
               </a:defRPr>
             </a:lvl2pPr>
             <a:lvl3pPr>
+              <a:buNone/>
               <a:defRPr sz="1725" b="1">
                 <a:solidFill>
                   <a:srgbClr val="F0F3FA"/>
@@ -24887,6 +24975,7 @@
               </a:defRPr>
             </a:lvl3pPr>
             <a:lvl4pPr>
+              <a:buNone/>
               <a:defRPr sz="1725" b="1">
                 <a:solidFill>
                   <a:srgbClr val="F0F3FA"/>
@@ -24897,6 +24986,7 @@
               </a:defRPr>
             </a:lvl4pPr>
             <a:lvl5pPr>
+              <a:buNone/>
               <a:defRPr sz="1725" b="1">
                 <a:solidFill>
                   <a:srgbClr val="F0F3FA"/>
@@ -24907,6 +24997,7 @@
               </a:defRPr>
             </a:lvl5pPr>
             <a:lvl6pPr>
+              <a:buNone/>
               <a:defRPr sz="1725" b="1">
                 <a:solidFill>
                   <a:srgbClr val="F0F3FA"/>
@@ -24917,6 +25008,7 @@
               </a:defRPr>
             </a:lvl6pPr>
             <a:lvl7pPr>
+              <a:buNone/>
               <a:defRPr sz="1725" b="1">
                 <a:solidFill>
                   <a:srgbClr val="F0F3FA"/>
@@ -24927,6 +25019,7 @@
               </a:defRPr>
             </a:lvl7pPr>
             <a:lvl8pPr>
+              <a:buNone/>
               <a:defRPr sz="1725" b="1">
                 <a:solidFill>
                   <a:srgbClr val="F0F3FA"/>
@@ -24937,6 +25030,7 @@
               </a:defRPr>
             </a:lvl8pPr>
             <a:lvl9pPr>
+              <a:buNone/>
               <a:defRPr sz="1725" b="1">
                 <a:solidFill>
                   <a:srgbClr val="F0F3FA"/>
@@ -24949,6 +25043,7 @@
           </a:lstStyle>
           <a:p xmlns:a="http://schemas.openxmlformats.org/drawingml/2006/main">
             <a:pPr>
+              <a:buNone/>
               <a:defRPr sz="1725" b="1">
                 <a:solidFill>
                   <a:srgbClr val="F0F3FA"/>
@@ -25014,6 +25109,7 @@
               </a:defRPr>
             </a:defPPr>
             <a:lvl1pPr>
+              <a:buNone/>
               <a:defRPr sz="1200">
                 <a:solidFill>
                   <a:srgbClr val="9AA5BD"/>
@@ -25024,6 +25120,7 @@
               </a:defRPr>
             </a:lvl1pPr>
             <a:lvl2pPr>
+              <a:buNone/>
               <a:defRPr sz="1200">
                 <a:solidFill>
                   <a:srgbClr val="9AA5BD"/>
@@ -25034,6 +25131,7 @@
               </a:defRPr>
             </a:lvl2pPr>
             <a:lvl3pPr>
+              <a:buNone/>
               <a:defRPr sz="1200">
                 <a:solidFill>
                   <a:srgbClr val="9AA5BD"/>
@@ -25044,6 +25142,7 @@
               </a:defRPr>
             </a:lvl3pPr>
             <a:lvl4pPr>
+              <a:buNone/>
               <a:defRPr sz="1200">
                 <a:solidFill>
                   <a:srgbClr val="9AA5BD"/>
@@ -25054,6 +25153,7 @@
               </a:defRPr>
             </a:lvl4pPr>
             <a:lvl5pPr>
+              <a:buNone/>
               <a:defRPr sz="1200">
                 <a:solidFill>
                   <a:srgbClr val="9AA5BD"/>
@@ -25064,6 +25164,7 @@
               </a:defRPr>
             </a:lvl5pPr>
             <a:lvl6pPr>
+              <a:buNone/>
               <a:defRPr sz="1200">
                 <a:solidFill>
                   <a:srgbClr val="9AA5BD"/>
@@ -25074,6 +25175,7 @@
               </a:defRPr>
             </a:lvl6pPr>
             <a:lvl7pPr>
+              <a:buNone/>
               <a:defRPr sz="1200">
                 <a:solidFill>
                   <a:srgbClr val="9AA5BD"/>
@@ -25084,6 +25186,7 @@
               </a:defRPr>
             </a:lvl7pPr>
             <a:lvl8pPr>
+              <a:buNone/>
               <a:defRPr sz="1200">
                 <a:solidFill>
                   <a:srgbClr val="9AA5BD"/>
@@ -25094,6 +25197,7 @@
               </a:defRPr>
             </a:lvl8pPr>
             <a:lvl9pPr>
+              <a:buNone/>
               <a:defRPr sz="1200">
                 <a:solidFill>
                   <a:srgbClr val="9AA5BD"/>
@@ -25106,6 +25210,7 @@
           </a:lstStyle>
           <a:p xmlns:a="http://schemas.openxmlformats.org/drawingml/2006/main">
             <a:pPr>
+              <a:buNone/>
               <a:defRPr sz="1200">
                 <a:solidFill>
                   <a:srgbClr val="9AA5BD"/>
@@ -25206,6 +25311,7 @@
               </a:defRPr>
             </a:defPPr>
             <a:lvl1pPr>
+              <a:buNone/>
               <a:defRPr sz="1050" b="1">
                 <a:solidFill>
                   <a:srgbClr val="9B8CFF"/>
@@ -25216,6 +25322,7 @@
               </a:defRPr>
             </a:lvl1pPr>
             <a:lvl2pPr>
+              <a:buNone/>
               <a:defRPr sz="1050" b="1">
                 <a:solidFill>
                   <a:srgbClr val="9B8CFF"/>
@@ -25226,6 +25333,7 @@
               </a:defRPr>
             </a:lvl2pPr>
             <a:lvl3pPr>
+              <a:buNone/>
               <a:defRPr sz="1050" b="1">
                 <a:solidFill>
                   <a:srgbClr val="9B8CFF"/>
@@ -25236,6 +25344,7 @@
               </a:defRPr>
             </a:lvl3pPr>
             <a:lvl4pPr>
+              <a:buNone/>
               <a:defRPr sz="1050" b="1">
                 <a:solidFill>
                   <a:srgbClr val="9B8CFF"/>
@@ -25246,6 +25355,7 @@
               </a:defRPr>
             </a:lvl4pPr>
             <a:lvl5pPr>
+              <a:buNone/>
               <a:defRPr sz="1050" b="1">
                 <a:solidFill>
                   <a:srgbClr val="9B8CFF"/>
@@ -25256,6 +25366,7 @@
               </a:defRPr>
             </a:lvl5pPr>
             <a:lvl6pPr>
+              <a:buNone/>
               <a:defRPr sz="1050" b="1">
                 <a:solidFill>
                   <a:srgbClr val="9B8CFF"/>
@@ -25266,6 +25377,7 @@
               </a:defRPr>
             </a:lvl6pPr>
             <a:lvl7pPr>
+              <a:buNone/>
               <a:defRPr sz="1050" b="1">
                 <a:solidFill>
                   <a:srgbClr val="9B8CFF"/>
@@ -25276,6 +25388,7 @@
               </a:defRPr>
             </a:lvl7pPr>
             <a:lvl8pPr>
+              <a:buNone/>
               <a:defRPr sz="1050" b="1">
                 <a:solidFill>
                   <a:srgbClr val="9B8CFF"/>
@@ -25286,6 +25399,7 @@
               </a:defRPr>
             </a:lvl8pPr>
             <a:lvl9pPr>
+              <a:buNone/>
               <a:defRPr sz="1050" b="1">
                 <a:solidFill>
                   <a:srgbClr val="9B8CFF"/>
@@ -25298,6 +25412,7 @@
           </a:lstStyle>
           <a:p xmlns:a="http://schemas.openxmlformats.org/drawingml/2006/main">
             <a:pPr>
+              <a:buNone/>
               <a:defRPr sz="1050" b="1">
                 <a:solidFill>
                   <a:srgbClr val="9B8CFF"/>
@@ -25363,6 +25478,7 @@
               </a:defRPr>
             </a:defPPr>
             <a:lvl1pPr>
+              <a:buNone/>
               <a:defRPr sz="1725" b="1">
                 <a:solidFill>
                   <a:srgbClr val="F0F3FA"/>
@@ -25373,6 +25489,7 @@
               </a:defRPr>
             </a:lvl1pPr>
             <a:lvl2pPr>
+              <a:buNone/>
               <a:defRPr sz="1725" b="1">
                 <a:solidFill>
                   <a:srgbClr val="F0F3FA"/>
@@ -25383,6 +25500,7 @@
               </a:defRPr>
             </a:lvl2pPr>
             <a:lvl3pPr>
+              <a:buNone/>
               <a:defRPr sz="1725" b="1">
                 <a:solidFill>
                   <a:srgbClr val="F0F3FA"/>
@@ -25393,6 +25511,7 @@
               </a:defRPr>
             </a:lvl3pPr>
             <a:lvl4pPr>
+              <a:buNone/>
               <a:defRPr sz="1725" b="1">
                 <a:solidFill>
                   <a:srgbClr val="F0F3FA"/>
@@ -25403,6 +25522,7 @@
               </a:defRPr>
             </a:lvl4pPr>
             <a:lvl5pPr>
+              <a:buNone/>
               <a:defRPr sz="1725" b="1">
                 <a:solidFill>
                   <a:srgbClr val="F0F3FA"/>
@@ -25413,6 +25533,7 @@
               </a:defRPr>
             </a:lvl5pPr>
             <a:lvl6pPr>
+              <a:buNone/>
               <a:defRPr sz="1725" b="1">
                 <a:solidFill>
                   <a:srgbClr val="F0F3FA"/>
@@ -25423,6 +25544,7 @@
               </a:defRPr>
             </a:lvl6pPr>
             <a:lvl7pPr>
+              <a:buNone/>
               <a:defRPr sz="1725" b="1">
                 <a:solidFill>
                   <a:srgbClr val="F0F3FA"/>
@@ -25433,6 +25555,7 @@
               </a:defRPr>
             </a:lvl7pPr>
             <a:lvl8pPr>
+              <a:buNone/>
               <a:defRPr sz="1725" b="1">
                 <a:solidFill>
                   <a:srgbClr val="F0F3FA"/>
@@ -25443,6 +25566,7 @@
               </a:defRPr>
             </a:lvl8pPr>
             <a:lvl9pPr>
+              <a:buNone/>
               <a:defRPr sz="1725" b="1">
                 <a:solidFill>
                   <a:srgbClr val="F0F3FA"/>
@@ -25455,6 +25579,7 @@
           </a:lstStyle>
           <a:p xmlns:a="http://schemas.openxmlformats.org/drawingml/2006/main">
             <a:pPr>
+              <a:buNone/>
               <a:defRPr sz="1725" b="1">
                 <a:solidFill>
                   <a:srgbClr val="F0F3FA"/>
@@ -25520,6 +25645,7 @@
               </a:defRPr>
             </a:defPPr>
             <a:lvl1pPr>
+              <a:buNone/>
               <a:defRPr sz="1200">
                 <a:solidFill>
                   <a:srgbClr val="9AA5BD"/>
@@ -25530,6 +25656,7 @@
               </a:defRPr>
             </a:lvl1pPr>
             <a:lvl2pPr>
+              <a:buNone/>
               <a:defRPr sz="1200">
                 <a:solidFill>
                   <a:srgbClr val="9AA5BD"/>
@@ -25540,6 +25667,7 @@
               </a:defRPr>
             </a:lvl2pPr>
             <a:lvl3pPr>
+              <a:buNone/>
               <a:defRPr sz="1200">
                 <a:solidFill>
                   <a:srgbClr val="9AA5BD"/>
@@ -25550,6 +25678,7 @@
               </a:defRPr>
             </a:lvl3pPr>
             <a:lvl4pPr>
+              <a:buNone/>
               <a:defRPr sz="1200">
                 <a:solidFill>
                   <a:srgbClr val="9AA5BD"/>
@@ -25560,6 +25689,7 @@
               </a:defRPr>
             </a:lvl4pPr>
             <a:lvl5pPr>
+              <a:buNone/>
               <a:defRPr sz="1200">
                 <a:solidFill>
                   <a:srgbClr val="9AA5BD"/>
@@ -25570,6 +25700,7 @@
               </a:defRPr>
             </a:lvl5pPr>
             <a:lvl6pPr>
+              <a:buNone/>
               <a:defRPr sz="1200">
                 <a:solidFill>
                   <a:srgbClr val="9AA5BD"/>
@@ -25580,6 +25711,7 @@
               </a:defRPr>
             </a:lvl6pPr>
             <a:lvl7pPr>
+              <a:buNone/>
               <a:defRPr sz="1200">
                 <a:solidFill>
                   <a:srgbClr val="9AA5BD"/>
@@ -25590,6 +25722,7 @@
               </a:defRPr>
             </a:lvl7pPr>
             <a:lvl8pPr>
+              <a:buNone/>
               <a:defRPr sz="1200">
                 <a:solidFill>
                   <a:srgbClr val="9AA5BD"/>
@@ -25600,6 +25733,7 @@
               </a:defRPr>
             </a:lvl8pPr>
             <a:lvl9pPr>
+              <a:buNone/>
               <a:defRPr sz="1200">
                 <a:solidFill>
                   <a:srgbClr val="9AA5BD"/>
@@ -25612,6 +25746,7 @@
           </a:lstStyle>
           <a:p xmlns:a="http://schemas.openxmlformats.org/drawingml/2006/main">
             <a:pPr>
+              <a:buNone/>
               <a:defRPr sz="1200">
                 <a:solidFill>
                   <a:srgbClr val="9AA5BD"/>
@@ -25712,6 +25847,7 @@
               </a:defRPr>
             </a:defPPr>
             <a:lvl1pPr>
+              <a:buNone/>
               <a:defRPr sz="1050" b="1">
                 <a:solidFill>
                   <a:srgbClr val="58DDB0"/>
@@ -25722,6 +25858,7 @@
               </a:defRPr>
             </a:lvl1pPr>
             <a:lvl2pPr>
+              <a:buNone/>
               <a:defRPr sz="1050" b="1">
                 <a:solidFill>
                   <a:srgbClr val="58DDB0"/>
@@ -25732,6 +25869,7 @@
               </a:defRPr>
             </a:lvl2pPr>
             <a:lvl3pPr>
+              <a:buNone/>
               <a:defRPr sz="1050" b="1">
                 <a:solidFill>
                   <a:srgbClr val="58DDB0"/>
@@ -25742,6 +25880,7 @@
               </a:defRPr>
             </a:lvl3pPr>
             <a:lvl4pPr>
+              <a:buNone/>
               <a:defRPr sz="1050" b="1">
                 <a:solidFill>
                   <a:srgbClr val="58DDB0"/>
@@ -25752,6 +25891,7 @@
               </a:defRPr>
             </a:lvl4pPr>
             <a:lvl5pPr>
+              <a:buNone/>
               <a:defRPr sz="1050" b="1">
                 <a:solidFill>
                   <a:srgbClr val="58DDB0"/>
@@ -25762,6 +25902,7 @@
               </a:defRPr>
             </a:lvl5pPr>
             <a:lvl6pPr>
+              <a:buNone/>
               <a:defRPr sz="1050" b="1">
                 <a:solidFill>
                   <a:srgbClr val="58DDB0"/>
@@ -25772,6 +25913,7 @@
               </a:defRPr>
             </a:lvl6pPr>
             <a:lvl7pPr>
+              <a:buNone/>
               <a:defRPr sz="1050" b="1">
                 <a:solidFill>
                   <a:srgbClr val="58DDB0"/>
@@ -25782,6 +25924,7 @@
               </a:defRPr>
             </a:lvl7pPr>
             <a:lvl8pPr>
+              <a:buNone/>
               <a:defRPr sz="1050" b="1">
                 <a:solidFill>
                   <a:srgbClr val="58DDB0"/>
@@ -25792,6 +25935,7 @@
               </a:defRPr>
             </a:lvl8pPr>
             <a:lvl9pPr>
+              <a:buNone/>
               <a:defRPr sz="1050" b="1">
                 <a:solidFill>
                   <a:srgbClr val="58DDB0"/>
@@ -25804,6 +25948,7 @@
           </a:lstStyle>
           <a:p xmlns:a="http://schemas.openxmlformats.org/drawingml/2006/main">
             <a:pPr>
+              <a:buNone/>
               <a:defRPr sz="1050" b="1">
                 <a:solidFill>
                   <a:srgbClr val="58DDB0"/>
@@ -25869,6 +26014,7 @@
               </a:defRPr>
             </a:defPPr>
             <a:lvl1pPr>
+              <a:buNone/>
               <a:defRPr sz="1725" b="1">
                 <a:solidFill>
                   <a:srgbClr val="F0F3FA"/>
@@ -25879,6 +26025,7 @@
               </a:defRPr>
             </a:lvl1pPr>
             <a:lvl2pPr>
+              <a:buNone/>
               <a:defRPr sz="1725" b="1">
                 <a:solidFill>
                   <a:srgbClr val="F0F3FA"/>
@@ -25889,6 +26036,7 @@
               </a:defRPr>
             </a:lvl2pPr>
             <a:lvl3pPr>
+              <a:buNone/>
               <a:defRPr sz="1725" b="1">
                 <a:solidFill>
                   <a:srgbClr val="F0F3FA"/>
@@ -25899,6 +26047,7 @@
               </a:defRPr>
             </a:lvl3pPr>
             <a:lvl4pPr>
+              <a:buNone/>
               <a:defRPr sz="1725" b="1">
                 <a:solidFill>
                   <a:srgbClr val="F0F3FA"/>
@@ -25909,6 +26058,7 @@
               </a:defRPr>
             </a:lvl4pPr>
             <a:lvl5pPr>
+              <a:buNone/>
               <a:defRPr sz="1725" b="1">
                 <a:solidFill>
                   <a:srgbClr val="F0F3FA"/>
@@ -25919,6 +26069,7 @@
               </a:defRPr>
             </a:lvl5pPr>
             <a:lvl6pPr>
+              <a:buNone/>
               <a:defRPr sz="1725" b="1">
                 <a:solidFill>
                   <a:srgbClr val="F0F3FA"/>
@@ -25929,6 +26080,7 @@
               </a:defRPr>
             </a:lvl6pPr>
             <a:lvl7pPr>
+              <a:buNone/>
               <a:defRPr sz="1725" b="1">
                 <a:solidFill>
                   <a:srgbClr val="F0F3FA"/>
@@ -25939,6 +26091,7 @@
               </a:defRPr>
             </a:lvl7pPr>
             <a:lvl8pPr>
+              <a:buNone/>
               <a:defRPr sz="1725" b="1">
                 <a:solidFill>
                   <a:srgbClr val="F0F3FA"/>
@@ -25949,6 +26102,7 @@
               </a:defRPr>
             </a:lvl8pPr>
             <a:lvl9pPr>
+              <a:buNone/>
               <a:defRPr sz="1725" b="1">
                 <a:solidFill>
                   <a:srgbClr val="F0F3FA"/>
@@ -25961,6 +26115,7 @@
           </a:lstStyle>
           <a:p xmlns:a="http://schemas.openxmlformats.org/drawingml/2006/main">
             <a:pPr>
+              <a:buNone/>
               <a:defRPr sz="1725" b="1">
                 <a:solidFill>
                   <a:srgbClr val="F0F3FA"/>
@@ -26026,6 +26181,7 @@
               </a:defRPr>
             </a:defPPr>
             <a:lvl1pPr>
+              <a:buNone/>
               <a:defRPr sz="1200">
                 <a:solidFill>
                   <a:srgbClr val="9AA5BD"/>
@@ -26036,6 +26192,7 @@
               </a:defRPr>
             </a:lvl1pPr>
             <a:lvl2pPr>
+              <a:buNone/>
               <a:defRPr sz="1200">
                 <a:solidFill>
                   <a:srgbClr val="9AA5BD"/>
@@ -26046,6 +26203,7 @@
               </a:defRPr>
             </a:lvl2pPr>
             <a:lvl3pPr>
+              <a:buNone/>
               <a:defRPr sz="1200">
                 <a:solidFill>
                   <a:srgbClr val="9AA5BD"/>
@@ -26056,6 +26214,7 @@
               </a:defRPr>
             </a:lvl3pPr>
             <a:lvl4pPr>
+              <a:buNone/>
               <a:defRPr sz="1200">
                 <a:solidFill>
                   <a:srgbClr val="9AA5BD"/>
@@ -26066,6 +26225,7 @@
               </a:defRPr>
             </a:lvl4pPr>
             <a:lvl5pPr>
+              <a:buNone/>
               <a:defRPr sz="1200">
                 <a:solidFill>
                   <a:srgbClr val="9AA5BD"/>
@@ -26076,6 +26236,7 @@
               </a:defRPr>
             </a:lvl5pPr>
             <a:lvl6pPr>
+              <a:buNone/>
               <a:defRPr sz="1200">
                 <a:solidFill>
                   <a:srgbClr val="9AA5BD"/>
@@ -26086,6 +26247,7 @@
               </a:defRPr>
             </a:lvl6pPr>
             <a:lvl7pPr>
+              <a:buNone/>
               <a:defRPr sz="1200">
                 <a:solidFill>
                   <a:srgbClr val="9AA5BD"/>
@@ -26096,6 +26258,7 @@
               </a:defRPr>
             </a:lvl7pPr>
             <a:lvl8pPr>
+              <a:buNone/>
               <a:defRPr sz="1200">
                 <a:solidFill>
                   <a:srgbClr val="9AA5BD"/>
@@ -26106,6 +26269,7 @@
               </a:defRPr>
             </a:lvl8pPr>
             <a:lvl9pPr>
+              <a:buNone/>
               <a:defRPr sz="1200">
                 <a:solidFill>
                   <a:srgbClr val="9AA5BD"/>
@@ -26118,6 +26282,7 @@
           </a:lstStyle>
           <a:p xmlns:a="http://schemas.openxmlformats.org/drawingml/2006/main">
             <a:pPr>
+              <a:buNone/>
               <a:defRPr sz="1200">
                 <a:solidFill>
                   <a:srgbClr val="9AA5BD"/>
@@ -26183,6 +26348,7 @@
               </a:defRPr>
             </a:defPPr>
             <a:lvl1pPr>
+              <a:buNone/>
               <a:defRPr sz="900" b="1">
                 <a:solidFill>
                   <a:srgbClr val="E8B76E"/>
@@ -26193,6 +26359,7 @@
               </a:defRPr>
             </a:lvl1pPr>
             <a:lvl2pPr>
+              <a:buNone/>
               <a:defRPr sz="900" b="1">
                 <a:solidFill>
                   <a:srgbClr val="E8B76E"/>
@@ -26203,6 +26370,7 @@
               </a:defRPr>
             </a:lvl2pPr>
             <a:lvl3pPr>
+              <a:buNone/>
               <a:defRPr sz="900" b="1">
                 <a:solidFill>
                   <a:srgbClr val="E8B76E"/>
@@ -26213,6 +26381,7 @@
               </a:defRPr>
             </a:lvl3pPr>
             <a:lvl4pPr>
+              <a:buNone/>
               <a:defRPr sz="900" b="1">
                 <a:solidFill>
                   <a:srgbClr val="E8B76E"/>
@@ -26223,6 +26392,7 @@
               </a:defRPr>
             </a:lvl4pPr>
             <a:lvl5pPr>
+              <a:buNone/>
               <a:defRPr sz="900" b="1">
                 <a:solidFill>
                   <a:srgbClr val="E8B76E"/>
@@ -26233,6 +26403,7 @@
               </a:defRPr>
             </a:lvl5pPr>
             <a:lvl6pPr>
+              <a:buNone/>
               <a:defRPr sz="900" b="1">
                 <a:solidFill>
                   <a:srgbClr val="E8B76E"/>
@@ -26243,6 +26414,7 @@
               </a:defRPr>
             </a:lvl6pPr>
             <a:lvl7pPr>
+              <a:buNone/>
               <a:defRPr sz="900" b="1">
                 <a:solidFill>
                   <a:srgbClr val="E8B76E"/>
@@ -26253,6 +26425,7 @@
               </a:defRPr>
             </a:lvl7pPr>
             <a:lvl8pPr>
+              <a:buNone/>
               <a:defRPr sz="900" b="1">
                 <a:solidFill>
                   <a:srgbClr val="E8B76E"/>
@@ -26263,6 +26436,7 @@
               </a:defRPr>
             </a:lvl8pPr>
             <a:lvl9pPr>
+              <a:buNone/>
               <a:defRPr sz="900" b="1">
                 <a:solidFill>
                   <a:srgbClr val="E8B76E"/>
@@ -26275,6 +26449,7 @@
           </a:lstStyle>
           <a:p xmlns:a="http://schemas.openxmlformats.org/drawingml/2006/main">
             <a:pPr>
+              <a:buNone/>
               <a:defRPr sz="900" b="1">
                 <a:solidFill>
                   <a:srgbClr val="E8B76E"/>
@@ -26340,6 +26515,7 @@
               </a:defRPr>
             </a:defPPr>
             <a:lvl1pPr algn="ctr">
+              <a:buNone/>
               <a:defRPr sz="1425" b="1">
                 <a:solidFill>
                   <a:srgbClr val="F0F3FA"/>
@@ -26350,6 +26526,7 @@
               </a:defRPr>
             </a:lvl1pPr>
             <a:lvl2pPr algn="ctr">
+              <a:buNone/>
               <a:defRPr sz="1425" b="1">
                 <a:solidFill>
                   <a:srgbClr val="F0F3FA"/>
@@ -26360,6 +26537,7 @@
               </a:defRPr>
             </a:lvl2pPr>
             <a:lvl3pPr algn="ctr">
+              <a:buNone/>
               <a:defRPr sz="1425" b="1">
                 <a:solidFill>
                   <a:srgbClr val="F0F3FA"/>
@@ -26370,6 +26548,7 @@
               </a:defRPr>
             </a:lvl3pPr>
             <a:lvl4pPr algn="ctr">
+              <a:buNone/>
               <a:defRPr sz="1425" b="1">
                 <a:solidFill>
                   <a:srgbClr val="F0F3FA"/>
@@ -26380,6 +26559,7 @@
               </a:defRPr>
             </a:lvl4pPr>
             <a:lvl5pPr algn="ctr">
+              <a:buNone/>
               <a:defRPr sz="1425" b="1">
                 <a:solidFill>
                   <a:srgbClr val="F0F3FA"/>
@@ -26390,6 +26570,7 @@
               </a:defRPr>
             </a:lvl5pPr>
             <a:lvl6pPr algn="ctr">
+              <a:buNone/>
               <a:defRPr sz="1425" b="1">
                 <a:solidFill>
                   <a:srgbClr val="F0F3FA"/>
@@ -26400,6 +26581,7 @@
               </a:defRPr>
             </a:lvl6pPr>
             <a:lvl7pPr algn="ctr">
+              <a:buNone/>
               <a:defRPr sz="1425" b="1">
                 <a:solidFill>
                   <a:srgbClr val="F0F3FA"/>
@@ -26410,6 +26592,7 @@
               </a:defRPr>
             </a:lvl7pPr>
             <a:lvl8pPr algn="ctr">
+              <a:buNone/>
               <a:defRPr sz="1425" b="1">
                 <a:solidFill>
                   <a:srgbClr val="F0F3FA"/>
@@ -26420,6 +26603,7 @@
               </a:defRPr>
             </a:lvl8pPr>
             <a:lvl9pPr algn="ctr">
+              <a:buNone/>
               <a:defRPr sz="1425" b="1">
                 <a:solidFill>
                   <a:srgbClr val="F0F3FA"/>
@@ -26432,6 +26616,7 @@
           </a:lstStyle>
           <a:p xmlns:a="http://schemas.openxmlformats.org/drawingml/2006/main">
             <a:pPr algn="ctr">
+              <a:buNone/>
               <a:defRPr sz="1425" b="1">
                 <a:solidFill>
                   <a:srgbClr val="F0F3FA"/>
@@ -26528,6 +26713,7 @@
               </a:defRPr>
             </a:defPPr>
             <a:lvl1pPr algn="ctr">
+              <a:buNone/>
               <a:defRPr sz="2100">
                 <a:solidFill>
                   <a:srgbClr val="546079"/>
@@ -26538,6 +26724,7 @@
               </a:defRPr>
             </a:lvl1pPr>
             <a:lvl2pPr algn="ctr">
+              <a:buNone/>
               <a:defRPr sz="2100">
                 <a:solidFill>
                   <a:srgbClr val="546079"/>
@@ -26548,6 +26735,7 @@
               </a:defRPr>
             </a:lvl2pPr>
             <a:lvl3pPr algn="ctr">
+              <a:buNone/>
               <a:defRPr sz="2100">
                 <a:solidFill>
                   <a:srgbClr val="546079"/>
@@ -26558,6 +26746,7 @@
               </a:defRPr>
             </a:lvl3pPr>
             <a:lvl4pPr algn="ctr">
+              <a:buNone/>
               <a:defRPr sz="2100">
                 <a:solidFill>
                   <a:srgbClr val="546079"/>
@@ -26568,6 +26757,7 @@
               </a:defRPr>
             </a:lvl4pPr>
             <a:lvl5pPr algn="ctr">
+              <a:buNone/>
               <a:defRPr sz="2100">
                 <a:solidFill>
                   <a:srgbClr val="546079"/>
@@ -26578,6 +26768,7 @@
               </a:defRPr>
             </a:lvl5pPr>
             <a:lvl6pPr algn="ctr">
+              <a:buNone/>
               <a:defRPr sz="2100">
                 <a:solidFill>
                   <a:srgbClr val="546079"/>
@@ -26588,6 +26779,7 @@
               </a:defRPr>
             </a:lvl6pPr>
             <a:lvl7pPr algn="ctr">
+              <a:buNone/>
               <a:defRPr sz="2100">
                 <a:solidFill>
                   <a:srgbClr val="546079"/>
@@ -26598,6 +26790,7 @@
               </a:defRPr>
             </a:lvl7pPr>
             <a:lvl8pPr algn="ctr">
+              <a:buNone/>
               <a:defRPr sz="2100">
                 <a:solidFill>
                   <a:srgbClr val="546079"/>
@@ -26608,6 +26801,7 @@
               </a:defRPr>
             </a:lvl8pPr>
             <a:lvl9pPr algn="ctr">
+              <a:buNone/>
               <a:defRPr sz="2100">
                 <a:solidFill>
                   <a:srgbClr val="546079"/>
@@ -26620,6 +26814,7 @@
           </a:lstStyle>
           <a:p xmlns:a="http://schemas.openxmlformats.org/drawingml/2006/main">
             <a:pPr algn="ctr">
+              <a:buNone/>
               <a:defRPr sz="2100">
                 <a:solidFill>
                   <a:srgbClr val="546079"/>
@@ -26685,6 +26880,7 @@
               </a:defRPr>
             </a:defPPr>
             <a:lvl1pPr>
+              <a:buNone/>
               <a:defRPr sz="1350" b="1">
                 <a:solidFill>
                   <a:srgbClr val="9B8CFF"/>
@@ -26695,6 +26891,7 @@
               </a:defRPr>
             </a:lvl1pPr>
             <a:lvl2pPr>
+              <a:buNone/>
               <a:defRPr sz="1350" b="1">
                 <a:solidFill>
                   <a:srgbClr val="9B8CFF"/>
@@ -26705,6 +26902,7 @@
               </a:defRPr>
             </a:lvl2pPr>
             <a:lvl3pPr>
+              <a:buNone/>
               <a:defRPr sz="1350" b="1">
                 <a:solidFill>
                   <a:srgbClr val="9B8CFF"/>
@@ -26715,6 +26913,7 @@
               </a:defRPr>
             </a:lvl3pPr>
             <a:lvl4pPr>
+              <a:buNone/>
               <a:defRPr sz="1350" b="1">
                 <a:solidFill>
                   <a:srgbClr val="9B8CFF"/>
@@ -26725,6 +26924,7 @@
               </a:defRPr>
             </a:lvl4pPr>
             <a:lvl5pPr>
+              <a:buNone/>
               <a:defRPr sz="1350" b="1">
                 <a:solidFill>
                   <a:srgbClr val="9B8CFF"/>
@@ -26735,6 +26935,7 @@
               </a:defRPr>
             </a:lvl5pPr>
             <a:lvl6pPr>
+              <a:buNone/>
               <a:defRPr sz="1350" b="1">
                 <a:solidFill>
                   <a:srgbClr val="9B8CFF"/>
@@ -26745,6 +26946,7 @@
               </a:defRPr>
             </a:lvl6pPr>
             <a:lvl7pPr>
+              <a:buNone/>
               <a:defRPr sz="1350" b="1">
                 <a:solidFill>
                   <a:srgbClr val="9B8CFF"/>
@@ -26755,6 +26957,7 @@
               </a:defRPr>
             </a:lvl7pPr>
             <a:lvl8pPr>
+              <a:buNone/>
               <a:defRPr sz="1350" b="1">
                 <a:solidFill>
                   <a:srgbClr val="9B8CFF"/>
@@ -26765,6 +26968,7 @@
               </a:defRPr>
             </a:lvl8pPr>
             <a:lvl9pPr>
+              <a:buNone/>
               <a:defRPr sz="1350" b="1">
                 <a:solidFill>
                   <a:srgbClr val="9B8CFF"/>
@@ -26777,6 +26981,7 @@
           </a:lstStyle>
           <a:p xmlns:a="http://schemas.openxmlformats.org/drawingml/2006/main">
             <a:pPr>
+              <a:buNone/>
               <a:defRPr sz="1350" b="1">
                 <a:solidFill>
                   <a:srgbClr val="9B8CFF"/>
@@ -26842,6 +27047,7 @@
               </a:defRPr>
             </a:defPPr>
             <a:lvl1pPr>
+              <a:buNone/>
               <a:defRPr sz="1050">
                 <a:solidFill>
                   <a:srgbClr val="61D9F7"/>
@@ -26852,6 +27058,7 @@
               </a:defRPr>
             </a:lvl1pPr>
             <a:lvl2pPr>
+              <a:buNone/>
               <a:defRPr sz="1050">
                 <a:solidFill>
                   <a:srgbClr val="61D9F7"/>
@@ -26862,6 +27069,7 @@
               </a:defRPr>
             </a:lvl2pPr>
             <a:lvl3pPr>
+              <a:buNone/>
               <a:defRPr sz="1050">
                 <a:solidFill>
                   <a:srgbClr val="61D9F7"/>
@@ -26872,6 +27080,7 @@
               </a:defRPr>
             </a:lvl3pPr>
             <a:lvl4pPr>
+              <a:buNone/>
               <a:defRPr sz="1050">
                 <a:solidFill>
                   <a:srgbClr val="61D9F7"/>
@@ -26882,6 +27091,7 @@
               </a:defRPr>
             </a:lvl4pPr>
             <a:lvl5pPr>
+              <a:buNone/>
               <a:defRPr sz="1050">
                 <a:solidFill>
                   <a:srgbClr val="61D9F7"/>
@@ -26892,6 +27102,7 @@
               </a:defRPr>
             </a:lvl5pPr>
             <a:lvl6pPr>
+              <a:buNone/>
               <a:defRPr sz="1050">
                 <a:solidFill>
                   <a:srgbClr val="61D9F7"/>
@@ -26902,6 +27113,7 @@
               </a:defRPr>
             </a:lvl6pPr>
             <a:lvl7pPr>
+              <a:buNone/>
               <a:defRPr sz="1050">
                 <a:solidFill>
                   <a:srgbClr val="61D9F7"/>
@@ -26912,6 +27124,7 @@
               </a:defRPr>
             </a:lvl7pPr>
             <a:lvl8pPr>
+              <a:buNone/>
               <a:defRPr sz="1050">
                 <a:solidFill>
                   <a:srgbClr val="61D9F7"/>
@@ -26922,6 +27135,7 @@
               </a:defRPr>
             </a:lvl8pPr>
             <a:lvl9pPr>
+              <a:buNone/>
               <a:defRPr sz="1050">
                 <a:solidFill>
                   <a:srgbClr val="61D9F7"/>
@@ -26934,6 +27148,7 @@
           </a:lstStyle>
           <a:p xmlns:a="http://schemas.openxmlformats.org/drawingml/2006/main">
             <a:pPr>
+              <a:buNone/>
               <a:defRPr sz="1050">
                 <a:solidFill>
                   <a:srgbClr val="61D9F7"/>
@@ -27030,6 +27245,7 @@
               </a:defRPr>
             </a:defPPr>
             <a:lvl1pPr>
+              <a:buNone/>
               <a:defRPr sz="900">
                 <a:solidFill>
                   <a:srgbClr val="65718A"/>
@@ -27040,6 +27256,7 @@
               </a:defRPr>
             </a:lvl1pPr>
             <a:lvl2pPr>
+              <a:buNone/>
               <a:defRPr sz="900">
                 <a:solidFill>
                   <a:srgbClr val="65718A"/>
@@ -27050,6 +27267,7 @@
               </a:defRPr>
             </a:lvl2pPr>
             <a:lvl3pPr>
+              <a:buNone/>
               <a:defRPr sz="900">
                 <a:solidFill>
                   <a:srgbClr val="65718A"/>
@@ -27060,6 +27278,7 @@
               </a:defRPr>
             </a:lvl3pPr>
             <a:lvl4pPr>
+              <a:buNone/>
               <a:defRPr sz="900">
                 <a:solidFill>
                   <a:srgbClr val="65718A"/>
@@ -27070,6 +27289,7 @@
               </a:defRPr>
             </a:lvl4pPr>
             <a:lvl5pPr>
+              <a:buNone/>
               <a:defRPr sz="900">
                 <a:solidFill>
                   <a:srgbClr val="65718A"/>
@@ -27080,6 +27300,7 @@
               </a:defRPr>
             </a:lvl5pPr>
             <a:lvl6pPr>
+              <a:buNone/>
               <a:defRPr sz="900">
                 <a:solidFill>
                   <a:srgbClr val="65718A"/>
@@ -27090,6 +27311,7 @@
               </a:defRPr>
             </a:lvl6pPr>
             <a:lvl7pPr>
+              <a:buNone/>
               <a:defRPr sz="900">
                 <a:solidFill>
                   <a:srgbClr val="65718A"/>
@@ -27100,6 +27322,7 @@
               </a:defRPr>
             </a:lvl7pPr>
             <a:lvl8pPr>
+              <a:buNone/>
               <a:defRPr sz="900">
                 <a:solidFill>
                   <a:srgbClr val="65718A"/>
@@ -27110,6 +27333,7 @@
               </a:defRPr>
             </a:lvl8pPr>
             <a:lvl9pPr>
+              <a:buNone/>
               <a:defRPr sz="900">
                 <a:solidFill>
                   <a:srgbClr val="65718A"/>
@@ -27122,6 +27346,7 @@
           </a:lstStyle>
           <a:p xmlns:a="http://schemas.openxmlformats.org/drawingml/2006/main">
             <a:pPr>
+              <a:buNone/>
               <a:defRPr sz="900">
                 <a:solidFill>
                   <a:srgbClr val="65718A"/>
@@ -27187,6 +27412,7 @@
               </a:defRPr>
             </a:defPPr>
             <a:lvl1pPr algn="r">
+              <a:buNone/>
               <a:defRPr sz="900">
                 <a:solidFill>
                   <a:srgbClr val="65718A"/>
@@ -27197,6 +27423,7 @@
               </a:defRPr>
             </a:lvl1pPr>
             <a:lvl2pPr algn="r">
+              <a:buNone/>
               <a:defRPr sz="900">
                 <a:solidFill>
                   <a:srgbClr val="65718A"/>
@@ -27207,6 +27434,7 @@
               </a:defRPr>
             </a:lvl2pPr>
             <a:lvl3pPr algn="r">
+              <a:buNone/>
               <a:defRPr sz="900">
                 <a:solidFill>
                   <a:srgbClr val="65718A"/>
@@ -27217,6 +27445,7 @@
               </a:defRPr>
             </a:lvl3pPr>
             <a:lvl4pPr algn="r">
+              <a:buNone/>
               <a:defRPr sz="900">
                 <a:solidFill>
                   <a:srgbClr val="65718A"/>
@@ -27227,6 +27456,7 @@
               </a:defRPr>
             </a:lvl4pPr>
             <a:lvl5pPr algn="r">
+              <a:buNone/>
               <a:defRPr sz="900">
                 <a:solidFill>
                   <a:srgbClr val="65718A"/>
@@ -27237,6 +27467,7 @@
               </a:defRPr>
             </a:lvl5pPr>
             <a:lvl6pPr algn="r">
+              <a:buNone/>
               <a:defRPr sz="900">
                 <a:solidFill>
                   <a:srgbClr val="65718A"/>
@@ -27247,6 +27478,7 @@
               </a:defRPr>
             </a:lvl6pPr>
             <a:lvl7pPr algn="r">
+              <a:buNone/>
               <a:defRPr sz="900">
                 <a:solidFill>
                   <a:srgbClr val="65718A"/>
@@ -27257,6 +27489,7 @@
               </a:defRPr>
             </a:lvl7pPr>
             <a:lvl8pPr algn="r">
+              <a:buNone/>
               <a:defRPr sz="900">
                 <a:solidFill>
                   <a:srgbClr val="65718A"/>
@@ -27267,6 +27500,7 @@
               </a:defRPr>
             </a:lvl8pPr>
             <a:lvl9pPr algn="r">
+              <a:buNone/>
               <a:defRPr sz="900">
                 <a:solidFill>
                   <a:srgbClr val="65718A"/>
@@ -27279,6 +27513,7 @@
           </a:lstStyle>
           <a:p xmlns:a="http://schemas.openxmlformats.org/drawingml/2006/main">
             <a:pPr algn="r">
+              <a:buNone/>
               <a:defRPr sz="900">
                 <a:solidFill>
                   <a:srgbClr val="65718A"/>
@@ -28495,7 +28730,7 @@
                 <a:ea typeface="Arial"/>
                 <a:cs typeface="Arial"/>
               </a:rPr>
-              <a:t>75 / 75</a:t>
+              <a:t>80 / 80</a:t>
             </a:r>
           </a:p>
         </p:txBody>
@@ -29538,7 +29773,7 @@
           <p:cNvPr id="17" name="Chart">
             <a:extLst xmlns:a="http://schemas.openxmlformats.org/drawingml/2006/main">
               <a:ext uri="{FF2B5EF4-FFF2-40B4-BE49-F238E27FC236}">
-                <a16:creationId xmlns:a16="http://schemas.microsoft.com/office/drawing/2014/main" id="{AB94B0CF-3577-4DD5-9553-7CE9B4E63F7F}"/>
+                <a16:creationId xmlns:a16="http://schemas.microsoft.com/office/drawing/2014/main" id="{762CE26F-7682-41C4-BD13-C386B6E89C90}"/>
               </a:ext>
             </a:extLst>
           </p:cNvPr>
@@ -29551,7 +29786,7 @@
         </p:xfrm>
         <a:graphic xmlns:a="http://schemas.openxmlformats.org/drawingml/2006/main">
           <a:graphicData uri="http://schemas.openxmlformats.org/drawingml/2006/chart">
-            <c:chart xmlns:r="http://schemas.openxmlformats.org/officeDocument/2006/relationships" xmlns:c="http://schemas.openxmlformats.org/drawingml/2006/chart" r:id="Rca6c4f60efe040c4"/>
+            <c:chart xmlns:r="http://schemas.openxmlformats.org/officeDocument/2006/relationships" xmlns:c="http://schemas.openxmlformats.org/drawingml/2006/chart" r:id="R0306ec828c7b48c8"/>
           </a:graphicData>
         </a:graphic>
       </p:graphicFrame>
@@ -29923,7 +30158,7 @@
           <p:cNvPr id="3" name="">
             <a:extLst xmlns:a="http://schemas.openxmlformats.org/drawingml/2006/main">
               <a:ext uri="{FF2B5EF4-FFF2-40B4-BE49-F238E27FC236}">
-                <a16:creationId xmlns:a16="http://schemas.microsoft.com/office/drawing/2014/main" id="{6AD489A6-6570-4CB0-9FD3-1B98A478D6FA}"/>
+                <a16:creationId xmlns:a16="http://schemas.microsoft.com/office/drawing/2014/main" id="{76E9934D-3C7E-4489-915F-77CE94986C0E}"/>
               </a:ext>
             </a:extLst>
           </p:cNvPr>
@@ -29933,7 +30168,7 @@
           <p:nvPr/>
         </p:nvPicPr>
         <p:blipFill>
-          <a:blip xmlns:r="http://schemas.openxmlformats.org/officeDocument/2006/relationships" xmlns:a="http://schemas.openxmlformats.org/drawingml/2006/main" r:embed="R4800270d28914bcc"/>
+          <a:blip xmlns:r="http://schemas.openxmlformats.org/officeDocument/2006/relationships" xmlns:a="http://schemas.openxmlformats.org/drawingml/2006/main" r:embed="R16c649d5b7ae480b"/>
           <a:srcRect xmlns:a="http://schemas.openxmlformats.org/drawingml/2006/main" l="0" t="47" r="0" b="47"/>
           <a:stretch xmlns:a="http://schemas.openxmlformats.org/drawingml/2006/main">
             <a:fillRect l="0" t="0" r="0" b="0"/>

</xml_diff>

<commit_message>
addition of public data
</commit_message>
<xml_diff>
--- a/submission/opsintel-ai-pitch-deck.pptx
+++ b/submission/opsintel-ai-pitch-deck.pptx
@@ -2,23 +2,23 @@
 <file path=ppt/presentation.xml><?xml version="1.0" encoding="utf-8"?>
 <p:presentation xmlns:p="http://schemas.openxmlformats.org/presentationml/2006/main">
   <p:sldMasterIdLst>
-    <p:sldMasterId xmlns:r="http://schemas.openxmlformats.org/officeDocument/2006/relationships" id="2147483648" r:id="R22c9760d1d8d446c"/>
+    <p:sldMasterId xmlns:r="http://schemas.openxmlformats.org/officeDocument/2006/relationships" id="2147483648" r:id="R9b270e9e2e474543"/>
   </p:sldMasterIdLst>
   <p:notesMasterIdLst>
-    <p:notesMasterId xmlns:r="http://schemas.openxmlformats.org/officeDocument/2006/relationships" r:id="Rdf2a1ae10398473b"/>
+    <p:notesMasterId xmlns:r="http://schemas.openxmlformats.org/officeDocument/2006/relationships" r:id="R7ae0cdedf6414171"/>
   </p:notesMasterIdLst>
   <p:sldIdLst>
-    <p:sldId xmlns:r="http://schemas.openxmlformats.org/officeDocument/2006/relationships" id="256" r:id="Rc294bb66b09145dd"/>
-    <p:sldId xmlns:r="http://schemas.openxmlformats.org/officeDocument/2006/relationships" id="257" r:id="Re9b5a530c5b147dc"/>
-    <p:sldId xmlns:r="http://schemas.openxmlformats.org/officeDocument/2006/relationships" id="258" r:id="Rbc417f482394435c"/>
-    <p:sldId xmlns:r="http://schemas.openxmlformats.org/officeDocument/2006/relationships" id="259" r:id="Ra52616d5c21b4225"/>
-    <p:sldId xmlns:r="http://schemas.openxmlformats.org/officeDocument/2006/relationships" id="260" r:id="R883ccfec1d344a4a"/>
-    <p:sldId xmlns:r="http://schemas.openxmlformats.org/officeDocument/2006/relationships" id="261" r:id="R6c198ae463194ba5"/>
-    <p:sldId xmlns:r="http://schemas.openxmlformats.org/officeDocument/2006/relationships" id="262" r:id="R8614c7a2212d4f60"/>
-    <p:sldId xmlns:r="http://schemas.openxmlformats.org/officeDocument/2006/relationships" id="263" r:id="R83992714612d4e40"/>
-    <p:sldId xmlns:r="http://schemas.openxmlformats.org/officeDocument/2006/relationships" id="264" r:id="Rba318edd36f64e19"/>
-    <p:sldId xmlns:r="http://schemas.openxmlformats.org/officeDocument/2006/relationships" id="265" r:id="R9bf849b8f8d04b2e"/>
-    <p:sldId xmlns:r="http://schemas.openxmlformats.org/officeDocument/2006/relationships" id="266" r:id="R111c80653bd9489c"/>
+    <p:sldId xmlns:r="http://schemas.openxmlformats.org/officeDocument/2006/relationships" id="256" r:id="Rd4a9c32eb6c5483a"/>
+    <p:sldId xmlns:r="http://schemas.openxmlformats.org/officeDocument/2006/relationships" id="257" r:id="Rc0e02d7262cf456e"/>
+    <p:sldId xmlns:r="http://schemas.openxmlformats.org/officeDocument/2006/relationships" id="258" r:id="R871a42c024a54208"/>
+    <p:sldId xmlns:r="http://schemas.openxmlformats.org/officeDocument/2006/relationships" id="259" r:id="Re825e59c0a4f41bb"/>
+    <p:sldId xmlns:r="http://schemas.openxmlformats.org/officeDocument/2006/relationships" id="260" r:id="Ra5f46523676d47bb"/>
+    <p:sldId xmlns:r="http://schemas.openxmlformats.org/officeDocument/2006/relationships" id="261" r:id="R0ffd4ae33b65406e"/>
+    <p:sldId xmlns:r="http://schemas.openxmlformats.org/officeDocument/2006/relationships" id="262" r:id="Rc29593c8bd8d45f3"/>
+    <p:sldId xmlns:r="http://schemas.openxmlformats.org/officeDocument/2006/relationships" id="263" r:id="Rb6e3a270a3ab4c31"/>
+    <p:sldId xmlns:r="http://schemas.openxmlformats.org/officeDocument/2006/relationships" id="264" r:id="R3f65b850c74c4ba0"/>
+    <p:sldId xmlns:r="http://schemas.openxmlformats.org/officeDocument/2006/relationships" id="265" r:id="R02db9b1a30be4d7a"/>
+    <p:sldId xmlns:r="http://schemas.openxmlformats.org/officeDocument/2006/relationships" id="266" r:id="R86226cc3988f40a6"/>
   </p:sldIdLst>
   <p:sldSz cx="12192000" cy="6858000"/>
   <p:notesSz cx="6858000" cy="9144000"/>
@@ -665,6 +665,12 @@
               <a:t>Sources: README.md problem statement; app/db.py incident retrieval; reports/impact-study-protocol.md. The comparison states an expected benefit only. No measured time saving is claimed.</a:t>
             </a:r>
           </a:p>
+          <a:p xmlns:a="http://schemas.openxmlformats.org/drawingml/2006/main">
+            <a:br/>
+            <a:r>
+              <a:t>Source for outage-cost context: Uptime Institute Global Data Center Survey 2024, p. 19. https://datacenter.uptimeinstitute.com/rs/711-RIA-145/images/2024.GlobalDataCenterSurvey.Report.pdf?version=0. This is broader outage context, not a measured OpsIntel or pipeline-specific result.</a:t>
+            </a:r>
+          </a:p>
         </p:txBody>
       </p:sp>
       <p:sp>
@@ -3591,12 +3597,12 @@
   </p:cSld>
   <p:clrMap bg1="lt1" tx1="dk1" bg2="lt2" tx2="dk2" accent1="accent1" accent2="accent2" accent3="accent3" accent4="accent4" accent5="accent5" accent6="accent6" hlink="hlink" folHlink="folHlink"/>
   <p:sldLayoutIdLst>
-    <p:sldLayoutId xmlns:r="http://schemas.openxmlformats.org/officeDocument/2006/relationships" id="2147483649" r:id="Re1bb3563bf71489a"/>
-    <p:sldLayoutId xmlns:r="http://schemas.openxmlformats.org/officeDocument/2006/relationships" id="2147483650" r:id="R2f0c526677f24618"/>
-    <p:sldLayoutId xmlns:r="http://schemas.openxmlformats.org/officeDocument/2006/relationships" id="2147483651" r:id="R2d2a2279fd1d4e2b"/>
-    <p:sldLayoutId xmlns:r="http://schemas.openxmlformats.org/officeDocument/2006/relationships" id="2147483652" r:id="R87bf9fcfd8cd4dcb"/>
-    <p:sldLayoutId xmlns:r="http://schemas.openxmlformats.org/officeDocument/2006/relationships" id="2147483653" r:id="R204a3ff50dc74f6d"/>
-    <p:sldLayoutId xmlns:r="http://schemas.openxmlformats.org/officeDocument/2006/relationships" id="2147483654" r:id="R34c5595a15d44ea6"/>
+    <p:sldLayoutId xmlns:r="http://schemas.openxmlformats.org/officeDocument/2006/relationships" id="2147483649" r:id="Rf2a262df81294182"/>
+    <p:sldLayoutId xmlns:r="http://schemas.openxmlformats.org/officeDocument/2006/relationships" id="2147483650" r:id="R3aada7718f704b9a"/>
+    <p:sldLayoutId xmlns:r="http://schemas.openxmlformats.org/officeDocument/2006/relationships" id="2147483651" r:id="R9b30ffe8166644a2"/>
+    <p:sldLayoutId xmlns:r="http://schemas.openxmlformats.org/officeDocument/2006/relationships" id="2147483652" r:id="R770e806e79184e06"/>
+    <p:sldLayoutId xmlns:r="http://schemas.openxmlformats.org/officeDocument/2006/relationships" id="2147483653" r:id="R425859d45263436d"/>
+    <p:sldLayoutId xmlns:r="http://schemas.openxmlformats.org/officeDocument/2006/relationships" id="2147483654" r:id="R90279c80380343b0"/>
   </p:sldLayoutIdLst>
   <p:txStyles>
     <p:titleStyle>
@@ -4123,296 +4129,6 @@
 </a:theme>
 </file>
 
-<file path=ppt/slides/charts/chart1.xml><?xml version="1.0" encoding="utf-8"?>
-<c:chartSpace xmlns:c="http://schemas.openxmlformats.org/drawingml/2006/chart" xmlns:r="http://schemas.openxmlformats.org/officeDocument/2006/relationships">
-  <c:lang val="en-US"/>
-  <c:chart>
-    <c:plotArea>
-      <c:barChart>
-        <c:barDir val="col"/>
-        <c:grouping val="clustered"/>
-        <c:varyColors val="0"/>
-        <c:ser>
-          <c:idx val="0"/>
-          <c:order val="0"/>
-          <c:tx>
-            <c:v>Median latency</c:v>
-          </c:tx>
-          <c:spPr>
-            <a:solidFill xmlns:a="http://schemas.openxmlformats.org/drawingml/2006/main">
-              <a:srgbClr val="8C7CF0"/>
-            </a:solidFill>
-            <a:ln xmlns:a="http://schemas.openxmlformats.org/drawingml/2006/main" w="0">
-              <a:solidFill>
-                <a:srgbClr val="8C7CF0"/>
-              </a:solidFill>
-              <a:prstDash val="solid"/>
-            </a:ln>
-          </c:spPr>
-          <c:invertIfNegative val="0"/>
-          <c:cat>
-            <c:strRef>
-              <c:f>'Chart Data'!$A$2:$A$5</c:f>
-              <c:strCache>
-                <c:ptCount val="4"/>
-                <c:pt idx="0">
-                  <c:v>Exasol 1M</c:v>
-                </c:pt>
-                <c:pt idx="1">
-                  <c:v>DuckDB 1M</c:v>
-                </c:pt>
-                <c:pt idx="2">
-                  <c:v>Exasol 10M</c:v>
-                </c:pt>
-                <c:pt idx="3">
-                  <c:v>DuckDB 10M</c:v>
-                </c:pt>
-              </c:strCache>
-            </c:strRef>
-          </c:cat>
-          <c:val>
-            <c:numRef>
-              <c:f>'Chart Data'!$B$2:$B$5</c:f>
-              <c:numCache>
-                <c:formatCode>0.000</c:formatCode>
-                <c:ptCount val="4"/>
-                <c:pt idx="0">
-                  <c:v>437.118</c:v>
-                </c:pt>
-                <c:pt idx="1">
-                  <c:v>114.912</c:v>
-                </c:pt>
-                <c:pt idx="2">
-                  <c:v>4902.269</c:v>
-                </c:pt>
-                <c:pt idx="3">
-                  <c:v>1080.358</c:v>
-                </c:pt>
-              </c:numCache>
-            </c:numRef>
-          </c:val>
-        </c:ser>
-        <c:dLbls>
-          <c:delete val="0"/>
-          <c:numFmt formatCode="0.000" sourceLinked="0"/>
-          <c:txPr>
-            <a:bodyPr xmlns:a="http://schemas.openxmlformats.org/drawingml/2006/main" anchorCtr="1"/>
-            <a:lstStyle xmlns:a="http://schemas.openxmlformats.org/drawingml/2006/main"/>
-            <a:p xmlns:a="http://schemas.openxmlformats.org/drawingml/2006/main">
-              <a:pPr>
-                <a:defRPr sz="825" b="1">
-                  <a:solidFill>
-                    <a:srgbClr val="F0F3FA"/>
-                  </a:solidFill>
-                  <a:latin typeface="Arial"/>
-                  <a:ea typeface="Arial"/>
-                  <a:cs typeface="Arial"/>
-                </a:defRPr>
-              </a:pPr>
-            </a:p>
-          </c:txPr>
-          <c:dLblPos val="outEnd"/>
-          <c:showLegendKey val="0"/>
-          <c:showVal val="1"/>
-          <c:showCatName val="0"/>
-          <c:showSerName val="0"/>
-          <c:showPercent val="0"/>
-          <c:showBubbleSize val="0"/>
-          <c:showLeaderLines val="0"/>
-        </c:dLbls>
-        <c:gapWidth val="55"/>
-        <c:axId val="48650112"/>
-        <c:axId val="48672768"/>
-      </c:barChart>
-      <c:catAx>
-        <c:axId val="48650112"/>
-        <c:scaling>
-          <c:orientation val="minMax"/>
-        </c:scaling>
-        <c:delete val="0"/>
-        <c:axPos val="b"/>
-        <c:title>
-          <c:tx>
-            <c:rich>
-              <a:bodyPr xmlns:a="http://schemas.openxmlformats.org/drawingml/2006/main"/>
-              <a:lstStyle xmlns:a="http://schemas.openxmlformats.org/drawingml/2006/main"/>
-              <a:p xmlns:a="http://schemas.openxmlformats.org/drawingml/2006/main">
-                <a:r>
-                  <a:rPr sz="900" b="1">
-                    <a:solidFill>
-                      <a:srgbClr val="9AA5BD"/>
-                    </a:solidFill>
-                    <a:latin typeface="Arial"/>
-                    <a:ea typeface="Arial"/>
-                    <a:cs typeface="Arial"/>
-                  </a:rPr>
-                  <a:t>Engine and workload</a:t>
-                </a:r>
-              </a:p>
-            </c:rich>
-          </c:tx>
-          <c:overlay val="0"/>
-          <c:txPr>
-            <a:bodyPr xmlns:a="http://schemas.openxmlformats.org/drawingml/2006/main" anchorCtr="1"/>
-            <a:lstStyle xmlns:a="http://schemas.openxmlformats.org/drawingml/2006/main"/>
-            <a:p xmlns:a="http://schemas.openxmlformats.org/drawingml/2006/main">
-              <a:pPr>
-                <a:defRPr sz="900" b="1">
-                  <a:solidFill>
-                    <a:srgbClr val="9AA5BD"/>
-                  </a:solidFill>
-                  <a:latin typeface="Arial"/>
-                  <a:ea typeface="Arial"/>
-                  <a:cs typeface="Arial"/>
-                </a:defRPr>
-              </a:pPr>
-            </a:p>
-          </c:txPr>
-        </c:title>
-        <c:numFmt formatCode="General"/>
-        <c:majorTickMark val="none"/>
-        <c:minorTickMark val="none"/>
-        <c:spPr>
-          <a:ln xmlns:a="http://schemas.openxmlformats.org/drawingml/2006/main" w="9525">
-            <a:solidFill>
-              <a:srgbClr val="59657D"/>
-            </a:solidFill>
-            <a:prstDash val="solid"/>
-          </a:ln>
-        </c:spPr>
-        <c:txPr>
-          <a:bodyPr xmlns:a="http://schemas.openxmlformats.org/drawingml/2006/main" anchorCtr="1"/>
-          <a:lstStyle xmlns:a="http://schemas.openxmlformats.org/drawingml/2006/main"/>
-          <a:p xmlns:a="http://schemas.openxmlformats.org/drawingml/2006/main">
-            <a:pPr>
-              <a:defRPr sz="825">
-                <a:solidFill>
-                  <a:srgbClr val="9AA5BD"/>
-                </a:solidFill>
-                <a:latin typeface="Arial"/>
-                <a:ea typeface="Arial"/>
-                <a:cs typeface="Arial"/>
-              </a:defRPr>
-            </a:pPr>
-          </a:p>
-        </c:txPr>
-        <c:crossAx val="48672768"/>
-      </c:catAx>
-      <c:valAx>
-        <c:axId val="48672768"/>
-        <c:scaling>
-          <c:orientation val="minMax"/>
-          <c:max val="5500"/>
-          <c:min val="0"/>
-        </c:scaling>
-        <c:delete val="0"/>
-        <c:axPos val="l"/>
-        <c:majorGridlines>
-          <c:spPr>
-            <a:ln xmlns:a="http://schemas.openxmlformats.org/drawingml/2006/main" w="9525">
-              <a:solidFill>
-                <a:srgbClr val="334058"/>
-              </a:solidFill>
-              <a:prstDash val="solid"/>
-            </a:ln>
-          </c:spPr>
-        </c:majorGridlines>
-        <c:title>
-          <c:tx>
-            <c:rich>
-              <a:bodyPr xmlns:a="http://schemas.openxmlformats.org/drawingml/2006/main"/>
-              <a:lstStyle xmlns:a="http://schemas.openxmlformats.org/drawingml/2006/main"/>
-              <a:p xmlns:a="http://schemas.openxmlformats.org/drawingml/2006/main">
-                <a:r>
-                  <a:rPr sz="900" b="1">
-                    <a:solidFill>
-                      <a:srgbClr val="9AA5BD"/>
-                    </a:solidFill>
-                    <a:latin typeface="Arial"/>
-                    <a:ea typeface="Arial"/>
-                    <a:cs typeface="Arial"/>
-                  </a:rPr>
-                  <a:t>Median latency (ms)</a:t>
-                </a:r>
-              </a:p>
-            </c:rich>
-          </c:tx>
-          <c:overlay val="0"/>
-          <c:txPr>
-            <a:bodyPr xmlns:a="http://schemas.openxmlformats.org/drawingml/2006/main" anchorCtr="1"/>
-            <a:lstStyle xmlns:a="http://schemas.openxmlformats.org/drawingml/2006/main"/>
-            <a:p xmlns:a="http://schemas.openxmlformats.org/drawingml/2006/main">
-              <a:pPr>
-                <a:defRPr sz="900" b="1">
-                  <a:solidFill>
-                    <a:srgbClr val="9AA5BD"/>
-                  </a:solidFill>
-                  <a:latin typeface="Arial"/>
-                  <a:ea typeface="Arial"/>
-                  <a:cs typeface="Arial"/>
-                </a:defRPr>
-              </a:pPr>
-            </a:p>
-          </c:txPr>
-        </c:title>
-        <c:numFmt formatCode="0"/>
-        <c:majorTickMark val="none"/>
-        <c:minorTickMark val="none"/>
-        <c:spPr>
-          <a:ln xmlns:a="http://schemas.openxmlformats.org/drawingml/2006/main" w="9525">
-            <a:solidFill>
-              <a:srgbClr val="59657D"/>
-            </a:solidFill>
-            <a:prstDash val="solid"/>
-          </a:ln>
-        </c:spPr>
-        <c:txPr>
-          <a:bodyPr xmlns:a="http://schemas.openxmlformats.org/drawingml/2006/main" anchorCtr="1"/>
-          <a:lstStyle xmlns:a="http://schemas.openxmlformats.org/drawingml/2006/main"/>
-          <a:p xmlns:a="http://schemas.openxmlformats.org/drawingml/2006/main">
-            <a:pPr>
-              <a:defRPr sz="825">
-                <a:solidFill>
-                  <a:srgbClr val="9AA5BD"/>
-                </a:solidFill>
-                <a:latin typeface="Arial"/>
-                <a:ea typeface="Arial"/>
-                <a:cs typeface="Arial"/>
-              </a:defRPr>
-            </a:pPr>
-          </a:p>
-        </c:txPr>
-        <c:crossAx val="48650112"/>
-        <c:crossBetween val="between"/>
-        <c:majorUnit val="1000"/>
-      </c:valAx>
-      <c:spPr>
-        <a:solidFill xmlns:a="http://schemas.openxmlformats.org/drawingml/2006/main">
-          <a:srgbClr val="080D18"/>
-        </a:solidFill>
-        <a:ln xmlns:a="http://schemas.openxmlformats.org/drawingml/2006/main" w="0">
-          <a:noFill/>
-          <a:prstDash val="solid"/>
-        </a:ln>
-      </c:spPr>
-    </c:plotArea>
-    <c:plotVisOnly val="1"/>
-  </c:chart>
-  <c:spPr>
-    <a:solidFill xmlns:a="http://schemas.openxmlformats.org/drawingml/2006/main">
-      <a:srgbClr val="080D18"/>
-    </a:solidFill>
-    <a:ln xmlns:a="http://schemas.openxmlformats.org/drawingml/2006/main" w="0">
-      <a:noFill/>
-      <a:prstDash val="solid"/>
-    </a:ln>
-  </c:spPr>
-  <c:externalData r:id="rIdChartSnapshot1">
-    <c:autoUpdate val="0"/>
-  </c:externalData>
-</c:chartSpace>
-</file>
-
 <file path=ppt/slides/slide1.xml><?xml version="1.0" encoding="utf-8"?>
 <p:sld xmlns:p="http://schemas.openxmlformats.org/presentationml/2006/main">
   <p:cSld>
@@ -5990,7 +5706,7 @@
                 <a:ea typeface="Arial"/>
                 <a:cs typeface="Arial"/>
               </a:rPr>
-              <a:t>What is proven, and what must be proven next</a:t>
+              <a:t>Evidence status and next validation steps</a:t>
             </a:r>
           </a:p>
         </p:txBody>
@@ -6689,7 +6405,7 @@
                 <a:ea typeface="Arial"/>
                 <a:cs typeface="Arial"/>
               </a:rPr>
-              <a:t>03  133 automated tests</a:t>
+              <a:t>03  137 automated tests</a:t>
             </a:r>
           </a:p>
         </p:txBody>
@@ -8755,7 +8471,7 @@
                 <a:ea typeface="Arial"/>
                 <a:cs typeface="Arial"/>
               </a:rPr>
-              <a:t>Clean-clone checks passed. Exasol workflow, external cases and participant trials remain pending.</a:t>
+              <a:t>Clean-clone checks passed. Exasol workflow, external review and participant trials remain pending.</a:t>
             </a:r>
           </a:p>
         </p:txBody>
@@ -12482,8 +12198,8 @@
         </p:nvSpPr>
         <p:spPr>
           <a:xfrm xmlns:a="http://schemas.openxmlformats.org/drawingml/2006/main">
-            <a:off x="6191250" y="5543550"/>
-            <a:ext cx="4762500" cy="533400"/>
+            <a:off x="6191250" y="5429250"/>
+            <a:ext cx="5048250" cy="723900"/>
           </a:xfrm>
           <a:prstGeom xmlns:a="http://schemas.openxmlformats.org/drawingml/2006/main" prst="rect">
             <a:avLst/>
@@ -12495,10 +12211,10 @@
           </a:ln>
         </p:spPr>
         <p:txBody>
-          <a:bodyPr xmlns:a="http://schemas.openxmlformats.org/drawingml/2006/main" anchor="ctr"/>
+          <a:bodyPr xmlns:a="http://schemas.openxmlformats.org/drawingml/2006/main" lIns="0" tIns="0" rIns="0" bIns="0" anchor="ctr"/>
           <a:lstStyle xmlns:a="http://schemas.openxmlformats.org/drawingml/2006/main">
             <a:defPPr algn="l">
-              <a:defRPr sz="1200" b="1">
+              <a:defRPr sz="1088" b="1">
                 <a:solidFill>
                   <a:srgbClr val="E8B76E"/>
                 </a:solidFill>
@@ -12609,8 +12325,11 @@
           </a:lstStyle>
           <a:p xmlns:a="http://schemas.openxmlformats.org/drawingml/2006/main">
             <a:pPr algn="l">
-              <a:buNone/>
-              <a:defRPr sz="1200" b="1">
+              <a:lnSpc>
+                <a:spcPct val="108000"/>
+              </a:lnSpc>
+              <a:buNone/>
+              <a:defRPr sz="1088" b="1">
                 <a:solidFill>
                   <a:srgbClr val="E8B76E"/>
                 </a:solidFill>
@@ -12620,7 +12339,7 @@
               </a:defRPr>
             </a:pPr>
             <a:r>
-              <a:rPr sz="1200" b="1">
+              <a:rPr sz="1088" b="1">
                 <a:solidFill>
                   <a:srgbClr val="E8B76E"/>
                 </a:solidFill>
@@ -12628,7 +12347,7 @@
                 <a:ea typeface="Arial"/>
                 <a:cs typeface="Arial"/>
               </a:rPr>
-              <a:t>No time saving is claimed yet. The prepared study measures investigation time and evidence selection.</a:t>
+              <a:t>54% of survey respondents reported a significant outage costing more than $100k (Uptime Institute, 2024). OpsIntel time saving remains unmeasured.</a:t>
             </a:r>
           </a:p>
         </p:txBody>
@@ -17041,7 +16760,7 @@
           <p:cNvPr id="3" name="">
             <a:extLst xmlns:a="http://schemas.openxmlformats.org/drawingml/2006/main">
               <a:ext uri="{FF2B5EF4-FFF2-40B4-BE49-F238E27FC236}">
-                <a16:creationId xmlns:a16="http://schemas.microsoft.com/office/drawing/2014/main" id="{A2B4326C-78D9-47A1-9134-02286CD54CF4}"/>
+                <a16:creationId xmlns:a16="http://schemas.microsoft.com/office/drawing/2014/main" id="{9BAFDCB4-D601-4E01-B4DD-6D37C3EFF375}"/>
               </a:ext>
             </a:extLst>
           </p:cNvPr>
@@ -17051,7 +16770,7 @@
           <p:nvPr/>
         </p:nvPicPr>
         <p:blipFill>
-          <a:blip xmlns:r="http://schemas.openxmlformats.org/officeDocument/2006/relationships" xmlns:a="http://schemas.openxmlformats.org/drawingml/2006/main" r:embed="R13ca1741e143418a"/>
+          <a:blip xmlns:r="http://schemas.openxmlformats.org/officeDocument/2006/relationships" xmlns:a="http://schemas.openxmlformats.org/drawingml/2006/main" r:embed="R17c2a32ab3794937"/>
           <a:srcRect xmlns:a="http://schemas.openxmlformats.org/drawingml/2006/main" l="13" t="0" r="13" b="0"/>
           <a:stretch xmlns:a="http://schemas.openxmlformats.org/drawingml/2006/main">
             <a:fillRect l="0" t="0" r="0" b="0"/>
@@ -18709,7 +18428,7 @@
           <p:cNvPr id="3" name="">
             <a:extLst xmlns:a="http://schemas.openxmlformats.org/drawingml/2006/main">
               <a:ext uri="{FF2B5EF4-FFF2-40B4-BE49-F238E27FC236}">
-                <a16:creationId xmlns:a16="http://schemas.microsoft.com/office/drawing/2014/main" id="{DC571ECD-0728-43C5-AD1A-4F8BFEC307E0}"/>
+                <a16:creationId xmlns:a16="http://schemas.microsoft.com/office/drawing/2014/main" id="{13762312-5258-4D77-92FE-5A86C57A77DD}"/>
               </a:ext>
             </a:extLst>
           </p:cNvPr>
@@ -18719,7 +18438,7 @@
           <p:nvPr/>
         </p:nvPicPr>
         <p:blipFill>
-          <a:blip xmlns:r="http://schemas.openxmlformats.org/officeDocument/2006/relationships" xmlns:a="http://schemas.openxmlformats.org/drawingml/2006/main" r:embed="R5a3e7f529e2f415d"/>
+          <a:blip xmlns:r="http://schemas.openxmlformats.org/officeDocument/2006/relationships" xmlns:a="http://schemas.openxmlformats.org/drawingml/2006/main" r:embed="R48f472e4c02a48a0"/>
           <a:srcRect xmlns:a="http://schemas.openxmlformats.org/drawingml/2006/main" l="15" t="0" r="15" b="0"/>
           <a:stretch xmlns:a="http://schemas.openxmlformats.org/drawingml/2006/main">
             <a:fillRect l="0" t="0" r="0" b="0"/>
@@ -23559,7 +23278,7 @@
                 <a:ea typeface="Arial"/>
                 <a:cs typeface="Arial"/>
               </a:rPr>
-              <a:t>QUERY USED BY GET /analytics/trend</a:t>
+              <a:t>LIVE QUERY USED BY /analytics/trend</a:t>
             </a:r>
           </a:p>
         </p:txBody>
@@ -24020,7 +23739,7 @@
                 <a:ea typeface="Arial"/>
                 <a:cs typeface="Arial"/>
               </a:rPr>
-              <a:t>CURRENT SEED · LIVE EXASOL OUTPUT</a:t>
+              <a:t>VERIFIED EXASOL OUTPUT</a:t>
             </a:r>
           </a:p>
         </p:txBody>
@@ -24187,7 +23906,7 @@
                 <a:ea typeface="Arial"/>
                 <a:cs typeface="Arial"/>
               </a:rPr>
-              <a:t>12 runs  ·  11 incidents  ·  64.1% average completeness</a:t>
+              <a:t>12 runs, 11 incidents, 64.1% average completeness</a:t>
             </a:r>
           </a:p>
         </p:txBody>
@@ -24354,7 +24073,7 @@
                 <a:ea typeface="Arial"/>
                 <a:cs typeface="Arial"/>
               </a:rPr>
-              <a:t>GET /analytics/trend reads this view directly. The current seed output was verified against Exasol Personal.</a:t>
+              <a:t>The API reads this view directly. Verified against Exasol Personal.</a:t>
             </a:r>
           </a:p>
         </p:txBody>
@@ -24550,7 +24269,7 @@
                 <a:ea typeface="Arial"/>
                 <a:cs typeface="Arial"/>
               </a:rPr>
-              <a:t>EXASOL FINDS THE SHARED FAILURE</a:t>
+              <a:t>TEMPORAL DEPENDENCY CORRELATION</a:t>
             </a:r>
           </a:p>
         </p:txBody>
@@ -27752,7 +27471,7 @@
                 <a:ea typeface="Arial"/>
                 <a:cs typeface="Arial"/>
               </a:rPr>
-              <a:t>SAME QUERY, MEASURED HONESTLY</a:t>
+              <a:t>LOCAL SINGLE-USER BENCHMARK</a:t>
             </a:r>
           </a:p>
         </p:txBody>
@@ -27919,7 +27638,7 @@
                 <a:ea typeface="Arial"/>
                 <a:cs typeface="Arial"/>
               </a:rPr>
-              <a:t>DuckDB was 4.5× faster at 10M rows in this local single-user test</a:t>
+              <a:t>At 10M rows, DuckDB was 4.5× faster</a:t>
             </a:r>
           </a:p>
         </p:txBody>
@@ -27940,8 +27659,8 @@
         </p:nvSpPr>
         <p:spPr>
           <a:xfrm xmlns:a="http://schemas.openxmlformats.org/drawingml/2006/main">
-            <a:off x="7810500" y="4991100"/>
-            <a:ext cx="2190750" cy="552450"/>
+            <a:off x="7810500" y="4953000"/>
+            <a:ext cx="1809750" cy="228600"/>
           </a:xfrm>
           <a:prstGeom xmlns:a="http://schemas.openxmlformats.org/drawingml/2006/main" prst="rect">
             <a:avLst/>
@@ -27953,12 +27672,12 @@
           </a:ln>
         </p:spPr>
         <p:txBody>
-          <a:bodyPr xmlns:a="http://schemas.openxmlformats.org/drawingml/2006/main" anchor="ctr"/>
+          <a:bodyPr xmlns:a="http://schemas.openxmlformats.org/drawingml/2006/main" lIns="0" tIns="0" rIns="0" bIns="0" anchor="ctr"/>
           <a:lstStyle xmlns:a="http://schemas.openxmlformats.org/drawingml/2006/main">
             <a:defPPr algn="l">
-              <a:defRPr sz="3225" b="1">
-                <a:solidFill>
-                  <a:srgbClr val="61D9F7"/>
+              <a:defRPr sz="1050" b="1">
+                <a:solidFill>
+                  <a:srgbClr val="58D9F7"/>
                 </a:solidFill>
                 <a:latin typeface="Arial"/>
                 <a:ea typeface="Arial"/>
@@ -28067,10 +27786,13 @@
           </a:lstStyle>
           <a:p xmlns:a="http://schemas.openxmlformats.org/drawingml/2006/main">
             <a:pPr algn="l">
-              <a:buNone/>
-              <a:defRPr sz="3225" b="1">
-                <a:solidFill>
-                  <a:srgbClr val="61D9F7"/>
+              <a:lnSpc>
+                <a:spcPct val="100000"/>
+              </a:lnSpc>
+              <a:buNone/>
+              <a:defRPr sz="1050" b="1">
+                <a:solidFill>
+                  <a:srgbClr val="58D9F7"/>
                 </a:solidFill>
                 <a:latin typeface="Arial"/>
                 <a:ea typeface="Arial"/>
@@ -28078,15 +27800,15 @@
               </a:defRPr>
             </a:pPr>
             <a:r>
-              <a:rPr sz="3225" b="1">
-                <a:solidFill>
-                  <a:srgbClr val="61D9F7"/>
+              <a:rPr sz="1050" b="1">
+                <a:solidFill>
+                  <a:srgbClr val="58D9F7"/>
                 </a:solidFill>
                 <a:latin typeface="Arial"/>
                 <a:ea typeface="Arial"/>
                 <a:cs typeface="Arial"/>
               </a:rPr>
-              <a:t>CACHE OFF</a:t>
+              <a:t>QUERY CACHE</a:t>
             </a:r>
           </a:p>
         </p:txBody>
@@ -28107,8 +27829,8 @@
         </p:nvSpPr>
         <p:spPr>
           <a:xfrm xmlns:a="http://schemas.openxmlformats.org/drawingml/2006/main">
-            <a:off x="7810500" y="5553075"/>
-            <a:ext cx="2190750" cy="419100"/>
+            <a:off x="7810500" y="5219700"/>
+            <a:ext cx="1809750" cy="400050"/>
           </a:xfrm>
           <a:prstGeom xmlns:a="http://schemas.openxmlformats.org/drawingml/2006/main" prst="rect">
             <a:avLst/>
@@ -28120,12 +27842,12 @@
           </a:ln>
         </p:spPr>
         <p:txBody>
-          <a:bodyPr xmlns:a="http://schemas.openxmlformats.org/drawingml/2006/main" anchor="ctr"/>
+          <a:bodyPr xmlns:a="http://schemas.openxmlformats.org/drawingml/2006/main" lIns="0" tIns="0" rIns="0" bIns="0" anchor="ctr"/>
           <a:lstStyle xmlns:a="http://schemas.openxmlformats.org/drawingml/2006/main">
             <a:defPPr algn="l">
-              <a:defRPr sz="1275" b="0">
-                <a:solidFill>
-                  <a:srgbClr val="9AA5BD"/>
+              <a:defRPr sz="2400" b="1">
+                <a:solidFill>
+                  <a:srgbClr val="58D9F7"/>
                 </a:solidFill>
                 <a:latin typeface="Arial"/>
                 <a:ea typeface="Arial"/>
@@ -28234,10 +27956,13 @@
           </a:lstStyle>
           <a:p xmlns:a="http://schemas.openxmlformats.org/drawingml/2006/main">
             <a:pPr algn="l">
-              <a:buNone/>
-              <a:defRPr sz="1275" b="0">
-                <a:solidFill>
-                  <a:srgbClr val="9AA5BD"/>
+              <a:lnSpc>
+                <a:spcPct val="95000"/>
+              </a:lnSpc>
+              <a:buNone/>
+              <a:defRPr sz="2400" b="1">
+                <a:solidFill>
+                  <a:srgbClr val="58D9F7"/>
                 </a:solidFill>
                 <a:latin typeface="Arial"/>
                 <a:ea typeface="Arial"/>
@@ -28245,15 +27970,15 @@
               </a:defRPr>
             </a:pPr>
             <a:r>
-              <a:rPr sz="1275" b="0">
-                <a:solidFill>
-                  <a:srgbClr val="9AA5BD"/>
+              <a:rPr sz="2400" b="1">
+                <a:solidFill>
+                  <a:srgbClr val="58D9F7"/>
                 </a:solidFill>
                 <a:latin typeface="Arial"/>
                 <a:ea typeface="Arial"/>
                 <a:cs typeface="Arial"/>
               </a:rPr>
-              <a:t>Exasol comparison</a:t>
+              <a:t>OFF</a:t>
             </a:r>
           </a:p>
         </p:txBody>
@@ -28274,8 +27999,8 @@
         </p:nvSpPr>
         <p:spPr>
           <a:xfrm xmlns:a="http://schemas.openxmlformats.org/drawingml/2006/main">
-            <a:off x="9620250" y="4991100"/>
-            <a:ext cx="2190750" cy="552450"/>
+            <a:off x="9886950" y="4953000"/>
+            <a:ext cx="1657350" cy="228600"/>
           </a:xfrm>
           <a:prstGeom xmlns:a="http://schemas.openxmlformats.org/drawingml/2006/main" prst="rect">
             <a:avLst/>
@@ -28287,12 +28012,12 @@
           </a:ln>
         </p:spPr>
         <p:txBody>
-          <a:bodyPr xmlns:a="http://schemas.openxmlformats.org/drawingml/2006/main" anchor="ctr"/>
+          <a:bodyPr xmlns:a="http://schemas.openxmlformats.org/drawingml/2006/main" lIns="0" tIns="0" rIns="0" bIns="0" anchor="ctr"/>
           <a:lstStyle xmlns:a="http://schemas.openxmlformats.org/drawingml/2006/main">
             <a:defPPr algn="l">
-              <a:defRPr sz="3225" b="1">
-                <a:solidFill>
-                  <a:srgbClr val="58DDB0"/>
+              <a:defRPr sz="1050" b="1">
+                <a:solidFill>
+                  <a:srgbClr val="50DEB5"/>
                 </a:solidFill>
                 <a:latin typeface="Arial"/>
                 <a:ea typeface="Arial"/>
@@ -28401,10 +28126,13 @@
           </a:lstStyle>
           <a:p xmlns:a="http://schemas.openxmlformats.org/drawingml/2006/main">
             <a:pPr algn="l">
-              <a:buNone/>
-              <a:defRPr sz="3225" b="1">
-                <a:solidFill>
-                  <a:srgbClr val="58DDB0"/>
+              <a:lnSpc>
+                <a:spcPct val="100000"/>
+              </a:lnSpc>
+              <a:buNone/>
+              <a:defRPr sz="1050" b="1">
+                <a:solidFill>
+                  <a:srgbClr val="50DEB5"/>
                 </a:solidFill>
                 <a:latin typeface="Arial"/>
                 <a:ea typeface="Arial"/>
@@ -28412,15 +28140,15 @@
               </a:defRPr>
             </a:pPr>
             <a:r>
-              <a:rPr sz="3225" b="1">
-                <a:solidFill>
-                  <a:srgbClr val="58DDB0"/>
+              <a:rPr sz="1050" b="1">
+                <a:solidFill>
+                  <a:srgbClr val="50DEB5"/>
                 </a:solidFill>
                 <a:latin typeface="Arial"/>
                 <a:ea typeface="Arial"/>
                 <a:cs typeface="Arial"/>
               </a:rPr>
-              <a:t>7 RUNS</a:t>
+              <a:t>REPETITIONS</a:t>
             </a:r>
           </a:p>
         </p:txBody>
@@ -28441,8 +28169,8 @@
         </p:nvSpPr>
         <p:spPr>
           <a:xfrm xmlns:a="http://schemas.openxmlformats.org/drawingml/2006/main">
-            <a:off x="9620250" y="5553075"/>
-            <a:ext cx="2190750" cy="419100"/>
+            <a:off x="9886950" y="5219700"/>
+            <a:ext cx="1657350" cy="400050"/>
           </a:xfrm>
           <a:prstGeom xmlns:a="http://schemas.openxmlformats.org/drawingml/2006/main" prst="rect">
             <a:avLst/>
@@ -28454,12 +28182,12 @@
           </a:ln>
         </p:spPr>
         <p:txBody>
-          <a:bodyPr xmlns:a="http://schemas.openxmlformats.org/drawingml/2006/main" anchor="ctr"/>
+          <a:bodyPr xmlns:a="http://schemas.openxmlformats.org/drawingml/2006/main" lIns="0" tIns="0" rIns="0" bIns="0" anchor="ctr"/>
           <a:lstStyle xmlns:a="http://schemas.openxmlformats.org/drawingml/2006/main">
             <a:defPPr algn="l">
-              <a:defRPr sz="1275" b="0">
-                <a:solidFill>
-                  <a:srgbClr val="9AA5BD"/>
+              <a:defRPr sz="2250" b="1">
+                <a:solidFill>
+                  <a:srgbClr val="50DEB5"/>
                 </a:solidFill>
                 <a:latin typeface="Arial"/>
                 <a:ea typeface="Arial"/>
@@ -28568,10 +28296,13 @@
           </a:lstStyle>
           <a:p xmlns:a="http://schemas.openxmlformats.org/drawingml/2006/main">
             <a:pPr algn="l">
-              <a:buNone/>
-              <a:defRPr sz="1275" b="0">
-                <a:solidFill>
-                  <a:srgbClr val="9AA5BD"/>
+              <a:lnSpc>
+                <a:spcPct val="95000"/>
+              </a:lnSpc>
+              <a:buNone/>
+              <a:defRPr sz="2250" b="1">
+                <a:solidFill>
+                  <a:srgbClr val="50DEB5"/>
                 </a:solidFill>
                 <a:latin typeface="Arial"/>
                 <a:ea typeface="Arial"/>
@@ -28579,15 +28310,15 @@
               </a:defRPr>
             </a:pPr>
             <a:r>
-              <a:rPr sz="1275" b="0">
-                <a:solidFill>
-                  <a:srgbClr val="9AA5BD"/>
+              <a:rPr sz="2250" b="1">
+                <a:solidFill>
+                  <a:srgbClr val="50DEB5"/>
                 </a:solidFill>
                 <a:latin typeface="Arial"/>
                 <a:ea typeface="Arial"/>
                 <a:cs typeface="Arial"/>
               </a:rPr>
-              <a:t>per engine</a:t>
+              <a:t>7 RUNS</a:t>
             </a:r>
           </a:p>
         </p:txBody>
@@ -28754,7 +28485,7 @@
                 <a:ea typeface="Arial"/>
                 <a:cs typeface="Arial"/>
               </a:rPr>
-              <a:t>133 / 133</a:t>
+              <a:t>137 / 137</a:t>
             </a:r>
           </a:p>
         </p:txBody>
@@ -29088,7 +28819,7 @@
                 <a:ea typeface="Arial"/>
                 <a:cs typeface="Arial"/>
               </a:rPr>
-              <a:t>27 / 27</a:t>
+              <a:t>6 / 9</a:t>
             </a:r>
           </a:p>
         </p:txBody>
@@ -29255,7 +28986,31 @@
                 <a:ea typeface="Arial"/>
                 <a:cs typeface="Arial"/>
               </a:rPr>
-              <a:t>project-authored holdout</a:t>
+              <a:t>licensed public corpus</a:t>
+            </a:r>
+          </a:p>
+          <a:p xmlns:a="http://schemas.openxmlformats.org/drawingml/2006/main">
+            <a:pPr algn="l">
+              <a:buNone/>
+              <a:defRPr sz="1350" b="0">
+                <a:solidFill>
+                  <a:srgbClr val="9AA5BD"/>
+                </a:solidFill>
+                <a:latin typeface="Arial"/>
+                <a:ea typeface="Arial"/>
+                <a:cs typeface="Arial"/>
+              </a:defRPr>
+            </a:pPr>
+            <a:r>
+              <a:rPr sz="1350" b="0">
+                <a:solidFill>
+                  <a:srgbClr val="9AA5BD"/>
+                </a:solidFill>
+                <a:latin typeface="Arial"/>
+                <a:ea typeface="Arial"/>
+                <a:cs typeface="Arial"/>
+              </a:rPr>
+              <a:t>project holdout: 27 / 27</a:t>
             </a:r>
           </a:p>
         </p:txBody>
@@ -29792,28 +29547,201 @@
           </a:p>
         </p:txBody>
       </p:sp>
-      <p:graphicFrame>
-        <p:nvGraphicFramePr>
-          <p:cNvPr id="17" name="Chart">
+      <p:pic>
+        <p:nvPicPr>
+          <p:cNvPr id="17" name="">
             <a:extLst xmlns:a="http://schemas.openxmlformats.org/drawingml/2006/main">
               <a:ext uri="{FF2B5EF4-FFF2-40B4-BE49-F238E27FC236}">
-                <a16:creationId xmlns:a16="http://schemas.microsoft.com/office/drawing/2014/main" id="{3A6CBD3F-F405-4D76-9897-F310FCBCD562}"/>
+                <a16:creationId xmlns:a16="http://schemas.microsoft.com/office/drawing/2014/main" id="{006AB33E-496E-498A-96A3-4E0E44CA565A}"/>
               </a:ext>
             </a:extLst>
           </p:cNvPr>
-          <p:cNvGraphicFramePr/>
+          <p:cNvPicPr>
+            <a:picLocks xmlns:a="http://schemas.openxmlformats.org/drawingml/2006/main" noChangeAspect="1"/>
+          </p:cNvPicPr>
           <p:nvPr/>
-        </p:nvGraphicFramePr>
-        <p:xfrm>
-          <a:off xmlns:a="http://schemas.openxmlformats.org/drawingml/2006/main" x="685800" y="2143125"/>
-          <a:ext xmlns:a="http://schemas.openxmlformats.org/drawingml/2006/main" cx="6667500" cy="2857500"/>
-        </p:xfrm>
-        <a:graphic xmlns:a="http://schemas.openxmlformats.org/drawingml/2006/main">
-          <a:graphicData uri="http://schemas.openxmlformats.org/drawingml/2006/chart">
-            <c:chart xmlns:r="http://schemas.openxmlformats.org/officeDocument/2006/relationships" xmlns:c="http://schemas.openxmlformats.org/drawingml/2006/chart" r:id="R8449f274b1614c58"/>
-          </a:graphicData>
-        </a:graphic>
-      </p:graphicFrame>
+        </p:nvPicPr>
+        <p:blipFill>
+          <a:blip xmlns:r="http://schemas.openxmlformats.org/officeDocument/2006/relationships" xmlns:a="http://schemas.openxmlformats.org/drawingml/2006/main" r:embed="R488213a2050549a2"/>
+          <a:stretch xmlns:a="http://schemas.openxmlformats.org/drawingml/2006/main"/>
+        </p:blipFill>
+        <p:spPr>
+          <a:xfrm xmlns:a="http://schemas.openxmlformats.org/drawingml/2006/main">
+            <a:off x="685800" y="2143125"/>
+            <a:ext cx="6667500" cy="2857500"/>
+          </a:xfrm>
+          <a:prstGeom xmlns:a="http://schemas.openxmlformats.org/drawingml/2006/main" prst="rect">
+            <a:avLst/>
+          </a:prstGeom>
+        </p:spPr>
+      </p:pic>
+      <p:sp>
+        <p:nvSpPr>
+          <p:cNvPr id="18" name="">
+            <a:extLst xmlns:a="http://schemas.openxmlformats.org/drawingml/2006/main">
+              <a:ext uri="{FF2B5EF4-FFF2-40B4-BE49-F238E27FC236}">
+                <a16:creationId xmlns:a16="http://schemas.microsoft.com/office/drawing/2014/main" id="{E2725AB0-C7A7-4454-9CBE-DCC521590D6F}"/>
+              </a:ext>
+            </a:extLst>
+          </p:cNvPr>
+          <p:cNvSpPr>
+            <a:spLocks xmlns:a="http://schemas.openxmlformats.org/drawingml/2006/main" noGrp="1"/>
+          </p:cNvSpPr>
+          <p:nvPr/>
+        </p:nvSpPr>
+        <p:spPr>
+          <a:xfrm xmlns:a="http://schemas.openxmlformats.org/drawingml/2006/main">
+            <a:off x="685800" y="5010150"/>
+            <a:ext cx="6667500" cy="190500"/>
+          </a:xfrm>
+          <a:prstGeom xmlns:a="http://schemas.openxmlformats.org/drawingml/2006/main" prst="rect">
+            <a:avLst/>
+          </a:prstGeom>
+          <a:noFill xmlns:a="http://schemas.openxmlformats.org/drawingml/2006/main"/>
+          <a:ln xmlns:a="http://schemas.openxmlformats.org/drawingml/2006/main" w="0">
+            <a:noFill/>
+            <a:prstDash val="solid"/>
+          </a:ln>
+        </p:spPr>
+        <p:txBody>
+          <a:bodyPr xmlns:a="http://schemas.openxmlformats.org/drawingml/2006/main"/>
+          <a:lstStyle xmlns:a="http://schemas.openxmlformats.org/drawingml/2006/main">
+            <a:defPPr>
+              <a:defRPr sz="825">
+                <a:solidFill>
+                  <a:srgbClr val="6F7B95"/>
+                </a:solidFill>
+                <a:latin typeface="Arial"/>
+                <a:ea typeface="Arial"/>
+                <a:cs typeface="Arial"/>
+              </a:defRPr>
+            </a:defPPr>
+            <a:lvl1pPr>
+              <a:buNone/>
+              <a:defRPr sz="825">
+                <a:solidFill>
+                  <a:srgbClr val="6F7B95"/>
+                </a:solidFill>
+                <a:latin typeface="Arial"/>
+                <a:ea typeface="Arial"/>
+                <a:cs typeface="Arial"/>
+              </a:defRPr>
+            </a:lvl1pPr>
+            <a:lvl2pPr>
+              <a:buNone/>
+              <a:defRPr sz="825">
+                <a:solidFill>
+                  <a:srgbClr val="6F7B95"/>
+                </a:solidFill>
+                <a:latin typeface="Arial"/>
+                <a:ea typeface="Arial"/>
+                <a:cs typeface="Arial"/>
+              </a:defRPr>
+            </a:lvl2pPr>
+            <a:lvl3pPr>
+              <a:buNone/>
+              <a:defRPr sz="825">
+                <a:solidFill>
+                  <a:srgbClr val="6F7B95"/>
+                </a:solidFill>
+                <a:latin typeface="Arial"/>
+                <a:ea typeface="Arial"/>
+                <a:cs typeface="Arial"/>
+              </a:defRPr>
+            </a:lvl3pPr>
+            <a:lvl4pPr>
+              <a:buNone/>
+              <a:defRPr sz="825">
+                <a:solidFill>
+                  <a:srgbClr val="6F7B95"/>
+                </a:solidFill>
+                <a:latin typeface="Arial"/>
+                <a:ea typeface="Arial"/>
+                <a:cs typeface="Arial"/>
+              </a:defRPr>
+            </a:lvl4pPr>
+            <a:lvl5pPr>
+              <a:buNone/>
+              <a:defRPr sz="825">
+                <a:solidFill>
+                  <a:srgbClr val="6F7B95"/>
+                </a:solidFill>
+                <a:latin typeface="Arial"/>
+                <a:ea typeface="Arial"/>
+                <a:cs typeface="Arial"/>
+              </a:defRPr>
+            </a:lvl5pPr>
+            <a:lvl6pPr>
+              <a:buNone/>
+              <a:defRPr sz="825">
+                <a:solidFill>
+                  <a:srgbClr val="6F7B95"/>
+                </a:solidFill>
+                <a:latin typeface="Arial"/>
+                <a:ea typeface="Arial"/>
+                <a:cs typeface="Arial"/>
+              </a:defRPr>
+            </a:lvl6pPr>
+            <a:lvl7pPr>
+              <a:buNone/>
+              <a:defRPr sz="825">
+                <a:solidFill>
+                  <a:srgbClr val="6F7B95"/>
+                </a:solidFill>
+                <a:latin typeface="Arial"/>
+                <a:ea typeface="Arial"/>
+                <a:cs typeface="Arial"/>
+              </a:defRPr>
+            </a:lvl7pPr>
+            <a:lvl8pPr>
+              <a:buNone/>
+              <a:defRPr sz="825">
+                <a:solidFill>
+                  <a:srgbClr val="6F7B95"/>
+                </a:solidFill>
+                <a:latin typeface="Arial"/>
+                <a:ea typeface="Arial"/>
+                <a:cs typeface="Arial"/>
+              </a:defRPr>
+            </a:lvl8pPr>
+            <a:lvl9pPr>
+              <a:buNone/>
+              <a:defRPr sz="825">
+                <a:solidFill>
+                  <a:srgbClr val="6F7B95"/>
+                </a:solidFill>
+                <a:latin typeface="Arial"/>
+                <a:ea typeface="Arial"/>
+                <a:cs typeface="Arial"/>
+              </a:defRPr>
+            </a:lvl9pPr>
+          </a:lstStyle>
+          <a:p xmlns:a="http://schemas.openxmlformats.org/drawingml/2006/main">
+            <a:pPr>
+              <a:buNone/>
+              <a:defRPr sz="825">
+                <a:solidFill>
+                  <a:srgbClr val="6F7B95"/>
+                </a:solidFill>
+                <a:latin typeface="Arial"/>
+                <a:ea typeface="Arial"/>
+                <a:cs typeface="Arial"/>
+              </a:defRPr>
+            </a:pPr>
+            <a:r>
+              <a:rPr sz="825">
+                <a:solidFill>
+                  <a:srgbClr val="6F7B95"/>
+                </a:solidFill>
+                <a:latin typeface="Arial"/>
+                <a:ea typeface="Arial"/>
+                <a:cs typeface="Arial"/>
+              </a:rPr>
+              <a:t>Source figure (non-editable). 10M medians: Exasol 4902.269 ms; DuckDB 1080.358 ms.</a:t>
+            </a:r>
+          </a:p>
+        </p:txBody>
+      </p:sp>
     </p:spTree>
     <p:extLst>
       <p:ext uri="{BB962C8B-B14F-4D97-AF65-F5344CB8AC3E}">
@@ -30182,7 +30110,7 @@
           <p:cNvPr id="3" name="">
             <a:extLst xmlns:a="http://schemas.openxmlformats.org/drawingml/2006/main">
               <a:ext uri="{FF2B5EF4-FFF2-40B4-BE49-F238E27FC236}">
-                <a16:creationId xmlns:a16="http://schemas.microsoft.com/office/drawing/2014/main" id="{B3135DAC-4A03-497C-97CF-3B35A80FB28B}"/>
+                <a16:creationId xmlns:a16="http://schemas.microsoft.com/office/drawing/2014/main" id="{E638B943-2B1C-4DE1-AD09-EFBF8D57981F}"/>
               </a:ext>
             </a:extLst>
           </p:cNvPr>
@@ -30192,7 +30120,7 @@
           <p:nvPr/>
         </p:nvPicPr>
         <p:blipFill>
-          <a:blip xmlns:r="http://schemas.openxmlformats.org/officeDocument/2006/relationships" xmlns:a="http://schemas.openxmlformats.org/drawingml/2006/main" r:embed="Rdccfffd0aaf34306"/>
+          <a:blip xmlns:r="http://schemas.openxmlformats.org/officeDocument/2006/relationships" xmlns:a="http://schemas.openxmlformats.org/drawingml/2006/main" r:embed="Rfa81a21f02594d40"/>
           <a:srcRect xmlns:a="http://schemas.openxmlformats.org/drawingml/2006/main" l="0" t="47" r="0" b="47"/>
           <a:stretch xmlns:a="http://schemas.openxmlformats.org/drawingml/2006/main">
             <a:fillRect l="0" t="0" r="0" b="0"/>

</xml_diff>

<commit_message>
docs: refresh submission verification results
</commit_message>
<xml_diff>
--- a/submission/opsintel-ai-pitch-deck.pptx
+++ b/submission/opsintel-ai-pitch-deck.pptx
@@ -6405,7 +6405,7 @@
                 <a:ea typeface="Arial"/>
                 <a:cs typeface="Arial"/>
               </a:rPr>
-              <a:t>03  137 automated tests</a:t>
+              <a:t>03  159 automated tests</a:t>
             </a:r>
           </a:p>
         </p:txBody>
@@ -28485,7 +28485,7 @@
                 <a:ea typeface="Arial"/>
                 <a:cs typeface="Arial"/>
               </a:rPr>
-              <a:t>137 / 137</a:t>
+              <a:t>159 / 159</a:t>
             </a:r>
           </a:p>
         </p:txBody>

</xml_diff>

<commit_message>
fix submission verification evidence
</commit_message>
<xml_diff>
--- a/submission/opsintel-ai-pitch-deck.pptx
+++ b/submission/opsintel-ai-pitch-deck.pptx
@@ -2,23 +2,23 @@
 <file path=ppt/presentation.xml><?xml version="1.0" encoding="utf-8"?>
 <p:presentation xmlns:p="http://schemas.openxmlformats.org/presentationml/2006/main">
   <p:sldMasterIdLst>
-    <p:sldMasterId xmlns:r="http://schemas.openxmlformats.org/officeDocument/2006/relationships" id="2147483648" r:id="R7c626848b4a94a78"/>
+    <p:sldMasterId xmlns:r="http://schemas.openxmlformats.org/officeDocument/2006/relationships" id="2147483648" r:id="R9b2de3906ade470a"/>
   </p:sldMasterIdLst>
   <p:notesMasterIdLst>
-    <p:notesMasterId xmlns:r="http://schemas.openxmlformats.org/officeDocument/2006/relationships" r:id="R7137506e51654c96"/>
+    <p:notesMasterId xmlns:r="http://schemas.openxmlformats.org/officeDocument/2006/relationships" r:id="Rde4e5f9383434e77"/>
   </p:notesMasterIdLst>
   <p:sldIdLst>
-    <p:sldId xmlns:r="http://schemas.openxmlformats.org/officeDocument/2006/relationships" id="256" r:id="Rf26cda66262a4f7a"/>
-    <p:sldId xmlns:r="http://schemas.openxmlformats.org/officeDocument/2006/relationships" id="257" r:id="Rc38258a46cba454e"/>
-    <p:sldId xmlns:r="http://schemas.openxmlformats.org/officeDocument/2006/relationships" id="258" r:id="R8b3273b0cd5944e6"/>
-    <p:sldId xmlns:r="http://schemas.openxmlformats.org/officeDocument/2006/relationships" id="259" r:id="Rb8a238f3e43644ca"/>
-    <p:sldId xmlns:r="http://schemas.openxmlformats.org/officeDocument/2006/relationships" id="260" r:id="R85548aef1a314fdc"/>
-    <p:sldId xmlns:r="http://schemas.openxmlformats.org/officeDocument/2006/relationships" id="261" r:id="Rec3efd37cbc343e0"/>
-    <p:sldId xmlns:r="http://schemas.openxmlformats.org/officeDocument/2006/relationships" id="262" r:id="R5ef78927781143a6"/>
-    <p:sldId xmlns:r="http://schemas.openxmlformats.org/officeDocument/2006/relationships" id="263" r:id="Rd078d67b43ba4979"/>
-    <p:sldId xmlns:r="http://schemas.openxmlformats.org/officeDocument/2006/relationships" id="264" r:id="Rb64f2576e97344d4"/>
-    <p:sldId xmlns:r="http://schemas.openxmlformats.org/officeDocument/2006/relationships" id="265" r:id="Rac238309791a4a3b"/>
-    <p:sldId xmlns:r="http://schemas.openxmlformats.org/officeDocument/2006/relationships" id="266" r:id="Rebb755176f944b86"/>
+    <p:sldId xmlns:r="http://schemas.openxmlformats.org/officeDocument/2006/relationships" id="256" r:id="Rde0a3016be6349d0"/>
+    <p:sldId xmlns:r="http://schemas.openxmlformats.org/officeDocument/2006/relationships" id="257" r:id="R2309ac01c21741c6"/>
+    <p:sldId xmlns:r="http://schemas.openxmlformats.org/officeDocument/2006/relationships" id="258" r:id="Rb10d005218e64a31"/>
+    <p:sldId xmlns:r="http://schemas.openxmlformats.org/officeDocument/2006/relationships" id="259" r:id="R7271c883a4c94a61"/>
+    <p:sldId xmlns:r="http://schemas.openxmlformats.org/officeDocument/2006/relationships" id="260" r:id="Re2fc5a27d3694c13"/>
+    <p:sldId xmlns:r="http://schemas.openxmlformats.org/officeDocument/2006/relationships" id="261" r:id="Ra2d490a5600b41a0"/>
+    <p:sldId xmlns:r="http://schemas.openxmlformats.org/officeDocument/2006/relationships" id="262" r:id="Rdb990d248ae941b5"/>
+    <p:sldId xmlns:r="http://schemas.openxmlformats.org/officeDocument/2006/relationships" id="263" r:id="Rf8e03627933c4a69"/>
+    <p:sldId xmlns:r="http://schemas.openxmlformats.org/officeDocument/2006/relationships" id="264" r:id="Racfde94277124541"/>
+    <p:sldId xmlns:r="http://schemas.openxmlformats.org/officeDocument/2006/relationships" id="265" r:id="R352c6cc344e14394"/>
+    <p:sldId xmlns:r="http://schemas.openxmlformats.org/officeDocument/2006/relationships" id="266" r:id="R6f4fe06942df4858"/>
   </p:sldIdLst>
   <p:sldSz cx="12192000" cy="6858000"/>
   <p:notesSz cx="6858000" cy="9144000"/>
@@ -3601,12 +3601,12 @@
   </p:cSld>
   <p:clrMap bg1="lt1" tx1="dk1" bg2="lt2" tx2="dk2" accent1="accent1" accent2="accent2" accent3="accent3" accent4="accent4" accent5="accent5" accent6="accent6" hlink="hlink" folHlink="folHlink"/>
   <p:sldLayoutIdLst>
-    <p:sldLayoutId xmlns:r="http://schemas.openxmlformats.org/officeDocument/2006/relationships" id="2147483649" r:id="R5cd53295bb4b4e6b"/>
-    <p:sldLayoutId xmlns:r="http://schemas.openxmlformats.org/officeDocument/2006/relationships" id="2147483650" r:id="Rd8094de7d78645bc"/>
-    <p:sldLayoutId xmlns:r="http://schemas.openxmlformats.org/officeDocument/2006/relationships" id="2147483651" r:id="R2410972c92634c31"/>
-    <p:sldLayoutId xmlns:r="http://schemas.openxmlformats.org/officeDocument/2006/relationships" id="2147483652" r:id="R03bb13a37c1242c0"/>
-    <p:sldLayoutId xmlns:r="http://schemas.openxmlformats.org/officeDocument/2006/relationships" id="2147483653" r:id="R3fd6fece705345e8"/>
-    <p:sldLayoutId xmlns:r="http://schemas.openxmlformats.org/officeDocument/2006/relationships" id="2147483654" r:id="R6e29e0a4775e43e9"/>
+    <p:sldLayoutId xmlns:r="http://schemas.openxmlformats.org/officeDocument/2006/relationships" id="2147483649" r:id="Ra563c76bd4d744d9"/>
+    <p:sldLayoutId xmlns:r="http://schemas.openxmlformats.org/officeDocument/2006/relationships" id="2147483650" r:id="R726794ae2be94898"/>
+    <p:sldLayoutId xmlns:r="http://schemas.openxmlformats.org/officeDocument/2006/relationships" id="2147483651" r:id="R0bddbb3596894e5c"/>
+    <p:sldLayoutId xmlns:r="http://schemas.openxmlformats.org/officeDocument/2006/relationships" id="2147483652" r:id="Rc6a17f7cb763409a"/>
+    <p:sldLayoutId xmlns:r="http://schemas.openxmlformats.org/officeDocument/2006/relationships" id="2147483653" r:id="R80a96dbbe03d4fa7"/>
+    <p:sldLayoutId xmlns:r="http://schemas.openxmlformats.org/officeDocument/2006/relationships" id="2147483654" r:id="R90e73b5dce864c9a"/>
   </p:sldLayoutIdLst>
   <p:txStyles>
     <p:titleStyle>
@@ -6409,7 +6409,29 @@
                 <a:ea typeface="Arial"/>
                 <a:cs typeface="Arial"/>
               </a:rPr>
-              <a:t>03  198 automated tests passed</a:t>
+              <a:t>03  </a:t>
+            </a:r>
+            <a:r>
+              <a:rPr sz="1575" b="0">
+                <a:solidFill>
+                  <a:srgbClr val="9AA5BD"/>
+                </a:solidFill>
+                <a:latin typeface="Arial"/>
+                <a:ea typeface="Arial"/>
+                <a:cs typeface="Arial"/>
+              </a:rPr>
+              <a:t>200</a:t>
+            </a:r>
+            <a:r>
+              <a:rPr sz="1575" b="0">
+                <a:solidFill>
+                  <a:srgbClr val="9AA5BD"/>
+                </a:solidFill>
+                <a:latin typeface="Arial"/>
+                <a:ea typeface="Arial"/>
+                <a:cs typeface="Arial"/>
+              </a:rPr>
+              <a:t> automated tests passed</a:t>
             </a:r>
           </a:p>
         </p:txBody>
@@ -16764,7 +16786,7 @@
           <p:cNvPr id="3" name="">
             <a:extLst xmlns:a="http://schemas.openxmlformats.org/drawingml/2006/main">
               <a:ext uri="{FF2B5EF4-FFF2-40B4-BE49-F238E27FC236}">
-                <a16:creationId xmlns:a16="http://schemas.microsoft.com/office/drawing/2014/main" id="{7E4923CD-9760-4539-97DD-027C19087300}"/>
+                <a16:creationId xmlns:a16="http://schemas.microsoft.com/office/drawing/2014/main" id="{626619D9-BB32-4885-9DA7-BF5F204E9980}"/>
               </a:ext>
             </a:extLst>
           </p:cNvPr>
@@ -16774,7 +16796,7 @@
           <p:nvPr/>
         </p:nvPicPr>
         <p:blipFill>
-          <a:blip xmlns:r="http://schemas.openxmlformats.org/officeDocument/2006/relationships" xmlns:a="http://schemas.openxmlformats.org/drawingml/2006/main" r:embed="R375442447c9e4f43"/>
+          <a:blip xmlns:r="http://schemas.openxmlformats.org/officeDocument/2006/relationships" xmlns:a="http://schemas.openxmlformats.org/drawingml/2006/main" r:embed="R12986440c95240be"/>
           <a:srcRect xmlns:a="http://schemas.openxmlformats.org/drawingml/2006/main" l="13" t="0" r="13" b="0"/>
           <a:stretch xmlns:a="http://schemas.openxmlformats.org/drawingml/2006/main">
             <a:fillRect l="0" t="0" r="0" b="0"/>
@@ -18432,7 +18454,7 @@
           <p:cNvPr id="3" name="">
             <a:extLst xmlns:a="http://schemas.openxmlformats.org/drawingml/2006/main">
               <a:ext uri="{FF2B5EF4-FFF2-40B4-BE49-F238E27FC236}">
-                <a16:creationId xmlns:a16="http://schemas.microsoft.com/office/drawing/2014/main" id="{CBD714D4-D3BF-45AF-A540-244C767806EB}"/>
+                <a16:creationId xmlns:a16="http://schemas.microsoft.com/office/drawing/2014/main" id="{27889626-03A9-49AE-80BE-E7F2080B3DBC}"/>
               </a:ext>
             </a:extLst>
           </p:cNvPr>
@@ -18442,7 +18464,7 @@
           <p:nvPr/>
         </p:nvPicPr>
         <p:blipFill>
-          <a:blip xmlns:r="http://schemas.openxmlformats.org/officeDocument/2006/relationships" xmlns:a="http://schemas.openxmlformats.org/drawingml/2006/main" r:embed="R87edbc5f152c47da"/>
+          <a:blip xmlns:r="http://schemas.openxmlformats.org/officeDocument/2006/relationships" xmlns:a="http://schemas.openxmlformats.org/drawingml/2006/main" r:embed="R316704a8d8934764"/>
           <a:srcRect xmlns:a="http://schemas.openxmlformats.org/drawingml/2006/main" l="15" t="0" r="15" b="0"/>
           <a:stretch xmlns:a="http://schemas.openxmlformats.org/drawingml/2006/main">
             <a:fillRect l="0" t="0" r="0" b="0"/>
@@ -28489,7 +28511,7 @@
                 <a:ea typeface="Arial"/>
                 <a:cs typeface="Arial"/>
               </a:rPr>
-              <a:t>198</a:t>
+              <a:t>200</a:t>
             </a:r>
           </a:p>
         </p:txBody>
@@ -29556,7 +29578,7 @@
           <p:cNvPr id="17" name="">
             <a:extLst xmlns:a="http://schemas.openxmlformats.org/drawingml/2006/main">
               <a:ext uri="{FF2B5EF4-FFF2-40B4-BE49-F238E27FC236}">
-                <a16:creationId xmlns:a16="http://schemas.microsoft.com/office/drawing/2014/main" id="{49A1D373-DB96-4CBC-991B-72F586EEA839}"/>
+                <a16:creationId xmlns:a16="http://schemas.microsoft.com/office/drawing/2014/main" id="{93D68F06-D547-4C3B-B3F7-1A1F17E3499C}"/>
               </a:ext>
             </a:extLst>
           </p:cNvPr>
@@ -29566,7 +29588,7 @@
           <p:nvPr/>
         </p:nvPicPr>
         <p:blipFill>
-          <a:blip xmlns:r="http://schemas.openxmlformats.org/officeDocument/2006/relationships" xmlns:a="http://schemas.openxmlformats.org/drawingml/2006/main" r:embed="R508cb8d7839d4613"/>
+          <a:blip xmlns:r="http://schemas.openxmlformats.org/officeDocument/2006/relationships" xmlns:a="http://schemas.openxmlformats.org/drawingml/2006/main" r:embed="R12e66e74fe044cb9"/>
           <a:stretch xmlns:a="http://schemas.openxmlformats.org/drawingml/2006/main"/>
         </p:blipFill>
         <p:spPr>
@@ -30114,7 +30136,7 @@
           <p:cNvPr id="3" name="">
             <a:extLst xmlns:a="http://schemas.openxmlformats.org/drawingml/2006/main">
               <a:ext uri="{FF2B5EF4-FFF2-40B4-BE49-F238E27FC236}">
-                <a16:creationId xmlns:a16="http://schemas.microsoft.com/office/drawing/2014/main" id="{E872BA96-9EAE-4061-82DA-87F38A92BA27}"/>
+                <a16:creationId xmlns:a16="http://schemas.microsoft.com/office/drawing/2014/main" id="{E7208C20-9A7C-4608-8DEF-DD6D8B8B88A1}"/>
               </a:ext>
             </a:extLst>
           </p:cNvPr>
@@ -30124,7 +30146,7 @@
           <p:nvPr/>
         </p:nvPicPr>
         <p:blipFill>
-          <a:blip xmlns:r="http://schemas.openxmlformats.org/officeDocument/2006/relationships" xmlns:a="http://schemas.openxmlformats.org/drawingml/2006/main" r:embed="Rdaed5a8d7be042d1"/>
+          <a:blip xmlns:r="http://schemas.openxmlformats.org/officeDocument/2006/relationships" xmlns:a="http://schemas.openxmlformats.org/drawingml/2006/main" r:embed="R6566f367b6d24070"/>
           <a:srcRect xmlns:a="http://schemas.openxmlformats.org/drawingml/2006/main" l="0" t="47" r="0" b="47"/>
           <a:stretch xmlns:a="http://schemas.openxmlformats.org/drawingml/2006/main">
             <a:fillRect l="0" t="0" r="0" b="0"/>

</xml_diff>

<commit_message>
fix CI submission evidence count
</commit_message>
<xml_diff>
--- a/submission/opsintel-ai-pitch-deck.pptx
+++ b/submission/opsintel-ai-pitch-deck.pptx
@@ -2,23 +2,23 @@
 <file path=ppt/presentation.xml><?xml version="1.0" encoding="utf-8"?>
 <p:presentation xmlns:p="http://schemas.openxmlformats.org/presentationml/2006/main">
   <p:sldMasterIdLst>
-    <p:sldMasterId xmlns:r="http://schemas.openxmlformats.org/officeDocument/2006/relationships" id="2147483648" r:id="R385ef9e45ee14cfb"/>
+    <p:sldMasterId xmlns:r="http://schemas.openxmlformats.org/officeDocument/2006/relationships" id="2147483648" r:id="R8f0898385cc54c5c"/>
   </p:sldMasterIdLst>
   <p:notesMasterIdLst>
-    <p:notesMasterId xmlns:r="http://schemas.openxmlformats.org/officeDocument/2006/relationships" r:id="Rc5f23f655eb24801"/>
+    <p:notesMasterId xmlns:r="http://schemas.openxmlformats.org/officeDocument/2006/relationships" r:id="Re85bb4967fd341bd"/>
   </p:notesMasterIdLst>
   <p:sldIdLst>
-    <p:sldId xmlns:r="http://schemas.openxmlformats.org/officeDocument/2006/relationships" id="256" r:id="Rf48da5815d254036"/>
-    <p:sldId xmlns:r="http://schemas.openxmlformats.org/officeDocument/2006/relationships" id="257" r:id="R1bb3f21672e24cc4"/>
-    <p:sldId xmlns:r="http://schemas.openxmlformats.org/officeDocument/2006/relationships" id="258" r:id="R41ba2014b8ee4895"/>
-    <p:sldId xmlns:r="http://schemas.openxmlformats.org/officeDocument/2006/relationships" id="259" r:id="Rbf95ed7f85d84357"/>
-    <p:sldId xmlns:r="http://schemas.openxmlformats.org/officeDocument/2006/relationships" id="260" r:id="R5cae5e15ade04ed5"/>
-    <p:sldId xmlns:r="http://schemas.openxmlformats.org/officeDocument/2006/relationships" id="261" r:id="R6a3c686bbdf544ff"/>
-    <p:sldId xmlns:r="http://schemas.openxmlformats.org/officeDocument/2006/relationships" id="262" r:id="R2814c6afbd1f40d3"/>
-    <p:sldId xmlns:r="http://schemas.openxmlformats.org/officeDocument/2006/relationships" id="263" r:id="R7ef5e529f3504882"/>
-    <p:sldId xmlns:r="http://schemas.openxmlformats.org/officeDocument/2006/relationships" id="264" r:id="R7b3011604d394295"/>
-    <p:sldId xmlns:r="http://schemas.openxmlformats.org/officeDocument/2006/relationships" id="265" r:id="R1edcc3bee90d48b4"/>
-    <p:sldId xmlns:r="http://schemas.openxmlformats.org/officeDocument/2006/relationships" id="266" r:id="Ra90352d2303f4c95"/>
+    <p:sldId xmlns:r="http://schemas.openxmlformats.org/officeDocument/2006/relationships" id="256" r:id="Reda3309b4ee342a1"/>
+    <p:sldId xmlns:r="http://schemas.openxmlformats.org/officeDocument/2006/relationships" id="257" r:id="Ra69e5454205b4f03"/>
+    <p:sldId xmlns:r="http://schemas.openxmlformats.org/officeDocument/2006/relationships" id="258" r:id="R86e9109cd3fd400f"/>
+    <p:sldId xmlns:r="http://schemas.openxmlformats.org/officeDocument/2006/relationships" id="259" r:id="R4f360d3002d84cff"/>
+    <p:sldId xmlns:r="http://schemas.openxmlformats.org/officeDocument/2006/relationships" id="260" r:id="R433cf33787074983"/>
+    <p:sldId xmlns:r="http://schemas.openxmlformats.org/officeDocument/2006/relationships" id="261" r:id="R2ae6a6d899c441fa"/>
+    <p:sldId xmlns:r="http://schemas.openxmlformats.org/officeDocument/2006/relationships" id="262" r:id="R18612bcd4a854d5a"/>
+    <p:sldId xmlns:r="http://schemas.openxmlformats.org/officeDocument/2006/relationships" id="263" r:id="R037aa53c603d4434"/>
+    <p:sldId xmlns:r="http://schemas.openxmlformats.org/officeDocument/2006/relationships" id="264" r:id="R3d78067e11144a60"/>
+    <p:sldId xmlns:r="http://schemas.openxmlformats.org/officeDocument/2006/relationships" id="265" r:id="R0a9791e0b38d4434"/>
+    <p:sldId xmlns:r="http://schemas.openxmlformats.org/officeDocument/2006/relationships" id="266" r:id="R195e5c72beb24439"/>
   </p:sldIdLst>
   <p:sldSz cx="12192000" cy="6858000"/>
   <p:notesSz cx="6858000" cy="9144000"/>
@@ -3606,12 +3606,12 @@
   </p:cSld>
   <p:clrMap bg1="lt1" tx1="dk1" bg2="lt2" tx2="dk2" accent1="accent1" accent2="accent2" accent3="accent3" accent4="accent4" accent5="accent5" accent6="accent6" hlink="hlink" folHlink="folHlink"/>
   <p:sldLayoutIdLst>
-    <p:sldLayoutId xmlns:r="http://schemas.openxmlformats.org/officeDocument/2006/relationships" id="2147483649" r:id="R01302da5c915426a"/>
-    <p:sldLayoutId xmlns:r="http://schemas.openxmlformats.org/officeDocument/2006/relationships" id="2147483650" r:id="R66fc5a5c174041d8"/>
-    <p:sldLayoutId xmlns:r="http://schemas.openxmlformats.org/officeDocument/2006/relationships" id="2147483651" r:id="R964192d5895a478f"/>
-    <p:sldLayoutId xmlns:r="http://schemas.openxmlformats.org/officeDocument/2006/relationships" id="2147483652" r:id="Rce588752c68542c2"/>
-    <p:sldLayoutId xmlns:r="http://schemas.openxmlformats.org/officeDocument/2006/relationships" id="2147483653" r:id="Ra8c12ffd7e7c4ae7"/>
-    <p:sldLayoutId xmlns:r="http://schemas.openxmlformats.org/officeDocument/2006/relationships" id="2147483654" r:id="R31196169b4694951"/>
+    <p:sldLayoutId xmlns:r="http://schemas.openxmlformats.org/officeDocument/2006/relationships" id="2147483649" r:id="Rb0e594a4014c482b"/>
+    <p:sldLayoutId xmlns:r="http://schemas.openxmlformats.org/officeDocument/2006/relationships" id="2147483650" r:id="Rd68db5273d434482"/>
+    <p:sldLayoutId xmlns:r="http://schemas.openxmlformats.org/officeDocument/2006/relationships" id="2147483651" r:id="R0f04f5b10db843d2"/>
+    <p:sldLayoutId xmlns:r="http://schemas.openxmlformats.org/officeDocument/2006/relationships" id="2147483652" r:id="R2e1fc1b478794eee"/>
+    <p:sldLayoutId xmlns:r="http://schemas.openxmlformats.org/officeDocument/2006/relationships" id="2147483653" r:id="Rbe16b71f730e4d43"/>
+    <p:sldLayoutId xmlns:r="http://schemas.openxmlformats.org/officeDocument/2006/relationships" id="2147483654" r:id="R591ca010d1344f67"/>
   </p:sldLayoutIdLst>
   <p:txStyles>
     <p:titleStyle>
@@ -6414,7 +6414,7 @@
                 <a:ea typeface="Arial"/>
                 <a:cs typeface="Arial"/>
               </a:rPr>
-              <a:t>03  197 automated tests passed</a:t>
+              <a:t>03  200 automated tests passed</a:t>
             </a:r>
           </a:p>
         </p:txBody>
@@ -16769,7 +16769,7 @@
           <p:cNvPr id="3" name="">
             <a:extLst xmlns:a="http://schemas.openxmlformats.org/drawingml/2006/main">
               <a:ext uri="{FF2B5EF4-FFF2-40B4-BE49-F238E27FC236}">
-                <a16:creationId xmlns:a16="http://schemas.microsoft.com/office/drawing/2014/main" id="{818F3B1F-CCFF-4D2B-84FB-07FF99C6F7D6}"/>
+                <a16:creationId xmlns:a16="http://schemas.microsoft.com/office/drawing/2014/main" id="{7E85781D-2BD2-436F-B624-89F83A34413E}"/>
               </a:ext>
             </a:extLst>
           </p:cNvPr>
@@ -16779,7 +16779,7 @@
           <p:nvPr/>
         </p:nvPicPr>
         <p:blipFill>
-          <a:blip xmlns:r="http://schemas.openxmlformats.org/officeDocument/2006/relationships" xmlns:a="http://schemas.openxmlformats.org/drawingml/2006/main" r:embed="R75166293a3a64f84"/>
+          <a:blip xmlns:r="http://schemas.openxmlformats.org/officeDocument/2006/relationships" xmlns:a="http://schemas.openxmlformats.org/drawingml/2006/main" r:embed="R2a3d206750074b71"/>
           <a:srcRect xmlns:a="http://schemas.openxmlformats.org/drawingml/2006/main" l="13" t="0" r="13" b="0"/>
           <a:stretch xmlns:a="http://schemas.openxmlformats.org/drawingml/2006/main">
             <a:fillRect l="0" t="0" r="0" b="0"/>
@@ -18437,7 +18437,7 @@
           <p:cNvPr id="3" name="">
             <a:extLst xmlns:a="http://schemas.openxmlformats.org/drawingml/2006/main">
               <a:ext uri="{FF2B5EF4-FFF2-40B4-BE49-F238E27FC236}">
-                <a16:creationId xmlns:a16="http://schemas.microsoft.com/office/drawing/2014/main" id="{7CA23A36-CB35-4A2C-AC26-6F613A8CA483}"/>
+                <a16:creationId xmlns:a16="http://schemas.microsoft.com/office/drawing/2014/main" id="{BA690D3A-653F-4A37-8410-0A0832BB682A}"/>
               </a:ext>
             </a:extLst>
           </p:cNvPr>
@@ -18447,7 +18447,7 @@
           <p:nvPr/>
         </p:nvPicPr>
         <p:blipFill>
-          <a:blip xmlns:r="http://schemas.openxmlformats.org/officeDocument/2006/relationships" xmlns:a="http://schemas.openxmlformats.org/drawingml/2006/main" r:embed="Rcc35607d2fd04cd3"/>
+          <a:blip xmlns:r="http://schemas.openxmlformats.org/officeDocument/2006/relationships" xmlns:a="http://schemas.openxmlformats.org/drawingml/2006/main" r:embed="R04433ff14cb44059"/>
           <a:srcRect xmlns:a="http://schemas.openxmlformats.org/drawingml/2006/main" l="15" t="0" r="15" b="0"/>
           <a:stretch xmlns:a="http://schemas.openxmlformats.org/drawingml/2006/main">
             <a:fillRect l="0" t="0" r="0" b="0"/>
@@ -28494,7 +28494,7 @@
                 <a:ea typeface="Arial"/>
                 <a:cs typeface="Arial"/>
               </a:rPr>
-              <a:t>197</a:t>
+              <a:t>200</a:t>
             </a:r>
           </a:p>
         </p:txBody>
@@ -29561,7 +29561,7 @@
           <p:cNvPr id="17" name="">
             <a:extLst xmlns:a="http://schemas.openxmlformats.org/drawingml/2006/main">
               <a:ext uri="{FF2B5EF4-FFF2-40B4-BE49-F238E27FC236}">
-                <a16:creationId xmlns:a16="http://schemas.microsoft.com/office/drawing/2014/main" id="{E68FA780-A4D5-42D9-B00C-8376B085A460}"/>
+                <a16:creationId xmlns:a16="http://schemas.microsoft.com/office/drawing/2014/main" id="{C406D308-F2D7-4240-BFCB-1A33DD25688F}"/>
               </a:ext>
             </a:extLst>
           </p:cNvPr>
@@ -29571,7 +29571,7 @@
           <p:nvPr/>
         </p:nvPicPr>
         <p:blipFill>
-          <a:blip xmlns:r="http://schemas.openxmlformats.org/officeDocument/2006/relationships" xmlns:a="http://schemas.openxmlformats.org/drawingml/2006/main" r:embed="R3141fed8595446e0"/>
+          <a:blip xmlns:r="http://schemas.openxmlformats.org/officeDocument/2006/relationships" xmlns:a="http://schemas.openxmlformats.org/drawingml/2006/main" r:embed="R294ef75ab9354dc9"/>
           <a:stretch xmlns:a="http://schemas.openxmlformats.org/drawingml/2006/main"/>
         </p:blipFill>
         <p:spPr>
@@ -30119,7 +30119,7 @@
           <p:cNvPr id="3" name="">
             <a:extLst xmlns:a="http://schemas.openxmlformats.org/drawingml/2006/main">
               <a:ext uri="{FF2B5EF4-FFF2-40B4-BE49-F238E27FC236}">
-                <a16:creationId xmlns:a16="http://schemas.microsoft.com/office/drawing/2014/main" id="{89C367BC-8474-4725-9E65-2AC74802A201}"/>
+                <a16:creationId xmlns:a16="http://schemas.microsoft.com/office/drawing/2014/main" id="{E56C83CE-358C-446C-B625-8161B64269FF}"/>
               </a:ext>
             </a:extLst>
           </p:cNvPr>
@@ -30129,7 +30129,7 @@
           <p:nvPr/>
         </p:nvPicPr>
         <p:blipFill>
-          <a:blip xmlns:r="http://schemas.openxmlformats.org/officeDocument/2006/relationships" xmlns:a="http://schemas.openxmlformats.org/drawingml/2006/main" r:embed="Reee97e0c2b2d4ffb"/>
+          <a:blip xmlns:r="http://schemas.openxmlformats.org/officeDocument/2006/relationships" xmlns:a="http://schemas.openxmlformats.org/drawingml/2006/main" r:embed="Re331be07709941bb"/>
           <a:srcRect xmlns:a="http://schemas.openxmlformats.org/drawingml/2006/main" l="0" t="47" r="0" b="47"/>
           <a:stretch xmlns:a="http://schemas.openxmlformats.org/drawingml/2006/main">
             <a:fillRect l="0" t="0" r="0" b="0"/>

</xml_diff>

<commit_message>
update in ppt and pdf
</commit_message>
<xml_diff>
--- a/submission/opsintel-ai-pitch-deck.pptx
+++ b/submission/opsintel-ai-pitch-deck.pptx
@@ -2,23 +2,23 @@
 <file path=ppt/presentation.xml><?xml version="1.0" encoding="utf-8"?>
 <p:presentation xmlns:p="http://schemas.openxmlformats.org/presentationml/2006/main">
   <p:sldMasterIdLst>
-    <p:sldMasterId xmlns:r="http://schemas.openxmlformats.org/officeDocument/2006/relationships" id="2147483648" r:id="R8f0898385cc54c5c"/>
+    <p:sldMasterId xmlns:r="http://schemas.openxmlformats.org/officeDocument/2006/relationships" id="2147483648" r:id="R523f1a898a66414e"/>
   </p:sldMasterIdLst>
   <p:notesMasterIdLst>
-    <p:notesMasterId xmlns:r="http://schemas.openxmlformats.org/officeDocument/2006/relationships" r:id="Re85bb4967fd341bd"/>
+    <p:notesMasterId xmlns:r="http://schemas.openxmlformats.org/officeDocument/2006/relationships" r:id="R671720803c5d47ea"/>
   </p:notesMasterIdLst>
   <p:sldIdLst>
-    <p:sldId xmlns:r="http://schemas.openxmlformats.org/officeDocument/2006/relationships" id="256" r:id="Reda3309b4ee342a1"/>
-    <p:sldId xmlns:r="http://schemas.openxmlformats.org/officeDocument/2006/relationships" id="257" r:id="Ra69e5454205b4f03"/>
-    <p:sldId xmlns:r="http://schemas.openxmlformats.org/officeDocument/2006/relationships" id="258" r:id="R86e9109cd3fd400f"/>
-    <p:sldId xmlns:r="http://schemas.openxmlformats.org/officeDocument/2006/relationships" id="259" r:id="R4f360d3002d84cff"/>
-    <p:sldId xmlns:r="http://schemas.openxmlformats.org/officeDocument/2006/relationships" id="260" r:id="R433cf33787074983"/>
-    <p:sldId xmlns:r="http://schemas.openxmlformats.org/officeDocument/2006/relationships" id="261" r:id="R2ae6a6d899c441fa"/>
-    <p:sldId xmlns:r="http://schemas.openxmlformats.org/officeDocument/2006/relationships" id="262" r:id="R18612bcd4a854d5a"/>
-    <p:sldId xmlns:r="http://schemas.openxmlformats.org/officeDocument/2006/relationships" id="263" r:id="R037aa53c603d4434"/>
-    <p:sldId xmlns:r="http://schemas.openxmlformats.org/officeDocument/2006/relationships" id="264" r:id="R3d78067e11144a60"/>
-    <p:sldId xmlns:r="http://schemas.openxmlformats.org/officeDocument/2006/relationships" id="265" r:id="R0a9791e0b38d4434"/>
-    <p:sldId xmlns:r="http://schemas.openxmlformats.org/officeDocument/2006/relationships" id="266" r:id="R195e5c72beb24439"/>
+    <p:sldId xmlns:r="http://schemas.openxmlformats.org/officeDocument/2006/relationships" id="256" r:id="Rabe7845a0ead4d41"/>
+    <p:sldId xmlns:r="http://schemas.openxmlformats.org/officeDocument/2006/relationships" id="257" r:id="R5c4cb25ca3304d78"/>
+    <p:sldId xmlns:r="http://schemas.openxmlformats.org/officeDocument/2006/relationships" id="258" r:id="R88c452cf2f4c46c2"/>
+    <p:sldId xmlns:r="http://schemas.openxmlformats.org/officeDocument/2006/relationships" id="259" r:id="R49bc4584a7544281"/>
+    <p:sldId xmlns:r="http://schemas.openxmlformats.org/officeDocument/2006/relationships" id="260" r:id="R2d67f04115ed4bca"/>
+    <p:sldId xmlns:r="http://schemas.openxmlformats.org/officeDocument/2006/relationships" id="261" r:id="R970509bebe5a48a2"/>
+    <p:sldId xmlns:r="http://schemas.openxmlformats.org/officeDocument/2006/relationships" id="262" r:id="Rf11dfd9a5b0b4af8"/>
+    <p:sldId xmlns:r="http://schemas.openxmlformats.org/officeDocument/2006/relationships" id="263" r:id="Rbbe1755561314924"/>
+    <p:sldId xmlns:r="http://schemas.openxmlformats.org/officeDocument/2006/relationships" id="264" r:id="R57fd685925c94d4b"/>
+    <p:sldId xmlns:r="http://schemas.openxmlformats.org/officeDocument/2006/relationships" id="265" r:id="R1026e18810984a64"/>
+    <p:sldId xmlns:r="http://schemas.openxmlformats.org/officeDocument/2006/relationships" id="266" r:id="Rb3b6f7b1811544a0"/>
   </p:sldIdLst>
   <p:sldSz cx="12192000" cy="6858000"/>
   <p:notesSz cx="6858000" cy="9144000"/>
@@ -3606,12 +3606,12 @@
   </p:cSld>
   <p:clrMap bg1="lt1" tx1="dk1" bg2="lt2" tx2="dk2" accent1="accent1" accent2="accent2" accent3="accent3" accent4="accent4" accent5="accent5" accent6="accent6" hlink="hlink" folHlink="folHlink"/>
   <p:sldLayoutIdLst>
-    <p:sldLayoutId xmlns:r="http://schemas.openxmlformats.org/officeDocument/2006/relationships" id="2147483649" r:id="Rb0e594a4014c482b"/>
-    <p:sldLayoutId xmlns:r="http://schemas.openxmlformats.org/officeDocument/2006/relationships" id="2147483650" r:id="Rd68db5273d434482"/>
-    <p:sldLayoutId xmlns:r="http://schemas.openxmlformats.org/officeDocument/2006/relationships" id="2147483651" r:id="R0f04f5b10db843d2"/>
-    <p:sldLayoutId xmlns:r="http://schemas.openxmlformats.org/officeDocument/2006/relationships" id="2147483652" r:id="R2e1fc1b478794eee"/>
-    <p:sldLayoutId xmlns:r="http://schemas.openxmlformats.org/officeDocument/2006/relationships" id="2147483653" r:id="Rbe16b71f730e4d43"/>
-    <p:sldLayoutId xmlns:r="http://schemas.openxmlformats.org/officeDocument/2006/relationships" id="2147483654" r:id="R591ca010d1344f67"/>
+    <p:sldLayoutId xmlns:r="http://schemas.openxmlformats.org/officeDocument/2006/relationships" id="2147483649" r:id="Rf3e717a86fab4ffb"/>
+    <p:sldLayoutId xmlns:r="http://schemas.openxmlformats.org/officeDocument/2006/relationships" id="2147483650" r:id="R0dbd38b98c534f41"/>
+    <p:sldLayoutId xmlns:r="http://schemas.openxmlformats.org/officeDocument/2006/relationships" id="2147483651" r:id="Rff6376f83e6f43b2"/>
+    <p:sldLayoutId xmlns:r="http://schemas.openxmlformats.org/officeDocument/2006/relationships" id="2147483652" r:id="R19c2f064eb2846af"/>
+    <p:sldLayoutId xmlns:r="http://schemas.openxmlformats.org/officeDocument/2006/relationships" id="2147483653" r:id="Rd60330060ce844e0"/>
+    <p:sldLayoutId xmlns:r="http://schemas.openxmlformats.org/officeDocument/2006/relationships" id="2147483654" r:id="R61c066a971b6409a"/>
   </p:sldLayoutIdLst>
   <p:txStyles>
     <p:titleStyle>
@@ -5780,7 +5780,7 @@
           </a:ln>
         </p:spPr>
         <p:txBody>
-          <a:bodyPr xmlns:a="http://schemas.openxmlformats.org/drawingml/2006/main" anchor="ctr"/>
+          <a:bodyPr xmlns:a="http://schemas.openxmlformats.org/drawingml/2006/main" anchor="ctr" wrap="square" lIns="12700" rIns="12700"/>
           <a:lstStyle xmlns:a="http://schemas.openxmlformats.org/drawingml/2006/main">
             <a:defPPr algn="l">
               <a:defRPr sz="1125" b="1">
@@ -5893,27 +5893,17 @@
             </a:lvl9pPr>
           </a:lstStyle>
           <a:p xmlns:a="http://schemas.openxmlformats.org/drawingml/2006/main">
-            <a:pPr algn="l">
-              <a:buNone/>
-              <a:defRPr sz="1125" b="1">
-                <a:solidFill>
-                  <a:srgbClr val="58DDB0"/>
-                </a:solidFill>
-                <a:latin typeface="Arial"/>
-                <a:ea typeface="Arial"/>
-                <a:cs typeface="Arial"/>
-              </a:defRPr>
+            <a:pPr>
+              <a:spcBef>
+                <a:spcPts val="0"/>
+              </a:spcBef>
+              <a:spcAft>
+                <a:spcPts val="200"/>
+              </a:spcAft>
             </a:pPr>
             <a:r>
-              <a:rPr sz="1125" b="1">
-                <a:solidFill>
-                  <a:srgbClr val="58DDB0"/>
-                </a:solidFill>
-                <a:latin typeface="Arial"/>
-                <a:ea typeface="Arial"/>
-                <a:cs typeface="Arial"/>
-              </a:rPr>
-              <a:t>RECORDED IN REPOSITORY</a:t>
+              <a:rPr sz="1050"/>
+              <a:t>VERIFIED IMPLEMENTATION</a:t>
             </a:r>
           </a:p>
         </p:txBody>
@@ -5947,7 +5937,7 @@
           </a:ln>
         </p:spPr>
         <p:txBody>
-          <a:bodyPr xmlns:a="http://schemas.openxmlformats.org/drawingml/2006/main" anchor="ctr"/>
+          <a:bodyPr xmlns:a="http://schemas.openxmlformats.org/drawingml/2006/main" anchor="ctr" wrap="square" lIns="12700" rIns="12700"/>
           <a:lstStyle xmlns:a="http://schemas.openxmlformats.org/drawingml/2006/main">
             <a:defPPr algn="l">
               <a:defRPr sz="1575" b="0">
@@ -6060,27 +6050,17 @@
             </a:lvl9pPr>
           </a:lstStyle>
           <a:p xmlns:a="http://schemas.openxmlformats.org/drawingml/2006/main">
-            <a:pPr algn="l">
-              <a:buNone/>
-              <a:defRPr sz="1575" b="0">
-                <a:solidFill>
-                  <a:srgbClr val="F0F3FA"/>
-                </a:solidFill>
-                <a:latin typeface="Arial"/>
-                <a:ea typeface="Arial"/>
-                <a:cs typeface="Arial"/>
-              </a:defRPr>
+            <a:pPr>
+              <a:spcBef>
+                <a:spcPts val="0"/>
+              </a:spcBef>
+              <a:spcAft>
+                <a:spcPts val="200"/>
+              </a:spcAft>
             </a:pPr>
             <a:r>
-              <a:rPr sz="1575" b="0">
-                <a:solidFill>
-                  <a:srgbClr val="F0F3FA"/>
-                </a:solidFill>
-                <a:latin typeface="Arial"/>
-                <a:ea typeface="Arial"/>
-                <a:cs typeface="Arial"/>
-              </a:rPr>
-              <a:t>01  Exasol queries, schema, and migration documented</a:t>
+              <a:rPr sz="1050"/>
+              <a:t>01  Live Exasol memory workflow verified</a:t>
             </a:r>
           </a:p>
         </p:txBody>
@@ -6114,7 +6094,7 @@
           </a:ln>
         </p:spPr>
         <p:txBody>
-          <a:bodyPr xmlns:a="http://schemas.openxmlformats.org/drawingml/2006/main" anchor="ctr"/>
+          <a:bodyPr xmlns:a="http://schemas.openxmlformats.org/drawingml/2006/main" anchor="ctr" wrap="square" lIns="12700" rIns="12700"/>
           <a:lstStyle xmlns:a="http://schemas.openxmlformats.org/drawingml/2006/main">
             <a:defPPr algn="l">
               <a:defRPr sz="1575" b="0">
@@ -6227,27 +6207,17 @@
             </a:lvl9pPr>
           </a:lstStyle>
           <a:p xmlns:a="http://schemas.openxmlformats.org/drawingml/2006/main">
-            <a:pPr algn="l">
-              <a:buNone/>
-              <a:defRPr sz="1575" b="0">
-                <a:solidFill>
-                  <a:srgbClr val="9AA5BD"/>
-                </a:solidFill>
-                <a:latin typeface="Arial"/>
-                <a:ea typeface="Arial"/>
-                <a:cs typeface="Arial"/>
-              </a:defRPr>
+            <a:pPr>
+              <a:spcBef>
+                <a:spcPts val="0"/>
+              </a:spcBef>
+              <a:spcAft>
+                <a:spcPts val="200"/>
+              </a:spcAft>
             </a:pPr>
             <a:r>
-              <a:rPr sz="1575" b="0">
-                <a:solidFill>
-                  <a:srgbClr val="9AA5BD"/>
-                </a:solidFill>
-                <a:latin typeface="Arial"/>
-                <a:ea typeface="Arial"/>
-                <a:cs typeface="Arial"/>
-              </a:rPr>
-              <a:t>02  Local 1M/10M benchmark report</a:t>
+              <a:rPr sz="1050"/>
+              <a:t>02  Restart persistence; retrieval score 0.5855</a:t>
             </a:r>
           </a:p>
         </p:txBody>
@@ -6281,7 +6251,7 @@
           </a:ln>
         </p:spPr>
         <p:txBody>
-          <a:bodyPr xmlns:a="http://schemas.openxmlformats.org/drawingml/2006/main" anchor="ctr"/>
+          <a:bodyPr xmlns:a="http://schemas.openxmlformats.org/drawingml/2006/main" anchor="ctr" wrap="square" lIns="12700" rIns="12700"/>
           <a:lstStyle xmlns:a="http://schemas.openxmlformats.org/drawingml/2006/main">
             <a:defPPr algn="l">
               <a:defRPr sz="1575" b="0">
@@ -6394,27 +6364,17 @@
             </a:lvl9pPr>
           </a:lstStyle>
           <a:p xmlns:a="http://schemas.openxmlformats.org/drawingml/2006/main">
-            <a:pPr algn="l">
-              <a:buNone/>
-              <a:defRPr sz="1575" b="0">
-                <a:solidFill>
-                  <a:srgbClr val="9AA5BD"/>
-                </a:solidFill>
-                <a:latin typeface="Arial"/>
-                <a:ea typeface="Arial"/>
-                <a:cs typeface="Arial"/>
-              </a:defRPr>
+            <a:pPr>
+              <a:spcBef>
+                <a:spcPts val="0"/>
+              </a:spcBef>
+              <a:spcAft>
+                <a:spcPts val="200"/>
+              </a:spcAft>
             </a:pPr>
             <a:r>
-              <a:rPr sz="1575" b="0">
-                <a:solidFill>
-                  <a:srgbClr val="9AA5BD"/>
-                </a:solidFill>
-                <a:latin typeface="Arial"/>
-                <a:ea typeface="Arial"/>
-                <a:cs typeface="Arial"/>
-              </a:rPr>
-              <a:t>03  200 automated tests passed</a:t>
+              <a:rPr sz="1050"/>
+              <a:t>03  Reviewer race guard: 1 HTTP 200 / 1 HTTP 409</a:t>
             </a:r>
           </a:p>
         </p:txBody>
@@ -6448,7 +6408,7 @@
           </a:ln>
         </p:spPr>
         <p:txBody>
-          <a:bodyPr xmlns:a="http://schemas.openxmlformats.org/drawingml/2006/main" anchor="ctr"/>
+          <a:bodyPr xmlns:a="http://schemas.openxmlformats.org/drawingml/2006/main" anchor="ctr" wrap="square" lIns="12700" rIns="12700"/>
           <a:lstStyle xmlns:a="http://schemas.openxmlformats.org/drawingml/2006/main">
             <a:defPPr algn="l">
               <a:defRPr sz="1425" b="0">
@@ -6561,27 +6521,17 @@
             </a:lvl9pPr>
           </a:lstStyle>
           <a:p xmlns:a="http://schemas.openxmlformats.org/drawingml/2006/main">
-            <a:pPr algn="l">
-              <a:buNone/>
-              <a:defRPr sz="1425" b="0">
-                <a:solidFill>
-                  <a:srgbClr val="9AA5BD"/>
-                </a:solidFill>
-                <a:latin typeface="Arial"/>
-                <a:ea typeface="Arial"/>
-                <a:cs typeface="Arial"/>
-              </a:defRPr>
+            <a:pPr>
+              <a:spcBef>
+                <a:spcPts val="0"/>
+              </a:spcBef>
+              <a:spcAft>
+                <a:spcPts val="200"/>
+              </a:spcAft>
             </a:pPr>
             <a:r>
-              <a:rPr sz="1425" b="0">
-                <a:solidFill>
-                  <a:srgbClr val="9AA5BD"/>
-                </a:solidFill>
-                <a:latin typeface="Arial"/>
-                <a:ea typeface="Arial"/>
-                <a:cs typeface="Arial"/>
-              </a:rPr>
-              <a:t>04  App routes inspected locally; Exasol unavailable today</a:t>
+              <a:rPr sz="1050"/>
+              <a:t>04  200 tests; challenge 16/16; empty-history benchmark measured</a:t>
             </a:r>
           </a:p>
         </p:txBody>
@@ -6646,7 +6596,7 @@
           </a:ln>
         </p:spPr>
         <p:txBody>
-          <a:bodyPr xmlns:a="http://schemas.openxmlformats.org/drawingml/2006/main" anchor="ctr"/>
+          <a:bodyPr xmlns:a="http://schemas.openxmlformats.org/drawingml/2006/main" anchor="ctr" wrap="square" lIns="12700" rIns="12700"/>
           <a:lstStyle xmlns:a="http://schemas.openxmlformats.org/drawingml/2006/main">
             <a:defPPr algn="l">
               <a:defRPr sz="1125" b="1">
@@ -6759,27 +6709,17 @@
             </a:lvl9pPr>
           </a:lstStyle>
           <a:p xmlns:a="http://schemas.openxmlformats.org/drawingml/2006/main">
-            <a:pPr algn="l">
-              <a:buNone/>
-              <a:defRPr sz="1125" b="1">
-                <a:solidFill>
-                  <a:srgbClr val="9B8CFF"/>
-                </a:solidFill>
-                <a:latin typeface="Arial"/>
-                <a:ea typeface="Arial"/>
-                <a:cs typeface="Arial"/>
-              </a:defRPr>
+            <a:pPr>
+              <a:spcBef>
+                <a:spcPts val="0"/>
+              </a:spcBef>
+              <a:spcAft>
+                <a:spcPts val="200"/>
+              </a:spcAft>
             </a:pPr>
             <a:r>
-              <a:rPr sz="1125" b="1">
-                <a:solidFill>
-                  <a:srgbClr val="9B8CFF"/>
-                </a:solidFill>
-                <a:latin typeface="Arial"/>
-                <a:ea typeface="Arial"/>
-                <a:cs typeface="Arial"/>
-              </a:rPr>
-              <a:t>NOT INDEPENDENT VALIDATION</a:t>
+              <a:rPr sz="1050"/>
+              <a:t>LIMITS OF CURRENT EVIDENCE</a:t>
             </a:r>
           </a:p>
         </p:txBody>
@@ -6813,7 +6753,7 @@
           </a:ln>
         </p:spPr>
         <p:txBody>
-          <a:bodyPr xmlns:a="http://schemas.openxmlformats.org/drawingml/2006/main" anchor="ctr"/>
+          <a:bodyPr xmlns:a="http://schemas.openxmlformats.org/drawingml/2006/main" anchor="ctr" wrap="square" lIns="12700" rIns="12700"/>
           <a:lstStyle xmlns:a="http://schemas.openxmlformats.org/drawingml/2006/main">
             <a:defPPr algn="l">
               <a:defRPr sz="1500" b="0">
@@ -6926,27 +6866,17 @@
             </a:lvl9pPr>
           </a:lstStyle>
           <a:p xmlns:a="http://schemas.openxmlformats.org/drawingml/2006/main">
-            <a:pPr algn="l">
-              <a:buNone/>
-              <a:defRPr sz="1500" b="0">
-                <a:solidFill>
-                  <a:srgbClr val="F0F3FA"/>
-                </a:solidFill>
-                <a:latin typeface="Arial"/>
-                <a:ea typeface="Arial"/>
-                <a:cs typeface="Arial"/>
-              </a:defRPr>
+            <a:pPr>
+              <a:spcBef>
+                <a:spcPts val="0"/>
+              </a:spcBef>
+              <a:spcAft>
+                <a:spcPts val="200"/>
+              </a:spcAft>
             </a:pPr>
             <a:r>
-              <a:rPr sz="1500" b="0">
-                <a:solidFill>
-                  <a:srgbClr val="F0F3FA"/>
-                </a:solidFill>
-                <a:latin typeface="Arial"/>
-                <a:ea typeface="Arial"/>
-                <a:cs typeface="Arial"/>
-              </a:rPr>
-              <a:t>01  Historical reviewer set: 4/19 baseline; 15/19 comparison</a:t>
+              <a:rPr sz="1050"/>
+              <a:t>01  Test identities only; test confirmation revoked</a:t>
             </a:r>
           </a:p>
         </p:txBody>
@@ -6980,7 +6910,7 @@
           </a:ln>
         </p:spPr>
         <p:txBody>
-          <a:bodyPr xmlns:a="http://schemas.openxmlformats.org/drawingml/2006/main" anchor="ctr"/>
+          <a:bodyPr xmlns:a="http://schemas.openxmlformats.org/drawingml/2006/main" anchor="ctr" wrap="square" lIns="12700" rIns="12700"/>
           <a:lstStyle xmlns:a="http://schemas.openxmlformats.org/drawingml/2006/main">
             <a:defPPr algn="l">
               <a:defRPr sz="1500" b="0">
@@ -7093,27 +7023,17 @@
             </a:lvl9pPr>
           </a:lstStyle>
           <a:p xmlns:a="http://schemas.openxmlformats.org/drawingml/2006/main">
-            <a:pPr algn="l">
-              <a:buNone/>
-              <a:defRPr sz="1500" b="0">
-                <a:solidFill>
-                  <a:srgbClr val="9AA5BD"/>
-                </a:solidFill>
-                <a:latin typeface="Arial"/>
-                <a:ea typeface="Arial"/>
-                <a:cs typeface="Arial"/>
-              </a:defRPr>
+            <a:pPr>
+              <a:spcBef>
+                <a:spcPts val="0"/>
+              </a:spcBef>
+              <a:spcAft>
+                <a:spcPts val="200"/>
+              </a:spcAft>
             </a:pPr>
             <a:r>
-              <a:rPr sz="1500" b="0">
-                <a:solidFill>
-                  <a:srgbClr val="9AA5BD"/>
-                </a:solidFill>
-                <a:latin typeface="Arial"/>
-                <a:ea typeface="Arial"/>
-                <a:cs typeface="Arial"/>
-              </a:rPr>
-              <a:t>02  Same 19 cases; not a new independent evaluation</a:t>
+              <a:rPr sz="1050"/>
+              <a:t>02  No active authorized human-confirmed memory</a:t>
             </a:r>
           </a:p>
         </p:txBody>
@@ -7147,7 +7067,7 @@
           </a:ln>
         </p:spPr>
         <p:txBody>
-          <a:bodyPr xmlns:a="http://schemas.openxmlformats.org/drawingml/2006/main" anchor="ctr"/>
+          <a:bodyPr xmlns:a="http://schemas.openxmlformats.org/drawingml/2006/main" anchor="ctr" wrap="square" lIns="12700" rIns="12700"/>
           <a:lstStyle xmlns:a="http://schemas.openxmlformats.org/drawingml/2006/main">
             <a:defPPr algn="l">
               <a:defRPr sz="1575" b="0">
@@ -7260,27 +7180,17 @@
             </a:lvl9pPr>
           </a:lstStyle>
           <a:p xmlns:a="http://schemas.openxmlformats.org/drawingml/2006/main">
-            <a:pPr algn="l">
-              <a:buNone/>
-              <a:defRPr sz="1575" b="0">
-                <a:solidFill>
-                  <a:srgbClr val="9AA5BD"/>
-                </a:solidFill>
-                <a:latin typeface="Arial"/>
-                <a:ea typeface="Arial"/>
-                <a:cs typeface="Arial"/>
-              </a:defRPr>
+            <a:pPr>
+              <a:spcBef>
+                <a:spcPts val="0"/>
+              </a:spcBef>
+              <a:spcAft>
+                <a:spcPts val="200"/>
+              </a:spcAft>
             </a:pPr>
             <a:r>
-              <a:rPr sz="1575" b="0">
-                <a:solidFill>
-                  <a:srgbClr val="9AA5BD"/>
-                </a:solidFill>
-                <a:latin typeface="Arial"/>
-                <a:ea typeface="Arial"/>
-                <a:cs typeface="Arial"/>
-              </a:rPr>
-              <a:t>03  Public corpus: 7/10 project labels; 0 outside adjudicators</a:t>
+              <a:rPr sz="1050"/>
+              <a:t>03  Public corpus: 7/10 project labels; no external adjudication</a:t>
             </a:r>
           </a:p>
         </p:txBody>
@@ -7314,7 +7224,7 @@
           </a:ln>
         </p:spPr>
         <p:txBody>
-          <a:bodyPr xmlns:a="http://schemas.openxmlformats.org/drawingml/2006/main" anchor="ctr"/>
+          <a:bodyPr xmlns:a="http://schemas.openxmlformats.org/drawingml/2006/main" anchor="ctr" wrap="square" lIns="12700" rIns="12700"/>
           <a:lstStyle xmlns:a="http://schemas.openxmlformats.org/drawingml/2006/main">
             <a:defPPr algn="l">
               <a:defRPr sz="1425" b="0">
@@ -7427,27 +7337,17 @@
             </a:lvl9pPr>
           </a:lstStyle>
           <a:p xmlns:a="http://schemas.openxmlformats.org/drawingml/2006/main">
-            <a:pPr algn="l">
-              <a:buNone/>
-              <a:defRPr sz="1425" b="0">
-                <a:solidFill>
-                  <a:srgbClr val="9AA5BD"/>
-                </a:solidFill>
-                <a:latin typeface="Arial"/>
-                <a:ea typeface="Arial"/>
-                <a:cs typeface="Arial"/>
-              </a:defRPr>
+            <a:pPr>
+              <a:spcBef>
+                <a:spcPts val="0"/>
+              </a:spcBef>
+              <a:spcAft>
+                <a:spcPts val="200"/>
+              </a:spcAft>
             </a:pPr>
             <a:r>
-              <a:rPr sz="1425" b="0">
-                <a:solidFill>
-                  <a:srgbClr val="9AA5BD"/>
-                </a:solidFill>
-                <a:latin typeface="Arial"/>
-                <a:ea typeface="Arial"/>
-                <a:cs typeface="Arial"/>
-              </a:rPr>
-              <a:t>04  Human impact study: 0 participants</a:t>
+              <a:rPr sz="1050"/>
+              <a:t>04  Human-impact study: 0 participants</a:t>
             </a:r>
           </a:p>
         </p:txBody>
@@ -7512,7 +7412,7 @@
           </a:ln>
         </p:spPr>
         <p:txBody>
-          <a:bodyPr xmlns:a="http://schemas.openxmlformats.org/drawingml/2006/main" anchor="ctr"/>
+          <a:bodyPr xmlns:a="http://schemas.openxmlformats.org/drawingml/2006/main" anchor="ctr" wrap="square" lIns="12700" rIns="12700"/>
           <a:lstStyle xmlns:a="http://schemas.openxmlformats.org/drawingml/2006/main">
             <a:defPPr algn="l">
               <a:defRPr sz="1125" b="1">
@@ -7625,26 +7525,16 @@
             </a:lvl9pPr>
           </a:lstStyle>
           <a:p xmlns:a="http://schemas.openxmlformats.org/drawingml/2006/main">
-            <a:pPr algn="l">
-              <a:buNone/>
-              <a:defRPr sz="1125" b="1">
-                <a:solidFill>
-                  <a:srgbClr val="E8B76E"/>
-                </a:solidFill>
-                <a:latin typeface="Arial"/>
-                <a:ea typeface="Arial"/>
-                <a:cs typeface="Arial"/>
-              </a:defRPr>
+            <a:pPr>
+              <a:spcBef>
+                <a:spcPts val="0"/>
+              </a:spcBef>
+              <a:spcAft>
+                <a:spcPts val="200"/>
+              </a:spcAft>
             </a:pPr>
             <a:r>
-              <a:rPr sz="1125" b="1">
-                <a:solidFill>
-                  <a:srgbClr val="E8B76E"/>
-                </a:solidFill>
-                <a:latin typeface="Arial"/>
-                <a:ea typeface="Arial"/>
-                <a:cs typeface="Arial"/>
-              </a:rPr>
+              <a:rPr sz="1050"/>
               <a:t>NEXT VALIDATION</a:t>
             </a:r>
           </a:p>
@@ -7679,7 +7569,7 @@
           </a:ln>
         </p:spPr>
         <p:txBody>
-          <a:bodyPr xmlns:a="http://schemas.openxmlformats.org/drawingml/2006/main" anchor="ctr"/>
+          <a:bodyPr xmlns:a="http://schemas.openxmlformats.org/drawingml/2006/main" anchor="ctr" wrap="square" lIns="12700" rIns="12700"/>
           <a:lstStyle xmlns:a="http://schemas.openxmlformats.org/drawingml/2006/main">
             <a:defPPr algn="l">
               <a:defRPr sz="1575" b="0">
@@ -7792,27 +7682,17 @@
             </a:lvl9pPr>
           </a:lstStyle>
           <a:p xmlns:a="http://schemas.openxmlformats.org/drawingml/2006/main">
-            <a:pPr algn="l">
-              <a:buNone/>
-              <a:defRPr sz="1575" b="0">
-                <a:solidFill>
-                  <a:srgbClr val="F0F3FA"/>
-                </a:solidFill>
-                <a:latin typeface="Arial"/>
-                <a:ea typeface="Arial"/>
-                <a:cs typeface="Arial"/>
-              </a:defRPr>
+            <a:pPr>
+              <a:spcBef>
+                <a:spcPts val="0"/>
+              </a:spcBef>
+              <a:spcAft>
+                <a:spcPts val="200"/>
+              </a:spcAft>
             </a:pPr>
             <a:r>
-              <a:rPr sz="1575" b="0">
-                <a:solidFill>
-                  <a:srgbClr val="F0F3FA"/>
-                </a:solidFill>
-                <a:latin typeface="Arial"/>
-                <a:ea typeface="Arial"/>
-                <a:cs typeface="Arial"/>
-              </a:rPr>
-              <a:t>01  Rehearse reviewer confirmation on authorized Exasol</a:t>
+              <a:rPr sz="1050"/>
+              <a:t>01  Obtain authorized human review of source-backed evidence</a:t>
             </a:r>
           </a:p>
         </p:txBody>
@@ -7846,7 +7726,7 @@
           </a:ln>
         </p:spPr>
         <p:txBody>
-          <a:bodyPr xmlns:a="http://schemas.openxmlformats.org/drawingml/2006/main" anchor="ctr"/>
+          <a:bodyPr xmlns:a="http://schemas.openxmlformats.org/drawingml/2006/main" anchor="ctr" wrap="square" lIns="12700" rIns="12700"/>
           <a:lstStyle xmlns:a="http://schemas.openxmlformats.org/drawingml/2006/main">
             <a:defPPr algn="l">
               <a:defRPr sz="1575" b="0">
@@ -7959,27 +7839,17 @@
             </a:lvl9pPr>
           </a:lstStyle>
           <a:p xmlns:a="http://schemas.openxmlformats.org/drawingml/2006/main">
-            <a:pPr algn="l">
-              <a:buNone/>
-              <a:defRPr sz="1575" b="0">
-                <a:solidFill>
-                  <a:srgbClr val="9AA5BD"/>
-                </a:solidFill>
-                <a:latin typeface="Arial"/>
-                <a:ea typeface="Arial"/>
-                <a:cs typeface="Arial"/>
-              </a:defRPr>
+            <a:pPr>
+              <a:spcBef>
+                <a:spcPts val="0"/>
+              </a:spcBef>
+              <a:spcAft>
+                <a:spcPts val="200"/>
+              </a:spcAft>
             </a:pPr>
             <a:r>
-              <a:rPr sz="1575" b="0">
-                <a:solidFill>
-                  <a:srgbClr val="9AA5BD"/>
-                </a:solidFill>
-                <a:latin typeface="Arial"/>
-                <a:ea typeface="Arial"/>
-                <a:cs typeface="Arial"/>
-              </a:rPr>
-              <a:t>02  Obtain fresh independent labels</a:t>
+              <a:rPr sz="1050"/>
+              <a:t>02  Build independently labelled evaluation set</a:t>
             </a:r>
           </a:p>
         </p:txBody>
@@ -8013,7 +7883,7 @@
           </a:ln>
         </p:spPr>
         <p:txBody>
-          <a:bodyPr xmlns:a="http://schemas.openxmlformats.org/drawingml/2006/main" anchor="ctr"/>
+          <a:bodyPr xmlns:a="http://schemas.openxmlformats.org/drawingml/2006/main" anchor="ctr" wrap="square" lIns="12700" rIns="12700"/>
           <a:lstStyle xmlns:a="http://schemas.openxmlformats.org/drawingml/2006/main">
             <a:defPPr algn="l">
               <a:defRPr sz="1575" b="0">
@@ -8126,27 +7996,17 @@
             </a:lvl9pPr>
           </a:lstStyle>
           <a:p xmlns:a="http://schemas.openxmlformats.org/drawingml/2006/main">
-            <a:pPr algn="l">
-              <a:buNone/>
-              <a:defRPr sz="1575" b="0">
-                <a:solidFill>
-                  <a:srgbClr val="9AA5BD"/>
-                </a:solidFill>
-                <a:latin typeface="Arial"/>
-                <a:ea typeface="Arial"/>
-                <a:cs typeface="Arial"/>
-              </a:defRPr>
+            <a:pPr>
+              <a:spcBef>
+                <a:spcPts val="0"/>
+              </a:spcBef>
+              <a:spcAft>
+                <a:spcPts val="200"/>
+              </a:spcAft>
             </a:pPr>
             <a:r>
-              <a:rPr sz="1575" b="0">
-                <a:solidFill>
-                  <a:srgbClr val="9AA5BD"/>
-                </a:solidFill>
-                <a:latin typeface="Arial"/>
-                <a:ea typeface="Arial"/>
-                <a:cs typeface="Arial"/>
-              </a:rPr>
-              <a:t>03  Measure engineer investigation outcomes</a:t>
+              <a:rPr sz="1050"/>
+              <a:t>03  Measure non-empty memory retrieval and scaling</a:t>
             </a:r>
           </a:p>
         </p:txBody>
@@ -8180,7 +8040,7 @@
           </a:ln>
         </p:spPr>
         <p:txBody>
-          <a:bodyPr xmlns:a="http://schemas.openxmlformats.org/drawingml/2006/main" anchor="ctr"/>
+          <a:bodyPr xmlns:a="http://schemas.openxmlformats.org/drawingml/2006/main" anchor="ctr" wrap="square" lIns="12700" rIns="12700"/>
           <a:lstStyle xmlns:a="http://schemas.openxmlformats.org/drawingml/2006/main">
             <a:defPPr algn="l">
               <a:defRPr sz="1575" b="0">
@@ -8293,27 +8153,17 @@
             </a:lvl9pPr>
           </a:lstStyle>
           <a:p xmlns:a="http://schemas.openxmlformats.org/drawingml/2006/main">
-            <a:pPr algn="l">
-              <a:buNone/>
-              <a:defRPr sz="1575" b="0">
-                <a:solidFill>
-                  <a:srgbClr val="9AA5BD"/>
-                </a:solidFill>
-                <a:latin typeface="Arial"/>
-                <a:ea typeface="Arial"/>
-                <a:cs typeface="Arial"/>
-              </a:defRPr>
+            <a:pPr>
+              <a:spcBef>
+                <a:spcPts val="0"/>
+              </a:spcBef>
+              <a:spcAft>
+                <a:spcPts val="200"/>
+              </a:spcAft>
             </a:pPr>
             <a:r>
-              <a:rPr sz="1575" b="0">
-                <a:solidFill>
-                  <a:srgbClr val="9AA5BD"/>
-                </a:solidFill>
-                <a:latin typeface="Arial"/>
-                <a:ea typeface="Arial"/>
-                <a:cs typeface="Arial"/>
-              </a:rPr>
-              <a:t>04  Record a new walkthrough without simulated actions</a:t>
+              <a:rPr sz="1050"/>
+              <a:t>04  Rehearse browser demo and clean-clone setup</a:t>
             </a:r>
           </a:p>
         </p:txBody>
@@ -8347,7 +8197,7 @@
           </a:ln>
         </p:spPr>
         <p:txBody>
-          <a:bodyPr xmlns:a="http://schemas.openxmlformats.org/drawingml/2006/main" anchor="ctr"/>
+          <a:bodyPr xmlns:a="http://schemas.openxmlformats.org/drawingml/2006/main" anchor="ctr" wrap="square" lIns="12700" rIns="12700"/>
           <a:lstStyle xmlns:a="http://schemas.openxmlformats.org/drawingml/2006/main">
             <a:defPPr algn="l">
               <a:defRPr sz="1500" b="1">
@@ -8460,27 +8310,17 @@
             </a:lvl9pPr>
           </a:lstStyle>
           <a:p xmlns:a="http://schemas.openxmlformats.org/drawingml/2006/main">
-            <a:pPr algn="l">
-              <a:buNone/>
-              <a:defRPr sz="1500" b="1">
-                <a:solidFill>
-                  <a:srgbClr val="61D9F7"/>
-                </a:solidFill>
-                <a:latin typeface="Arial"/>
-                <a:ea typeface="Arial"/>
-                <a:cs typeface="Arial"/>
-              </a:defRPr>
+            <a:pPr>
+              <a:spcBef>
+                <a:spcPts val="0"/>
+              </a:spcBef>
+              <a:spcAft>
+                <a:spcPts val="200"/>
+              </a:spcAft>
             </a:pPr>
             <a:r>
-              <a:rPr sz="1500" b="1">
-                <a:solidFill>
-                  <a:srgbClr val="61D9F7"/>
-                </a:solidFill>
-                <a:latin typeface="Arial"/>
-                <a:ea typeface="Arial"/>
-                <a:cs typeface="Arial"/>
-              </a:rPr>
-              <a:t>Exasol was unavailable for this run. No new memory confirmation, independent labels, user study, or new video is claimed.</a:t>
+              <a:rPr sz="950"/>
+              <a:t>Benchmark: empty history only — median 51.627 ms; p95 64.753 ms. No active confirmed memories. E2E used temporary test identities; confirmation was revoked. No human validation, scaling, independent-evaluation or impact result is claimed.</a:t>
             </a:r>
           </a:p>
         </p:txBody>
@@ -9075,7 +8915,7 @@
           </a:ln>
         </p:spPr>
         <p:txBody>
-          <a:bodyPr xmlns:a="http://schemas.openxmlformats.org/drawingml/2006/main" anchor="ctr"/>
+          <a:bodyPr xmlns:a="http://schemas.openxmlformats.org/drawingml/2006/main" anchor="ctr" wrap="square"/>
           <a:lstStyle xmlns:a="http://schemas.openxmlformats.org/drawingml/2006/main">
             <a:defPPr algn="l">
               <a:defRPr sz="4650" b="1">
@@ -9188,75 +9028,21 @@
             </a:lvl9pPr>
           </a:lstStyle>
           <a:p xmlns:a="http://schemas.openxmlformats.org/drawingml/2006/main">
-            <a:pPr algn="l">
-              <a:buNone/>
-              <a:defRPr sz="4650" b="1">
-                <a:solidFill>
-                  <a:srgbClr val="F0F3FA"/>
-                </a:solidFill>
-                <a:latin typeface="Arial"/>
-                <a:ea typeface="Arial"/>
-                <a:cs typeface="Arial"/>
-              </a:defRPr>
-            </a:pPr>
             <a:r>
-              <a:rPr sz="4650" b="1">
-                <a:solidFill>
-                  <a:srgbClr val="F0F3FA"/>
-                </a:solidFill>
-                <a:latin typeface="Arial"/>
-                <a:ea typeface="Arial"/>
-                <a:cs typeface="Arial"/>
-              </a:rPr>
+              <a:rPr sz="2500"/>
               <a:t>Investigate with evidence.</a:t>
             </a:r>
           </a:p>
           <a:p xmlns:a="http://schemas.openxmlformats.org/drawingml/2006/main">
-            <a:pPr algn="l">
-              <a:buNone/>
-              <a:defRPr sz="4650" b="1">
-                <a:solidFill>
-                  <a:srgbClr val="F0F3FA"/>
-                </a:solidFill>
-                <a:latin typeface="Arial"/>
-                <a:ea typeface="Arial"/>
-                <a:cs typeface="Arial"/>
-              </a:defRPr>
-            </a:pPr>
             <a:r>
-              <a:rPr sz="4650" b="1">
-                <a:solidFill>
-                  <a:srgbClr val="F0F3FA"/>
-                </a:solidFill>
-                <a:latin typeface="Arial"/>
-                <a:ea typeface="Arial"/>
-                <a:cs typeface="Arial"/>
-              </a:rPr>
+              <a:rPr sz="2500"/>
               <a:t>Keep causes reviewable.</a:t>
             </a:r>
           </a:p>
           <a:p xmlns:a="http://schemas.openxmlformats.org/drawingml/2006/main">
-            <a:pPr algn="l">
-              <a:buNone/>
-              <a:defRPr sz="4650" b="1">
-                <a:solidFill>
-                  <a:srgbClr val="F0F3FA"/>
-                </a:solidFill>
-                <a:latin typeface="Arial"/>
-                <a:ea typeface="Arial"/>
-                <a:cs typeface="Arial"/>
-              </a:defRPr>
-            </a:pPr>
             <a:r>
-              <a:rPr sz="4650" b="1">
-                <a:solidFill>
-                  <a:srgbClr val="F0F3FA"/>
-                </a:solidFill>
-                <a:latin typeface="Arial"/>
-                <a:ea typeface="Arial"/>
-                <a:cs typeface="Arial"/>
-              </a:rPr>
-              <a:t>Confirm only after review.</a:t>
+              <a:rPr sz="2500"/>
+              <a:t>Confirm only after authorized review.</a:t>
             </a:r>
           </a:p>
         </p:txBody>
@@ -9488,7 +9274,7 @@
           </a:ln>
         </p:spPr>
         <p:txBody>
-          <a:bodyPr xmlns:a="http://schemas.openxmlformats.org/drawingml/2006/main" anchor="ctr"/>
+          <a:bodyPr xmlns:a="http://schemas.openxmlformats.org/drawingml/2006/main" anchor="ctr" wrap="square"/>
           <a:lstStyle xmlns:a="http://schemas.openxmlformats.org/drawingml/2006/main">
             <a:defPPr algn="l">
               <a:defRPr sz="1725" b="0">
@@ -9601,27 +9387,9 @@
             </a:lvl9pPr>
           </a:lstStyle>
           <a:p xmlns:a="http://schemas.openxmlformats.org/drawingml/2006/main">
-            <a:pPr algn="l">
-              <a:buNone/>
-              <a:defRPr sz="1725" b="0">
-                <a:solidFill>
-                  <a:srgbClr val="9AA5BD"/>
-                </a:solidFill>
-                <a:latin typeface="Arial"/>
-                <a:ea typeface="Arial"/>
-                <a:cs typeface="Arial"/>
-              </a:defRPr>
-            </a:pPr>
             <a:r>
-              <a:rPr sz="1725" b="0">
-                <a:solidFill>
-                  <a:srgbClr val="9AA5BD"/>
-                </a:solidFill>
-                <a:latin typeface="Arial"/>
-                <a:ea typeface="Arial"/>
-                <a:cs typeface="Arial"/>
-              </a:rPr>
-              <a:t>Demo status: current video is historical and does not show verified memory</a:t>
+              <a:rPr sz="1100"/>
+              <a:t>Technical workflow verified. Authorized human validation remains pending.</a:t>
             </a:r>
           </a:p>
         </p:txBody>
@@ -16769,7 +16537,7 @@
           <p:cNvPr id="3" name="">
             <a:extLst xmlns:a="http://schemas.openxmlformats.org/drawingml/2006/main">
               <a:ext uri="{FF2B5EF4-FFF2-40B4-BE49-F238E27FC236}">
-                <a16:creationId xmlns:a16="http://schemas.microsoft.com/office/drawing/2014/main" id="{7E85781D-2BD2-436F-B624-89F83A34413E}"/>
+                <a16:creationId xmlns:a16="http://schemas.microsoft.com/office/drawing/2014/main" id="{11D4D10E-827C-4C8A-B1EC-893443199352}"/>
               </a:ext>
             </a:extLst>
           </p:cNvPr>
@@ -16779,7 +16547,7 @@
           <p:nvPr/>
         </p:nvPicPr>
         <p:blipFill>
-          <a:blip xmlns:r="http://schemas.openxmlformats.org/officeDocument/2006/relationships" xmlns:a="http://schemas.openxmlformats.org/drawingml/2006/main" r:embed="R2a3d206750074b71"/>
+          <a:blip xmlns:r="http://schemas.openxmlformats.org/officeDocument/2006/relationships" xmlns:a="http://schemas.openxmlformats.org/drawingml/2006/main" r:embed="Rfc3cebc37bb141f7"/>
           <a:srcRect xmlns:a="http://schemas.openxmlformats.org/drawingml/2006/main" l="13" t="0" r="13" b="0"/>
           <a:stretch xmlns:a="http://schemas.openxmlformats.org/drawingml/2006/main">
             <a:fillRect l="0" t="0" r="0" b="0"/>
@@ -18437,7 +18205,7 @@
           <p:cNvPr id="3" name="">
             <a:extLst xmlns:a="http://schemas.openxmlformats.org/drawingml/2006/main">
               <a:ext uri="{FF2B5EF4-FFF2-40B4-BE49-F238E27FC236}">
-                <a16:creationId xmlns:a16="http://schemas.microsoft.com/office/drawing/2014/main" id="{BA690D3A-653F-4A37-8410-0A0832BB682A}"/>
+                <a16:creationId xmlns:a16="http://schemas.microsoft.com/office/drawing/2014/main" id="{2FEB30C8-E38A-4457-8D9B-EDAA30FE0E51}"/>
               </a:ext>
             </a:extLst>
           </p:cNvPr>
@@ -18447,7 +18215,7 @@
           <p:nvPr/>
         </p:nvPicPr>
         <p:blipFill>
-          <a:blip xmlns:r="http://schemas.openxmlformats.org/officeDocument/2006/relationships" xmlns:a="http://schemas.openxmlformats.org/drawingml/2006/main" r:embed="R04433ff14cb44059"/>
+          <a:blip xmlns:r="http://schemas.openxmlformats.org/officeDocument/2006/relationships" xmlns:a="http://schemas.openxmlformats.org/drawingml/2006/main" r:embed="R1ad9a73a9fa84e9c"/>
           <a:srcRect xmlns:a="http://schemas.openxmlformats.org/drawingml/2006/main" l="15" t="0" r="15" b="0"/>
           <a:stretch xmlns:a="http://schemas.openxmlformats.org/drawingml/2006/main">
             <a:fillRect l="0" t="0" r="0" b="0"/>
@@ -29561,7 +29329,7 @@
           <p:cNvPr id="17" name="">
             <a:extLst xmlns:a="http://schemas.openxmlformats.org/drawingml/2006/main">
               <a:ext uri="{FF2B5EF4-FFF2-40B4-BE49-F238E27FC236}">
-                <a16:creationId xmlns:a16="http://schemas.microsoft.com/office/drawing/2014/main" id="{C406D308-F2D7-4240-BFCB-1A33DD25688F}"/>
+                <a16:creationId xmlns:a16="http://schemas.microsoft.com/office/drawing/2014/main" id="{71694D61-F560-4699-84D6-B00EC9D800AB}"/>
               </a:ext>
             </a:extLst>
           </p:cNvPr>
@@ -29571,7 +29339,7 @@
           <p:nvPr/>
         </p:nvPicPr>
         <p:blipFill>
-          <a:blip xmlns:r="http://schemas.openxmlformats.org/officeDocument/2006/relationships" xmlns:a="http://schemas.openxmlformats.org/drawingml/2006/main" r:embed="R294ef75ab9354dc9"/>
+          <a:blip xmlns:r="http://schemas.openxmlformats.org/officeDocument/2006/relationships" xmlns:a="http://schemas.openxmlformats.org/drawingml/2006/main" r:embed="Rfb5c73d1b94f485b"/>
           <a:stretch xmlns:a="http://schemas.openxmlformats.org/drawingml/2006/main"/>
         </p:blipFill>
         <p:spPr>
@@ -30119,7 +29887,7 @@
           <p:cNvPr id="3" name="">
             <a:extLst xmlns:a="http://schemas.openxmlformats.org/drawingml/2006/main">
               <a:ext uri="{FF2B5EF4-FFF2-40B4-BE49-F238E27FC236}">
-                <a16:creationId xmlns:a16="http://schemas.microsoft.com/office/drawing/2014/main" id="{E56C83CE-358C-446C-B625-8161B64269FF}"/>
+                <a16:creationId xmlns:a16="http://schemas.microsoft.com/office/drawing/2014/main" id="{D00D6E1E-CBA0-41FC-8673-2BB652752034}"/>
               </a:ext>
             </a:extLst>
           </p:cNvPr>
@@ -30129,7 +29897,7 @@
           <p:nvPr/>
         </p:nvPicPr>
         <p:blipFill>
-          <a:blip xmlns:r="http://schemas.openxmlformats.org/officeDocument/2006/relationships" xmlns:a="http://schemas.openxmlformats.org/drawingml/2006/main" r:embed="Re331be07709941bb"/>
+          <a:blip xmlns:r="http://schemas.openxmlformats.org/officeDocument/2006/relationships" xmlns:a="http://schemas.openxmlformats.org/drawingml/2006/main" r:embed="R66c6731ec4214cca"/>
           <a:srcRect xmlns:a="http://schemas.openxmlformats.org/drawingml/2006/main" l="0" t="47" r="0" b="47"/>
           <a:stretch xmlns:a="http://schemas.openxmlformats.org/drawingml/2006/main">
             <a:fillRect l="0" t="0" r="0" b="0"/>

</xml_diff>